<commit_message>
refine deck for projector presentation
</commit_message>
<xml_diff>
--- a/ppt/SynCura_Deck_V3_FINAL.pptx
+++ b/ppt/SynCura_Deck_V3_FINAL.pptx
@@ -3105,6 +3105,30 @@
       <p:grpSpPr/>
       <p:pic>
         <p:nvPicPr>
+          <p:cNvPr id="9" name="Picture 8" descr="syncura-watermark.png"/>
+          <p:cNvPicPr>
+            <a:picLocks noChangeAspect="1"/>
+          </p:cNvPicPr>
+          <p:nvPr/>
+        </p:nvPicPr>
+        <p:blipFill>
+          <a:blip r:embed="rId4"/>
+          <a:stretch>
+            <a:fillRect/>
+          </a:stretch>
+        </p:blipFill>
+        <p:spPr>
+          <a:xfrm>
+            <a:off x="6675120" y="2743200"/>
+            <a:ext cx="5212080" cy="5212080"/>
+          </a:xfrm>
+          <a:prstGeom prst="rect">
+            <a:avLst/>
+          </a:prstGeom>
+        </p:spPr>
+      </p:pic>
+      <p:pic>
+        <p:nvPicPr>
           <p:cNvPr id="2" name="Picture 1" descr="image.png"/>
           <p:cNvPicPr>
             <a:picLocks noChangeAspect="1"/>
@@ -3261,7 +3285,7 @@
               <a:buNone/>
             </a:pPr>
             <a:r>
-              <a:rPr sz="3200" b="1">
+              <a:rPr sz="3400" b="1">
                 <a:solidFill>
                   <a:srgbClr val="000000"/>
                 </a:solidFill>
@@ -3299,7 +3323,7 @@
               <a:buNone/>
             </a:pPr>
             <a:r>
-              <a:rPr sz="2800" b="1">
+              <a:rPr sz="3000" b="1">
                 <a:solidFill>
                   <a:srgbClr val="000000"/>
                 </a:solidFill>
@@ -3309,7 +3333,7 @@
 </a:t>
             </a:r>
             <a:r>
-              <a:rPr sz="2800">
+              <a:rPr sz="3000">
                 <a:solidFill>
                   <a:srgbClr val="000000"/>
                 </a:solidFill>
@@ -3319,7 +3343,7 @@
 </a:t>
             </a:r>
             <a:r>
-              <a:rPr sz="2800">
+              <a:rPr sz="3000">
                 <a:solidFill>
                   <a:srgbClr val="000000"/>
                 </a:solidFill>
@@ -3329,7 +3353,7 @@
 </a:t>
             </a:r>
             <a:r>
-              <a:rPr sz="2800">
+              <a:rPr sz="3000">
                 <a:solidFill>
                   <a:srgbClr val="000000"/>
                 </a:solidFill>
@@ -3384,6 +3408,30 @@
       <p:grpSpPr/>
       <p:pic>
         <p:nvPicPr>
+          <p:cNvPr id="7" name="Picture 6" descr="syncura-watermark.png"/>
+          <p:cNvPicPr>
+            <a:picLocks noChangeAspect="1"/>
+          </p:cNvPicPr>
+          <p:nvPr/>
+        </p:nvPicPr>
+        <p:blipFill>
+          <a:blip r:embed="rId4"/>
+          <a:stretch>
+            <a:fillRect/>
+          </a:stretch>
+        </p:blipFill>
+        <p:spPr>
+          <a:xfrm>
+            <a:off x="6675120" y="2743200"/>
+            <a:ext cx="5212080" cy="5212080"/>
+          </a:xfrm>
+          <a:prstGeom prst="rect">
+            <a:avLst/>
+          </a:prstGeom>
+        </p:spPr>
+      </p:pic>
+      <p:pic>
+        <p:nvPicPr>
           <p:cNvPr id="2" name="Picture 1" descr="image.png"/>
           <p:cNvPicPr>
             <a:picLocks noChangeAspect="1"/>
@@ -3502,7 +3550,7 @@
               <a:buNone/>
             </a:pPr>
             <a:r>
-              <a:rPr sz="3000" b="1">
+              <a:rPr sz="3400" b="1">
                 <a:solidFill>
                   <a:srgbClr val="1757AC"/>
                 </a:solidFill>
@@ -3544,7 +3592,7 @@
               <a:buChar char="•"/>
             </a:pPr>
             <a:r>
-              <a:rPr sz="1800">
+              <a:rPr sz="2200">
                 <a:solidFill>
                   <a:srgbClr val="000000"/>
                 </a:solidFill>
@@ -3561,7 +3609,7 @@
               <a:buChar char="•"/>
             </a:pPr>
             <a:r>
-              <a:rPr sz="1800">
+              <a:rPr sz="2200">
                 <a:solidFill>
                   <a:srgbClr val="000000"/>
                 </a:solidFill>
@@ -3578,7 +3626,7 @@
               <a:buChar char="•"/>
             </a:pPr>
             <a:r>
-              <a:rPr sz="1800">
+              <a:rPr sz="2200">
                 <a:solidFill>
                   <a:srgbClr val="000000"/>
                 </a:solidFill>
@@ -3595,7 +3643,7 @@
               <a:buChar char="•"/>
             </a:pPr>
             <a:r>
-              <a:rPr sz="1800">
+              <a:rPr sz="2200">
                 <a:solidFill>
                   <a:srgbClr val="000000"/>
                 </a:solidFill>
@@ -3626,6 +3674,30 @@
       <p:grpSpPr/>
       <p:pic>
         <p:nvPicPr>
+          <p:cNvPr id="21" name="Picture 20" descr="syncura-watermark.png"/>
+          <p:cNvPicPr>
+            <a:picLocks noChangeAspect="1"/>
+          </p:cNvPicPr>
+          <p:nvPr/>
+        </p:nvPicPr>
+        <p:blipFill>
+          <a:blip r:embed="rId4"/>
+          <a:stretch>
+            <a:fillRect/>
+          </a:stretch>
+        </p:blipFill>
+        <p:spPr>
+          <a:xfrm>
+            <a:off x="6675120" y="2743200"/>
+            <a:ext cx="5212080" cy="5212080"/>
+          </a:xfrm>
+          <a:prstGeom prst="rect">
+            <a:avLst/>
+          </a:prstGeom>
+        </p:spPr>
+      </p:pic>
+      <p:pic>
+        <p:nvPicPr>
           <p:cNvPr id="2" name="Picture 1" descr="image.png"/>
           <p:cNvPicPr>
             <a:picLocks noChangeAspect="1"/>
@@ -3744,7 +3816,7 @@
               <a:buNone/>
             </a:pPr>
             <a:r>
-              <a:rPr sz="3000" b="1">
+              <a:rPr sz="3400" b="1">
                 <a:solidFill>
                   <a:srgbClr val="1757AC"/>
                 </a:solidFill>
@@ -3786,7 +3858,7 @@
               <a:buChar char="•"/>
             </a:pPr>
             <a:r>
-              <a:rPr sz="2000">
+              <a:rPr sz="2300">
                 <a:latin typeface="Calibri"/>
               </a:rPr>
               <a:t>Backend: Python 3.10, FastAPI, uvicorn, NumPy, scikit-learn, PyTorch</a:t>
@@ -3794,7 +3866,7 @@
           </a:p>
           <a:p>
             <a:r>
-              <a:rPr sz="2000">
+              <a:rPr sz="2300">
                 <a:latin typeface="Calibri"/>
               </a:rPr>
               <a:t>Two LSTM hidden layers (96 units) + Temporal Attention</a:t>
@@ -3802,7 +3874,7 @@
           </a:p>
           <a:p>
             <a:r>
-              <a:rPr sz="2000">
+              <a:rPr sz="2300">
                 <a:latin typeface="Calibri"/>
               </a:rPr>
               <a:t>Microservices: FastAPI real-time backend, React + Vite frontend</a:t>
@@ -3810,7 +3882,7 @@
           </a:p>
           <a:p>
             <a:r>
-              <a:rPr sz="2000">
+              <a:rPr sz="2300">
                 <a:latin typeface="Calibri"/>
               </a:rPr>
               <a:t>Edge/stream ingestion: MQTT with Eclipse Mosquitto</a:t>
@@ -3861,7 +3933,7 @@
           <a:p>
             <a:pPr algn="ctr"/>
             <a:r>
-              <a:rPr sz="2000" b="1">
+              <a:rPr sz="2200" b="1">
                 <a:solidFill>
                   <a:srgbClr val="1757AC"/>
                 </a:solidFill>
@@ -3877,7 +3949,7 @@
               </a:spcBef>
             </a:pPr>
             <a:r>
-              <a:rPr sz="1500">
+              <a:rPr sz="1800">
                 <a:solidFill>
                   <a:srgbClr val="000000"/>
                 </a:solidFill>
@@ -3974,7 +4046,7 @@
           <a:p>
             <a:pPr algn="ctr"/>
             <a:r>
-              <a:rPr sz="2000" b="1">
+              <a:rPr sz="2200" b="1">
                 <a:solidFill>
                   <a:srgbClr val="1757AC"/>
                 </a:solidFill>
@@ -3990,7 +4062,7 @@
               </a:spcBef>
             </a:pPr>
             <a:r>
-              <a:rPr sz="1500">
+              <a:rPr sz="1800">
                 <a:solidFill>
                   <a:srgbClr val="000000"/>
                 </a:solidFill>
@@ -4087,7 +4159,7 @@
           <a:p>
             <a:pPr algn="ctr"/>
             <a:r>
-              <a:rPr sz="2000" b="1">
+              <a:rPr sz="2200" b="1">
                 <a:solidFill>
                   <a:srgbClr val="1757AC"/>
                 </a:solidFill>
@@ -4103,7 +4175,7 @@
               </a:spcBef>
             </a:pPr>
             <a:r>
-              <a:rPr sz="1500">
+              <a:rPr sz="1800">
                 <a:solidFill>
                   <a:srgbClr val="000000"/>
                 </a:solidFill>
@@ -4200,7 +4272,7 @@
           <a:p>
             <a:pPr algn="ctr"/>
             <a:r>
-              <a:rPr sz="2000" b="1">
+              <a:rPr sz="2200" b="1">
                 <a:solidFill>
                   <a:srgbClr val="1757AC"/>
                 </a:solidFill>
@@ -4216,7 +4288,7 @@
               </a:spcBef>
             </a:pPr>
             <a:r>
-              <a:rPr sz="1500">
+              <a:rPr sz="1800">
                 <a:solidFill>
                   <a:srgbClr val="000000"/>
                 </a:solidFill>
@@ -4247,6 +4319,30 @@
       <p:grpSpPr/>
       <p:pic>
         <p:nvPicPr>
+          <p:cNvPr id="7" name="Picture 6" descr="syncura-watermark.png"/>
+          <p:cNvPicPr>
+            <a:picLocks noChangeAspect="1"/>
+          </p:cNvPicPr>
+          <p:nvPr/>
+        </p:nvPicPr>
+        <p:blipFill>
+          <a:blip r:embed="rId4"/>
+          <a:stretch>
+            <a:fillRect/>
+          </a:stretch>
+        </p:blipFill>
+        <p:spPr>
+          <a:xfrm>
+            <a:off x="6675120" y="2743200"/>
+            <a:ext cx="5212080" cy="5212080"/>
+          </a:xfrm>
+          <a:prstGeom prst="rect">
+            <a:avLst/>
+          </a:prstGeom>
+        </p:spPr>
+      </p:pic>
+      <p:pic>
+        <p:nvPicPr>
           <p:cNvPr id="2" name="Picture 1" descr="image.png"/>
           <p:cNvPicPr>
             <a:picLocks noChangeAspect="1"/>
@@ -4365,7 +4461,7 @@
               <a:buNone/>
             </a:pPr>
             <a:r>
-              <a:rPr sz="3000" b="1">
+              <a:rPr sz="3400" b="1">
                 <a:solidFill>
                   <a:srgbClr val="1757AC"/>
                 </a:solidFill>
@@ -4407,7 +4503,7 @@
               <a:buChar char="•"/>
             </a:pPr>
             <a:r>
-              <a:rPr sz="2100">
+              <a:rPr sz="2400">
                 <a:solidFill>
                   <a:srgbClr val="000000"/>
                 </a:solidFill>
@@ -4419,7 +4515,7 @@
           <a:p>
             <a:pPr/>
             <a:r>
-              <a:rPr sz="2100">
+              <a:rPr sz="2400">
                 <a:solidFill>
                   <a:srgbClr val="000000"/>
                 </a:solidFill>
@@ -4450,6 +4546,30 @@
       <p:grpSpPr/>
       <p:pic>
         <p:nvPicPr>
+          <p:cNvPr id="7" name="Picture 6" descr="syncura-watermark.png"/>
+          <p:cNvPicPr>
+            <a:picLocks noChangeAspect="1"/>
+          </p:cNvPicPr>
+          <p:nvPr/>
+        </p:nvPicPr>
+        <p:blipFill>
+          <a:blip r:embed="rId4"/>
+          <a:stretch>
+            <a:fillRect/>
+          </a:stretch>
+        </p:blipFill>
+        <p:spPr>
+          <a:xfrm>
+            <a:off x="6675120" y="2743200"/>
+            <a:ext cx="5212080" cy="5212080"/>
+          </a:xfrm>
+          <a:prstGeom prst="rect">
+            <a:avLst/>
+          </a:prstGeom>
+        </p:spPr>
+      </p:pic>
+      <p:pic>
+        <p:nvPicPr>
           <p:cNvPr id="2" name="Picture 1" descr="image.png"/>
           <p:cNvPicPr>
             <a:picLocks noChangeAspect="1"/>
@@ -4566,7 +4686,7 @@
           <a:p>
             <a:pPr algn="ctr"/>
             <a:r>
-              <a:rPr sz="3000" b="1">
+              <a:rPr sz="3400" b="1">
                 <a:solidFill>
                   <a:srgbClr val="1757AC"/>
                 </a:solidFill>
@@ -4608,7 +4728,7 @@
               <a:buChar char="•"/>
             </a:pPr>
             <a:r>
-              <a:rPr sz="2000">
+              <a:rPr sz="2400">
                 <a:solidFill>
                   <a:srgbClr val="000000"/>
                 </a:solidFill>
@@ -4625,7 +4745,7 @@
               <a:buChar char="•"/>
             </a:pPr>
             <a:r>
-              <a:rPr sz="2000">
+              <a:rPr sz="2400">
                 <a:solidFill>
                   <a:srgbClr val="000000"/>
                 </a:solidFill>
@@ -4642,7 +4762,7 @@
               <a:buChar char="•"/>
             </a:pPr>
             <a:r>
-              <a:rPr sz="2000">
+              <a:rPr sz="2400">
                 <a:solidFill>
                   <a:srgbClr val="000000"/>
                 </a:solidFill>
@@ -4659,7 +4779,7 @@
               <a:buChar char="•"/>
             </a:pPr>
             <a:r>
-              <a:rPr sz="2000">
+              <a:rPr sz="2400">
                 <a:solidFill>
                   <a:srgbClr val="000000"/>
                 </a:solidFill>
@@ -4676,7 +4796,7 @@
               <a:buChar char="•"/>
             </a:pPr>
             <a:r>
-              <a:rPr sz="2000">
+              <a:rPr sz="2400">
                 <a:solidFill>
                   <a:srgbClr val="000000"/>
                 </a:solidFill>
@@ -4707,6 +4827,30 @@
       <p:grpSpPr/>
       <p:pic>
         <p:nvPicPr>
+          <p:cNvPr id="7" name="Picture 6" descr="syncura-watermark.png"/>
+          <p:cNvPicPr>
+            <a:picLocks noChangeAspect="1"/>
+          </p:cNvPicPr>
+          <p:nvPr/>
+        </p:nvPicPr>
+        <p:blipFill>
+          <a:blip r:embed="rId4"/>
+          <a:stretch>
+            <a:fillRect/>
+          </a:stretch>
+        </p:blipFill>
+        <p:spPr>
+          <a:xfrm>
+            <a:off x="6675120" y="2743200"/>
+            <a:ext cx="5212080" cy="5212080"/>
+          </a:xfrm>
+          <a:prstGeom prst="rect">
+            <a:avLst/>
+          </a:prstGeom>
+        </p:spPr>
+      </p:pic>
+      <p:pic>
+        <p:nvPicPr>
           <p:cNvPr id="2" name="Picture 1" descr="image.png"/>
           <p:cNvPicPr>
             <a:picLocks noChangeAspect="1"/>
@@ -4761,8 +4905,8 @@
         </p:nvSpPr>
         <p:spPr>
           <a:xfrm>
-            <a:off x="4073652" y="886054"/>
-            <a:ext cx="12801600" cy="1234440"/>
+            <a:off x="4114800" y="914400"/>
+            <a:ext cx="12801600" cy="1280160"/>
           </a:xfrm>
           <a:prstGeom prst="rect">
             <a:avLst/>
@@ -4770,25 +4914,24 @@
           <a:noFill/>
         </p:spPr>
         <p:txBody>
-          <a:bodyPr wrap="square"/>
-          <a:lstStyle/>
-          <a:p>
-            <a:pPr algn="ctr" indent="0" marL="0">
-              <a:lnSpc>
-                <a:spcPct val="150000"/>
-              </a:lnSpc>
-              <a:buNone/>
-            </a:pPr>
-            <a:r>
-              <a:rPr sz="2000" b="1">
+          <a:bodyPr wrap="none">
+            <a:spAutoFit/>
+          </a:bodyPr>
+          <a:lstStyle/>
+          <a:p>
+            <a:pPr algn="ctr"/>
+            <a:r>
+              <a:rPr sz="2800" b="1">
                 <a:solidFill>
                   <a:srgbClr val="000000"/>
                 </a:solidFill>
                 <a:latin typeface="Calibri"/>
               </a:rPr>
-              <a:t>P.A. COLLEGE OF ENGINEERING
-</a:t>
-            </a:r>
+              <a:t>P.A. COLLEGE OF ENGINEERING</a:t>
+            </a:r>
+          </a:p>
+          <a:p>
+            <a:pPr algn="ctr"/>
             <a:r>
               <a:rPr sz="2000" b="1">
                 <a:solidFill>
@@ -4809,7 +4952,7 @@
         </p:nvSpPr>
         <p:spPr>
           <a:xfrm>
-            <a:off x="914400" y="1979676"/>
+            <a:off x="914400" y="2011680"/>
             <a:ext cx="16459200" cy="914400"/>
           </a:xfrm>
           <a:prstGeom prst="rect">
@@ -4818,20 +4961,20 @@
           <a:noFill/>
         </p:spPr>
         <p:txBody>
-          <a:bodyPr wrap="square"/>
-          <a:lstStyle/>
-          <a:p>
-            <a:pPr algn="ctr" indent="0" marL="0">
-              <a:buNone/>
-            </a:pPr>
-            <a:r>
-              <a:rPr sz="3000" b="1">
+          <a:bodyPr wrap="none">
+            <a:spAutoFit/>
+          </a:bodyPr>
+          <a:lstStyle/>
+          <a:p>
+            <a:pPr algn="ctr"/>
+            <a:r>
+              <a:rPr sz="3400" b="1">
                 <a:solidFill>
                   <a:srgbClr val="1757AC"/>
                 </a:solidFill>
                 <a:latin typeface="Calibri"/>
               </a:rPr>
-              <a:t>REFERENCES</a:t>
+              <a:t>CONCLUSION</a:t>
             </a:r>
           </a:p>
         </p:txBody>
@@ -4844,8 +4987,8 @@
         </p:nvSpPr>
         <p:spPr>
           <a:xfrm>
-            <a:off x="990295" y="3261665"/>
-            <a:ext cx="16303752" cy="6035040"/>
+            <a:off x="1005840" y="3291840"/>
+            <a:ext cx="16276320" cy="6035040"/>
           </a:xfrm>
           <a:prstGeom prst="rect">
             <a:avLst/>
@@ -4853,88 +4996,76 @@
           <a:noFill/>
         </p:spPr>
         <p:txBody>
-          <a:bodyPr wrap="square"/>
+          <a:bodyPr wrap="square">
+            <a:spAutoFit/>
+          </a:bodyPr>
           <a:lstStyle/>
           <a:p>
             <a:pPr marL="406400" indent="-406400">
-              <a:lnSpc>
-                <a:spcPct val="150000"/>
-              </a:lnSpc>
               <a:spcAft>
-                <a:spcPts val="1400"/>
+                <a:spcPts val="700"/>
               </a:spcAft>
-              <a:buSzPct val="100000"/>
               <a:buChar char="•"/>
             </a:pPr>
             <a:r>
-              <a:rPr sz="1500">
-                <a:latin typeface="Calibri"/>
-              </a:rPr>
-              <a:t>[1] Zheng et al. (2025): Development and Validation of a Dynamic Real-Time Risk Prediction Model for ICU Patients Based on Longitudinal Irregular Data: Multicenter Retrospective Study. JMIR 27:e69293.</a:t>
-            </a:r>
-          </a:p>
-          <a:p>
-            <a:r>
-              <a:rPr sz="1500">
-                <a:latin typeface="Calibri"/>
-              </a:rPr>
-              <a:t>[2] Wang, Bai &amp; Jin (2026): Explainable Deep-Learning Models for Predicting ICU Patient Outcome. Frontiers in Physiology 17.</a:t>
-            </a:r>
-          </a:p>
-          <a:p>
-            <a:r>
-              <a:rPr sz="1500">
-                <a:latin typeface="Calibri"/>
-              </a:rPr>
-              <a:t>[3] Yan et al. (2026): Deep Learning-Based In-Hospital Mortality Prediction Using Long-Term Sequential Data in ICU Patients. PeerJ 14:e21631.</a:t>
-            </a:r>
-          </a:p>
-          <a:p>
-            <a:r>
-              <a:rPr sz="1500">
-                <a:latin typeface="Calibri"/>
-              </a:rPr>
-              <a:t>[4] Sadanandan (2026): Multimodal Deep Learning for Early Prediction of Patient Deterioration in the ICU: Integrating Time-Series EHR Data with Clinical Notes. arXiv:2603.14719.</a:t>
-            </a:r>
-          </a:p>
-          <a:p>
-            <a:r>
-              <a:rPr sz="1500">
-                <a:latin typeface="Calibri"/>
-              </a:rPr>
-              <a:t>[5] Wu et al. (2024): Revisiting the Potential Value of Vital Signs in the Real-Time Prediction of Mortality Risk in ICU Patients. J Big Data 11:40.</a:t>
-            </a:r>
-          </a:p>
-          <a:p>
-            <a:r>
-              <a:rPr sz="1500">
-                <a:latin typeface="Calibri"/>
-              </a:rPr>
-              <a:t>[6] Xie et al. (2025): Unlocking the Potential of Real-Time ICU Mortality Prediction: Redefining Risk Assessment with Continuous Data Recovery. npj Digital Medicine 8:733.</a:t>
-            </a:r>
-          </a:p>
-          <a:p>
-            <a:r>
-              <a:rPr sz="1500">
-                <a:latin typeface="Calibri"/>
-              </a:rPr>
-              <a:t>[7] Choi et al. (2020): Deep Interpretable Early Warning System for the Detection of Clinical Deterioration. IEEE J-BHI 24(9).</a:t>
-            </a:r>
-          </a:p>
-          <a:p>
-            <a:r>
-              <a:rPr sz="1500">
-                <a:latin typeface="Calibri"/>
-              </a:rPr>
-              <a:t>[8] Scheid et al. (2025): Development and Validation of a Clinical Wearable Deep Learning Based Continuous In-Hospital Deterioration Prediction Model. Nature Communications 16:9513.</a:t>
-            </a:r>
-          </a:p>
-          <a:p>
-            <a:r>
-              <a:rPr sz="1500">
-                <a:latin typeface="Calibri"/>
-              </a:rPr>
-              <a:t>[9] PhysioNet (2012): Computing in Cardiology Challenge 2012 dataset. physionet.org/content/challenge-2012.</a:t>
+              <a:rPr sz="2400">
+                <a:solidFill>
+                  <a:srgbClr val="000000"/>
+                </a:solidFill>
+                <a:latin typeface="Calibri"/>
+              </a:rPr>
+              <a:t>SynCura demonstrates an end-to-end explainable ICU risk-monitoring workflow from clinical time-series input to dashboard output.</a:t>
+            </a:r>
+          </a:p>
+          <a:p>
+            <a:pPr marL="406400" indent="-406400">
+              <a:spcAft>
+                <a:spcPts val="700"/>
+              </a:spcAft>
+              <a:buChar char="•"/>
+            </a:pPr>
+            <a:r>
+              <a:rPr sz="2400">
+                <a:solidFill>
+                  <a:srgbClr val="000000"/>
+                </a:solidFill>
+                <a:latin typeface="Calibri"/>
+              </a:rPr>
+              <a:t>Temporal attention and SHAP provide an interpretable view of which time steps and features influenced the prediction.</a:t>
+            </a:r>
+          </a:p>
+          <a:p>
+            <a:pPr marL="406400" indent="-406400">
+              <a:spcAft>
+                <a:spcPts val="700"/>
+              </a:spcAft>
+              <a:buChar char="•"/>
+            </a:pPr>
+            <a:r>
+              <a:rPr sz="2400">
+                <a:solidFill>
+                  <a:srgbClr val="000000"/>
+                </a:solidFill>
+                <a:latin typeface="Calibri"/>
+              </a:rPr>
+              <a:t>The deployed ensemble achieved 0.840 validation AUC and 0.844 set-B holdout AUC.</a:t>
+            </a:r>
+          </a:p>
+          <a:p>
+            <a:pPr marL="406400" indent="-406400">
+              <a:spcAft>
+                <a:spcPts val="700"/>
+              </a:spcAft>
+              <a:buChar char="•"/>
+            </a:pPr>
+            <a:r>
+              <a:rPr sz="2400">
+                <a:solidFill>
+                  <a:srgbClr val="000000"/>
+                </a:solidFill>
+                <a:latin typeface="Calibri"/>
+              </a:rPr>
+              <a:t>These results support the prototype concept, while further clinical and external validation is required before real-world use.</a:t>
             </a:r>
           </a:p>
         </p:txBody>
@@ -4959,6 +5090,30 @@
       <p:grpSpPr/>
       <p:pic>
         <p:nvPicPr>
+          <p:cNvPr id="7" name="Picture 6" descr="syncura-watermark.png"/>
+          <p:cNvPicPr>
+            <a:picLocks noChangeAspect="1"/>
+          </p:cNvPicPr>
+          <p:nvPr/>
+        </p:nvPicPr>
+        <p:blipFill>
+          <a:blip r:embed="rId4"/>
+          <a:stretch>
+            <a:fillRect/>
+          </a:stretch>
+        </p:blipFill>
+        <p:spPr>
+          <a:xfrm>
+            <a:off x="6675120" y="2743200"/>
+            <a:ext cx="5212080" cy="5212080"/>
+          </a:xfrm>
+          <a:prstGeom prst="rect">
+            <a:avLst/>
+          </a:prstGeom>
+        </p:spPr>
+      </p:pic>
+      <p:pic>
+        <p:nvPicPr>
           <p:cNvPr id="2" name="Picture 1" descr="image.png"/>
           <p:cNvPicPr>
             <a:picLocks noChangeAspect="1"/>
@@ -5061,8 +5216,8 @@
         </p:nvSpPr>
         <p:spPr>
           <a:xfrm>
-            <a:off x="914400" y="4389120"/>
-            <a:ext cx="16459200" cy="1371600"/>
+            <a:off x="914400" y="1979676"/>
+            <a:ext cx="16459200" cy="914400"/>
           </a:xfrm>
           <a:prstGeom prst="rect">
             <a:avLst/>
@@ -5077,13 +5232,116 @@
               <a:buNone/>
             </a:pPr>
             <a:r>
-              <a:rPr sz="3000" b="1">
+              <a:rPr sz="3400" b="1">
                 <a:solidFill>
                   <a:srgbClr val="1757AC"/>
                 </a:solidFill>
                 <a:latin typeface="Calibri"/>
               </a:rPr>
-              <a:t>THANK YOU</a:t>
+              <a:t>REFERENCES</a:t>
+            </a:r>
+          </a:p>
+        </p:txBody>
+      </p:sp>
+      <p:sp>
+        <p:nvSpPr>
+          <p:cNvPr id="6" name="TextBox 5"/>
+          <p:cNvSpPr txBox="1"/>
+          <p:nvPr/>
+        </p:nvSpPr>
+        <p:spPr>
+          <a:xfrm>
+            <a:off x="990295" y="3261665"/>
+            <a:ext cx="16303752" cy="6035040"/>
+          </a:xfrm>
+          <a:prstGeom prst="rect">
+            <a:avLst/>
+          </a:prstGeom>
+          <a:noFill/>
+        </p:spPr>
+        <p:txBody>
+          <a:bodyPr wrap="square"/>
+          <a:lstStyle/>
+          <a:p>
+            <a:pPr marL="406400" indent="-406400">
+              <a:lnSpc>
+                <a:spcPct val="150000"/>
+              </a:lnSpc>
+              <a:spcAft>
+                <a:spcPts val="1400"/>
+              </a:spcAft>
+              <a:buSzPct val="100000"/>
+              <a:buChar char="•"/>
+            </a:pPr>
+            <a:r>
+              <a:rPr sz="1800">
+                <a:latin typeface="Calibri"/>
+              </a:rPr>
+              <a:t>[1] Zheng et al. (2025): Development and Validation of a Dynamic Real-Time Risk Prediction Model for ICU Patients Based on Longitudinal Irregular Data: Multicenter Retrospective Study. JMIR 27:e69293.</a:t>
+            </a:r>
+          </a:p>
+          <a:p>
+            <a:r>
+              <a:rPr sz="1800">
+                <a:latin typeface="Calibri"/>
+              </a:rPr>
+              <a:t>[2] Wang, Bai &amp; Jin (2026): Explainable Deep-Learning Models for Predicting ICU Patient Outcome. Frontiers in Physiology 17.</a:t>
+            </a:r>
+          </a:p>
+          <a:p>
+            <a:r>
+              <a:rPr sz="1800">
+                <a:latin typeface="Calibri"/>
+              </a:rPr>
+              <a:t>[3] Yan et al. (2026): Deep Learning-Based In-Hospital Mortality Prediction Using Long-Term Sequential Data in ICU Patients. PeerJ 14:e21631.</a:t>
+            </a:r>
+          </a:p>
+          <a:p>
+            <a:r>
+              <a:rPr sz="1800">
+                <a:latin typeface="Calibri"/>
+              </a:rPr>
+              <a:t>[4] Sadanandan (2026): Multimodal Deep Learning for Early Prediction of Patient Deterioration in the ICU: Integrating Time-Series EHR Data with Clinical Notes. arXiv:2603.14719.</a:t>
+            </a:r>
+          </a:p>
+          <a:p>
+            <a:r>
+              <a:rPr sz="1800">
+                <a:latin typeface="Calibri"/>
+              </a:rPr>
+              <a:t>[5] Wu et al. (2024): Revisiting the Potential Value of Vital Signs in the Real-Time Prediction of Mortality Risk in ICU Patients. J Big Data 11:40.</a:t>
+            </a:r>
+          </a:p>
+          <a:p>
+            <a:r>
+              <a:rPr sz="1800">
+                <a:latin typeface="Calibri"/>
+              </a:rPr>
+              <a:t>[6] Xie et al. (2025): Unlocking the Potential of Real-Time ICU Mortality Prediction: Redefining Risk Assessment with Continuous Data Recovery. npj Digital Medicine 8:733.</a:t>
+            </a:r>
+          </a:p>
+          <a:p>
+            <a:r>
+              <a:rPr sz="1800">
+                <a:latin typeface="Calibri"/>
+              </a:rPr>
+              <a:t>[7] Choi et al. (2020): Deep Interpretable Early Warning System for the Detection of Clinical Deterioration. IEEE J-BHI 24(9).</a:t>
+            </a:r>
+          </a:p>
+          <a:p>
+            <a:r>
+              <a:rPr sz="1800">
+                <a:latin typeface="Calibri"/>
+              </a:rPr>
+              <a:t>[8] Scheid et al. (2025): Development and Validation of a Clinical Wearable Deep Learning Based Continuous In-Hospital Deterioration Prediction Model. Nature Communications 16:9513.</a:t>
+            </a:r>
+          </a:p>
+          <a:p>
+            <a:r>
+              <a:rPr sz="1800">
+                <a:latin typeface="Calibri"/>
+              </a:rPr>
+              <a:t>[9] PhysioNet (2012): Computing in Cardiology Challenge 2012 dataset. physionet.org/content/challenge-2012.</a:t>
             </a:r>
           </a:p>
         </p:txBody>
@@ -5108,6 +5366,30 @@
       <p:grpSpPr/>
       <p:pic>
         <p:nvPicPr>
+          <p:cNvPr id="6" name="Picture 5" descr="syncura-watermark.png"/>
+          <p:cNvPicPr>
+            <a:picLocks noChangeAspect="1"/>
+          </p:cNvPicPr>
+          <p:nvPr/>
+        </p:nvPicPr>
+        <p:blipFill>
+          <a:blip r:embed="rId4"/>
+          <a:stretch>
+            <a:fillRect/>
+          </a:stretch>
+        </p:blipFill>
+        <p:spPr>
+          <a:xfrm>
+            <a:off x="6675120" y="2743200"/>
+            <a:ext cx="5212080" cy="5212080"/>
+          </a:xfrm>
+          <a:prstGeom prst="rect">
+            <a:avLst/>
+          </a:prstGeom>
+        </p:spPr>
+      </p:pic>
+      <p:pic>
+        <p:nvPicPr>
           <p:cNvPr id="2" name="Picture 1" descr="image.png"/>
           <p:cNvPicPr>
             <a:picLocks noChangeAspect="1"/>
@@ -5162,8 +5444,8 @@
         </p:nvSpPr>
         <p:spPr>
           <a:xfrm>
-            <a:off x="4114800" y="914400"/>
-            <a:ext cx="12801600" cy="1280160"/>
+            <a:off x="4073652" y="886054"/>
+            <a:ext cx="12801600" cy="1234440"/>
           </a:xfrm>
           <a:prstGeom prst="rect">
             <a:avLst/>
@@ -5171,12 +5453,15 @@
           <a:noFill/>
         </p:spPr>
         <p:txBody>
-          <a:bodyPr wrap="none">
-            <a:spAutoFit/>
-          </a:bodyPr>
-          <a:lstStyle/>
-          <a:p>
-            <a:pPr algn="ctr"/>
+          <a:bodyPr wrap="square"/>
+          <a:lstStyle/>
+          <a:p>
+            <a:pPr algn="ctr" indent="0" marL="0">
+              <a:lnSpc>
+                <a:spcPct val="150000"/>
+              </a:lnSpc>
+              <a:buNone/>
+            </a:pPr>
             <a:r>
               <a:rPr sz="2000" b="1">
                 <a:solidFill>
@@ -5184,13 +5469,11 @@
                 </a:solidFill>
                 <a:latin typeface="Calibri"/>
               </a:rPr>
-              <a:t>P.A. COLLEGE OF ENGINEERING</a:t>
-            </a:r>
-          </a:p>
-          <a:p>
-            <a:pPr algn="ctr"/>
-            <a:r>
-              <a:rPr sz="1500" b="1">
+              <a:t>P.A. COLLEGE OF ENGINEERING
+</a:t>
+            </a:r>
+            <a:r>
+              <a:rPr sz="2000" b="1">
                 <a:solidFill>
                   <a:srgbClr val="000000"/>
                 </a:solidFill>
@@ -5209,8 +5492,8 @@
         </p:nvSpPr>
         <p:spPr>
           <a:xfrm>
-            <a:off x="914400" y="2011680"/>
-            <a:ext cx="16459200" cy="914400"/>
+            <a:off x="914400" y="4389120"/>
+            <a:ext cx="16459200" cy="1371600"/>
           </a:xfrm>
           <a:prstGeom prst="rect">
             <a:avLst/>
@@ -5218,111 +5501,20 @@
           <a:noFill/>
         </p:spPr>
         <p:txBody>
-          <a:bodyPr wrap="none">
-            <a:spAutoFit/>
-          </a:bodyPr>
-          <a:lstStyle/>
-          <a:p>
-            <a:pPr algn="ctr"/>
-            <a:r>
-              <a:rPr sz="3000" b="1">
+          <a:bodyPr wrap="square"/>
+          <a:lstStyle/>
+          <a:p>
+            <a:pPr algn="ctr" indent="0" marL="0">
+              <a:buNone/>
+            </a:pPr>
+            <a:r>
+              <a:rPr sz="6000" b="1">
                 <a:solidFill>
                   <a:srgbClr val="1757AC"/>
                 </a:solidFill>
                 <a:latin typeface="Calibri"/>
               </a:rPr>
-              <a:t>CONCLUSION</a:t>
-            </a:r>
-          </a:p>
-        </p:txBody>
-      </p:sp>
-      <p:sp>
-        <p:nvSpPr>
-          <p:cNvPr id="6" name="TextBox 5"/>
-          <p:cNvSpPr txBox="1"/>
-          <p:nvPr/>
-        </p:nvSpPr>
-        <p:spPr>
-          <a:xfrm>
-            <a:off x="1005840" y="3291840"/>
-            <a:ext cx="16276320" cy="6035040"/>
-          </a:xfrm>
-          <a:prstGeom prst="rect">
-            <a:avLst/>
-          </a:prstGeom>
-          <a:noFill/>
-        </p:spPr>
-        <p:txBody>
-          <a:bodyPr wrap="square">
-            <a:spAutoFit/>
-          </a:bodyPr>
-          <a:lstStyle/>
-          <a:p>
-            <a:pPr marL="406400" indent="-406400">
-              <a:spcAft>
-                <a:spcPts val="700"/>
-              </a:spcAft>
-              <a:buChar char="•"/>
-            </a:pPr>
-            <a:r>
-              <a:rPr sz="2000">
-                <a:solidFill>
-                  <a:srgbClr val="000000"/>
-                </a:solidFill>
-                <a:latin typeface="Calibri"/>
-              </a:rPr>
-              <a:t>SynCura demonstrates an end-to-end explainable ICU risk-monitoring workflow from clinical time-series input to dashboard output.</a:t>
-            </a:r>
-          </a:p>
-          <a:p>
-            <a:pPr marL="406400" indent="-406400">
-              <a:spcAft>
-                <a:spcPts val="700"/>
-              </a:spcAft>
-              <a:buChar char="•"/>
-            </a:pPr>
-            <a:r>
-              <a:rPr sz="2000">
-                <a:solidFill>
-                  <a:srgbClr val="000000"/>
-                </a:solidFill>
-                <a:latin typeface="Calibri"/>
-              </a:rPr>
-              <a:t>Temporal attention and SHAP provide an interpretable view of which time steps and features influenced the prediction.</a:t>
-            </a:r>
-          </a:p>
-          <a:p>
-            <a:pPr marL="406400" indent="-406400">
-              <a:spcAft>
-                <a:spcPts val="700"/>
-              </a:spcAft>
-              <a:buChar char="•"/>
-            </a:pPr>
-            <a:r>
-              <a:rPr sz="2000">
-                <a:solidFill>
-                  <a:srgbClr val="000000"/>
-                </a:solidFill>
-                <a:latin typeface="Calibri"/>
-              </a:rPr>
-              <a:t>The deployed ensemble achieved 0.840 validation AUC and 0.844 set-B holdout AUC.</a:t>
-            </a:r>
-          </a:p>
-          <a:p>
-            <a:pPr marL="406400" indent="-406400">
-              <a:spcAft>
-                <a:spcPts val="700"/>
-              </a:spcAft>
-              <a:buChar char="•"/>
-            </a:pPr>
-            <a:r>
-              <a:rPr sz="2000">
-                <a:solidFill>
-                  <a:srgbClr val="000000"/>
-                </a:solidFill>
-                <a:latin typeface="Calibri"/>
-              </a:rPr>
-              <a:t>These results support the prototype concept, while further clinical and external validation is required before real-world use.</a:t>
+              <a:t>THANK YOU</a:t>
             </a:r>
           </a:p>
         </p:txBody>
@@ -5347,6 +5539,30 @@
       <p:grpSpPr/>
       <p:pic>
         <p:nvPicPr>
+          <p:cNvPr id="7" name="Picture 6" descr="syncura-watermark.png"/>
+          <p:cNvPicPr>
+            <a:picLocks noChangeAspect="1"/>
+          </p:cNvPicPr>
+          <p:nvPr/>
+        </p:nvPicPr>
+        <p:blipFill>
+          <a:blip r:embed="rId4"/>
+          <a:stretch>
+            <a:fillRect/>
+          </a:stretch>
+        </p:blipFill>
+        <p:spPr>
+          <a:xfrm>
+            <a:off x="6675120" y="2743200"/>
+            <a:ext cx="5212080" cy="5212080"/>
+          </a:xfrm>
+          <a:prstGeom prst="rect">
+            <a:avLst/>
+          </a:prstGeom>
+        </p:spPr>
+      </p:pic>
+      <p:pic>
+        <p:nvPicPr>
           <p:cNvPr id="2" name="Picture 1" descr="image.png"/>
           <p:cNvPicPr>
             <a:picLocks noChangeAspect="1"/>
@@ -5465,7 +5681,7 @@
               <a:buNone/>
             </a:pPr>
             <a:r>
-              <a:rPr sz="3000" b="1">
+              <a:rPr sz="3400" b="1">
                 <a:solidFill>
                   <a:srgbClr val="1757AC"/>
                 </a:solidFill>
@@ -5503,7 +5719,7 @@
               <a:buNone/>
             </a:pPr>
             <a:r>
-              <a:rPr sz="2200" b="1">
+              <a:rPr sz="2400" b="1">
                 <a:solidFill>
                   <a:srgbClr val="000000"/>
                 </a:solidFill>
@@ -5520,7 +5736,7 @@
               <a:buNone/>
             </a:pPr>
             <a:r>
-              <a:rPr sz="2200" b="1">
+              <a:rPr sz="2400" b="1">
                 <a:solidFill>
                   <a:srgbClr val="000000"/>
                 </a:solidFill>
@@ -5537,7 +5753,7 @@
               <a:buNone/>
             </a:pPr>
             <a:r>
-              <a:rPr sz="2200" b="1">
+              <a:rPr sz="2400" b="1">
                 <a:solidFill>
                   <a:srgbClr val="000000"/>
                 </a:solidFill>
@@ -5554,7 +5770,7 @@
               <a:buNone/>
             </a:pPr>
             <a:r>
-              <a:rPr sz="2200" b="1">
+              <a:rPr sz="2400" b="1">
                 <a:solidFill>
                   <a:srgbClr val="000000"/>
                 </a:solidFill>
@@ -5585,6 +5801,30 @@
       <p:grpSpPr/>
       <p:pic>
         <p:nvPicPr>
+          <p:cNvPr id="7" name="Picture 6" descr="syncura-watermark.png"/>
+          <p:cNvPicPr>
+            <a:picLocks noChangeAspect="1"/>
+          </p:cNvPicPr>
+          <p:nvPr/>
+        </p:nvPicPr>
+        <p:blipFill>
+          <a:blip r:embed="rId4"/>
+          <a:stretch>
+            <a:fillRect/>
+          </a:stretch>
+        </p:blipFill>
+        <p:spPr>
+          <a:xfrm>
+            <a:off x="6675120" y="2743200"/>
+            <a:ext cx="5212080" cy="5212080"/>
+          </a:xfrm>
+          <a:prstGeom prst="rect">
+            <a:avLst/>
+          </a:prstGeom>
+        </p:spPr>
+      </p:pic>
+      <p:pic>
+        <p:nvPicPr>
           <p:cNvPr id="2" name="Picture 1" descr="image.png"/>
           <p:cNvPicPr>
             <a:picLocks noChangeAspect="1"/>
@@ -5703,7 +5943,7 @@
               <a:buNone/>
             </a:pPr>
             <a:r>
-              <a:rPr sz="3000" b="1">
+              <a:rPr sz="3400" b="1">
                 <a:solidFill>
                   <a:srgbClr val="1757AC"/>
                 </a:solidFill>
@@ -5745,7 +5985,7 @@
               <a:buChar char="•"/>
             </a:pPr>
             <a:r>
-              <a:rPr sz="2200">
+              <a:rPr sz="2400">
                 <a:solidFill>
                   <a:srgbClr val="000000"/>
                 </a:solidFill>
@@ -5757,7 +5997,7 @@
           <a:p>
             <a:pPr/>
             <a:r>
-              <a:rPr sz="2200">
+              <a:rPr sz="2400">
                 <a:solidFill>
                   <a:srgbClr val="000000"/>
                 </a:solidFill>
@@ -5769,7 +6009,7 @@
           <a:p>
             <a:pPr/>
             <a:r>
-              <a:rPr sz="2200">
+              <a:rPr sz="2400">
                 <a:solidFill>
                   <a:srgbClr val="000000"/>
                 </a:solidFill>
@@ -5781,7 +6021,7 @@
           <a:p>
             <a:pPr/>
             <a:r>
-              <a:rPr sz="2200">
+              <a:rPr sz="2400">
                 <a:solidFill>
                   <a:srgbClr val="000000"/>
                 </a:solidFill>
@@ -5812,6 +6052,30 @@
       <p:grpSpPr/>
       <p:pic>
         <p:nvPicPr>
+          <p:cNvPr id="7" name="Picture 6" descr="syncura-watermark.png"/>
+          <p:cNvPicPr>
+            <a:picLocks noChangeAspect="1"/>
+          </p:cNvPicPr>
+          <p:nvPr/>
+        </p:nvPicPr>
+        <p:blipFill>
+          <a:blip r:embed="rId4"/>
+          <a:stretch>
+            <a:fillRect/>
+          </a:stretch>
+        </p:blipFill>
+        <p:spPr>
+          <a:xfrm>
+            <a:off x="6675120" y="2743200"/>
+            <a:ext cx="5212080" cy="5212080"/>
+          </a:xfrm>
+          <a:prstGeom prst="rect">
+            <a:avLst/>
+          </a:prstGeom>
+        </p:spPr>
+      </p:pic>
+      <p:pic>
+        <p:nvPicPr>
           <p:cNvPr id="2" name="Picture 1" descr="image.png"/>
           <p:cNvPicPr>
             <a:picLocks noChangeAspect="1"/>
@@ -5930,7 +6194,7 @@
               <a:buNone/>
             </a:pPr>
             <a:r>
-              <a:rPr sz="3000" b="1">
+              <a:rPr sz="3400" b="1">
                 <a:solidFill>
                   <a:srgbClr val="1757AC"/>
                 </a:solidFill>
@@ -5972,7 +6236,7 @@
               <a:buChar char="•"/>
             </a:pPr>
             <a:r>
-              <a:rPr sz="1900">
+              <a:rPr sz="2000">
                 <a:latin typeface="Calibri"/>
               </a:rPr>
               <a:t>Base paper: Zheng et al. (2025) - Temporal-Branch Attention LSTM (TBAL), MIMIC-IV + eICU, dynamic AUROC ~0.936. SynCura adapts TBAL to PhysioNet 2012.</a:t>
@@ -5980,7 +6244,7 @@
           </a:p>
           <a:p>
             <a:r>
-              <a:rPr sz="1900">
+              <a:rPr sz="2000">
                 <a:latin typeface="Calibri"/>
               </a:rPr>
               <a:t>Support 1: Yan et al. (2026) - single LSTM, multi-centre ICU, AUC 0.802.</a:t>
@@ -5988,7 +6252,7 @@
           </a:p>
           <a:p>
             <a:r>
-              <a:rPr sz="1900">
+              <a:rPr sz="2000">
                 <a:latin typeface="Calibri"/>
               </a:rPr>
               <a:t>Support 2: Sadanandan (2026) - multimodal LSTM + ClinicalBERT, AUROC 0.786.</a:t>
@@ -5996,7 +6260,7 @@
           </a:p>
           <a:p>
             <a:r>
-              <a:rPr sz="1900">
+              <a:rPr sz="2000">
                 <a:latin typeface="Calibri"/>
               </a:rPr>
               <a:t>Support 3: Wu et al. (2024) - vital-signs-only LSTM, AUC 0.926.</a:t>
@@ -6004,7 +6268,7 @@
           </a:p>
           <a:p>
             <a:r>
-              <a:rPr sz="1900">
+              <a:rPr sz="2000">
                 <a:latin typeface="Calibri"/>
               </a:rPr>
               <a:t>Support 4: Xie et al. (2025) - RealMIP missing-data recovery, AUC 0.957-0.968.</a:t>
@@ -6012,7 +6276,7 @@
           </a:p>
           <a:p>
             <a:r>
-              <a:rPr sz="1900">
+              <a:rPr sz="2000">
                 <a:latin typeface="Calibri"/>
               </a:rPr>
               <a:t>Support 5: Choi et al. (2020) - interpretable BiLSTM early-warning, AUROC ~0.880.</a:t>
@@ -6020,7 +6284,7 @@
           </a:p>
           <a:p>
             <a:r>
-              <a:rPr sz="1900">
+              <a:rPr sz="2000">
                 <a:latin typeface="Calibri"/>
               </a:rPr>
               <a:t>Support 6: Scheid et al. (2025) - continuous wearable deep learning, AUROC ~0.890.</a:t>
@@ -6028,7 +6292,7 @@
           </a:p>
           <a:p>
             <a:r>
-              <a:rPr sz="1900">
+              <a:rPr sz="2000">
                 <a:latin typeface="Calibri"/>
               </a:rPr>
               <a:t>Support 7: Wang, Bai &amp; Jin (2026) - explainable LSTM, AUC 0.79-0.87.</a:t>
@@ -6036,7 +6300,7 @@
           </a:p>
           <a:p>
             <a:r>
-              <a:rPr sz="1900">
+              <a:rPr sz="2000">
                 <a:latin typeface="Calibri"/>
               </a:rPr>
               <a:t>Gap: models report single AUC only; few validate on unseen patients; none ship a real-time explainable risk path.</a:t>
@@ -6064,6 +6328,30 @@
       <p:grpSpPr/>
       <p:pic>
         <p:nvPicPr>
+          <p:cNvPr id="7" name="Picture 6" descr="syncura-watermark.png"/>
+          <p:cNvPicPr>
+            <a:picLocks noChangeAspect="1"/>
+          </p:cNvPicPr>
+          <p:nvPr/>
+        </p:nvPicPr>
+        <p:blipFill>
+          <a:blip r:embed="rId4"/>
+          <a:stretch>
+            <a:fillRect/>
+          </a:stretch>
+        </p:blipFill>
+        <p:spPr>
+          <a:xfrm>
+            <a:off x="6675120" y="2743200"/>
+            <a:ext cx="5212080" cy="5212080"/>
+          </a:xfrm>
+          <a:prstGeom prst="rect">
+            <a:avLst/>
+          </a:prstGeom>
+        </p:spPr>
+      </p:pic>
+      <p:pic>
+        <p:nvPicPr>
           <p:cNvPr id="2" name="Picture 1" descr="image.png"/>
           <p:cNvPicPr>
             <a:picLocks noChangeAspect="1"/>
@@ -6182,7 +6470,7 @@
               <a:buNone/>
             </a:pPr>
             <a:r>
-              <a:rPr sz="3000" b="1">
+              <a:rPr sz="3400" b="1">
                 <a:solidFill>
                   <a:srgbClr val="1757AC"/>
                 </a:solidFill>
@@ -6224,7 +6512,7 @@
               <a:buChar char="•"/>
             </a:pPr>
             <a:r>
-              <a:rPr sz="2100">
+              <a:rPr sz="2300">
                 <a:latin typeface="Calibri"/>
               </a:rPr>
               <a:t>Title: Development and Validation of a Dynamic Real-Time Risk Prediction Model for ICU Patients based on Longitudinal Irregular Data</a:t>
@@ -6232,7 +6520,7 @@
           </a:p>
           <a:p>
             <a:r>
-              <a:rPr sz="2100">
+              <a:rPr sz="2300">
                 <a:latin typeface="Calibri"/>
               </a:rPr>
               <a:t>Authors: Zheng et al. (2025) - JMIR vol. 27, e69293</a:t>
@@ -6240,7 +6528,7 @@
           </a:p>
           <a:p>
             <a:r>
-              <a:rPr sz="2100">
+              <a:rPr sz="2300">
                 <a:latin typeface="Calibri"/>
               </a:rPr>
               <a:t>Method: Temporal-Branch Attention LSTM (TBAL); longitudinal irregular EHR; MIMIC-IV + eICU</a:t>
@@ -6248,7 +6536,7 @@
           </a:p>
           <a:p>
             <a:r>
-              <a:rPr sz="2100">
+              <a:rPr sz="2300">
                 <a:latin typeface="Calibri"/>
               </a:rPr>
               <a:t>Dynamic AUROC ~0.936; static ~0.812; recall 79.1%</a:t>
@@ -6256,7 +6544,7 @@
           </a:p>
           <a:p>
             <a:r>
-              <a:rPr sz="2100">
+              <a:rPr sz="2300">
                 <a:latin typeface="Calibri"/>
               </a:rPr>
               <a:t>SynCura adapts TBAL: 90-min rolling window, 12 features, temporal attention, PhysioNet 2012</a:t>
@@ -6264,7 +6552,7 @@
           </a:p>
           <a:p>
             <a:r>
-              <a:rPr sz="2100">
+              <a:rPr sz="2300">
                 <a:latin typeface="Calibri"/>
               </a:rPr>
               <a:t>Caution - hindsight bias: with retrospective data till discharge AUROC rises to 0.989 (future info); cross-hospital drops to 0.81</a:t>
@@ -6292,6 +6580,30 @@
       <p:grpSpPr/>
       <p:pic>
         <p:nvPicPr>
+          <p:cNvPr id="8" name="Picture 7" descr="syncura-watermark.png"/>
+          <p:cNvPicPr>
+            <a:picLocks noChangeAspect="1"/>
+          </p:cNvPicPr>
+          <p:nvPr/>
+        </p:nvPicPr>
+        <p:blipFill>
+          <a:blip r:embed="rId5"/>
+          <a:stretch>
+            <a:fillRect/>
+          </a:stretch>
+        </p:blipFill>
+        <p:spPr>
+          <a:xfrm>
+            <a:off x="6675120" y="2743200"/>
+            <a:ext cx="5212080" cy="5212080"/>
+          </a:xfrm>
+          <a:prstGeom prst="rect">
+            <a:avLst/>
+          </a:prstGeom>
+        </p:spPr>
+      </p:pic>
+      <p:pic>
+        <p:nvPicPr>
           <p:cNvPr id="2" name="Picture 1" descr="image.png"/>
           <p:cNvPicPr>
             <a:picLocks noChangeAspect="1"/>
@@ -6410,7 +6722,7 @@
               <a:buNone/>
             </a:pPr>
             <a:r>
-              <a:rPr sz="3000" b="1">
+              <a:rPr sz="3400" b="1">
                 <a:solidFill>
                   <a:srgbClr val="1757AC"/>
                 </a:solidFill>
@@ -6452,7 +6764,7 @@
               <a:buChar char="•"/>
             </a:pPr>
             <a:r>
-              <a:rPr sz="1800">
+              <a:rPr sz="2300">
                 <a:solidFill>
                   <a:srgbClr val="000000"/>
                 </a:solidFill>
@@ -6469,7 +6781,7 @@
               <a:buChar char="•"/>
             </a:pPr>
             <a:r>
-              <a:rPr sz="1800">
+              <a:rPr sz="2300">
                 <a:solidFill>
                   <a:srgbClr val="000000"/>
                 </a:solidFill>
@@ -6486,7 +6798,7 @@
               <a:buChar char="•"/>
             </a:pPr>
             <a:r>
-              <a:rPr sz="1800">
+              <a:rPr sz="2300">
                 <a:solidFill>
                   <a:srgbClr val="000000"/>
                 </a:solidFill>
@@ -6503,7 +6815,7 @@
               <a:buChar char="•"/>
             </a:pPr>
             <a:r>
-              <a:rPr sz="1800">
+              <a:rPr sz="2300">
                 <a:solidFill>
                   <a:srgbClr val="000000"/>
                 </a:solidFill>
@@ -6558,6 +6870,30 @@
       <p:grpSpPr/>
       <p:pic>
         <p:nvPicPr>
+          <p:cNvPr id="16" name="Picture 15" descr="syncura-watermark.png"/>
+          <p:cNvPicPr>
+            <a:picLocks noChangeAspect="1"/>
+          </p:cNvPicPr>
+          <p:nvPr/>
+        </p:nvPicPr>
+        <p:blipFill>
+          <a:blip r:embed="rId4"/>
+          <a:stretch>
+            <a:fillRect/>
+          </a:stretch>
+        </p:blipFill>
+        <p:spPr>
+          <a:xfrm>
+            <a:off x="6675120" y="2743200"/>
+            <a:ext cx="5212080" cy="5212080"/>
+          </a:xfrm>
+          <a:prstGeom prst="rect">
+            <a:avLst/>
+          </a:prstGeom>
+        </p:spPr>
+      </p:pic>
+      <p:pic>
+        <p:nvPicPr>
           <p:cNvPr id="2" name="Picture 1" descr="image.png"/>
           <p:cNvPicPr>
             <a:picLocks noChangeAspect="1"/>
@@ -6676,7 +7012,7 @@
               <a:buNone/>
             </a:pPr>
             <a:r>
-              <a:rPr sz="3000" b="1">
+              <a:rPr sz="3400" b="1">
                 <a:solidFill>
                   <a:srgbClr val="1757AC"/>
                 </a:solidFill>
@@ -6730,7 +7066,7 @@
           <a:p>
             <a:pPr algn="ctr"/>
             <a:r>
-              <a:rPr sz="2000" b="1">
+              <a:rPr sz="2200" b="1">
                 <a:solidFill>
                   <a:srgbClr val="1757AC"/>
                 </a:solidFill>
@@ -6746,7 +7082,7 @@
               </a:spcBef>
             </a:pPr>
             <a:r>
-              <a:rPr sz="1500">
+              <a:rPr sz="1800">
                 <a:solidFill>
                   <a:srgbClr val="000000"/>
                 </a:solidFill>
@@ -6844,7 +7180,7 @@
           <a:p>
             <a:pPr algn="ctr"/>
             <a:r>
-              <a:rPr sz="2000" b="1">
+              <a:rPr sz="2200" b="1">
                 <a:solidFill>
                   <a:srgbClr val="1757AC"/>
                 </a:solidFill>
@@ -6860,7 +7196,7 @@
               </a:spcBef>
             </a:pPr>
             <a:r>
-              <a:rPr sz="1500">
+              <a:rPr sz="1800">
                 <a:solidFill>
                   <a:srgbClr val="000000"/>
                 </a:solidFill>
@@ -6958,7 +7294,7 @@
           <a:p>
             <a:pPr algn="ctr"/>
             <a:r>
-              <a:rPr sz="2000" b="1">
+              <a:rPr sz="2200" b="1">
                 <a:solidFill>
                   <a:srgbClr val="1757AC"/>
                 </a:solidFill>
@@ -6974,7 +7310,7 @@
               </a:spcBef>
             </a:pPr>
             <a:r>
-              <a:rPr sz="1500">
+              <a:rPr sz="1800">
                 <a:solidFill>
                   <a:srgbClr val="000000"/>
                 </a:solidFill>
@@ -7072,7 +7408,7 @@
           <a:p>
             <a:pPr algn="ctr"/>
             <a:r>
-              <a:rPr sz="2000" b="1">
+              <a:rPr sz="2200" b="1">
                 <a:solidFill>
                   <a:srgbClr val="1757AC"/>
                 </a:solidFill>
@@ -7088,7 +7424,7 @@
               </a:spcBef>
             </a:pPr>
             <a:r>
-              <a:rPr sz="1500">
+              <a:rPr sz="1800">
                 <a:solidFill>
                   <a:srgbClr val="000000"/>
                 </a:solidFill>
@@ -7186,7 +7522,7 @@
           <a:p>
             <a:pPr algn="ctr"/>
             <a:r>
-              <a:rPr sz="2000" b="1">
+              <a:rPr sz="2200" b="1">
                 <a:solidFill>
                   <a:srgbClr val="1757AC"/>
                 </a:solidFill>
@@ -7202,7 +7538,7 @@
               </a:spcBef>
             </a:pPr>
             <a:r>
-              <a:rPr sz="1500">
+              <a:rPr sz="1800">
                 <a:solidFill>
                   <a:srgbClr val="000000"/>
                 </a:solidFill>
@@ -7238,7 +7574,7 @@
           <a:p>
             <a:pPr algn="ctr"/>
             <a:r>
-              <a:rPr sz="1500" i="1">
+              <a:rPr sz="1800" i="1">
                 <a:solidFill>
                   <a:srgbClr val="444444"/>
                 </a:solidFill>
@@ -7269,6 +7605,30 @@
       <p:grpSpPr/>
       <p:pic>
         <p:nvPicPr>
+          <p:cNvPr id="7" name="Picture 6" descr="syncura-watermark.png"/>
+          <p:cNvPicPr>
+            <a:picLocks noChangeAspect="1"/>
+          </p:cNvPicPr>
+          <p:nvPr/>
+        </p:nvPicPr>
+        <p:blipFill>
+          <a:blip r:embed="rId4"/>
+          <a:stretch>
+            <a:fillRect/>
+          </a:stretch>
+        </p:blipFill>
+        <p:spPr>
+          <a:xfrm>
+            <a:off x="6675120" y="2743200"/>
+            <a:ext cx="5212080" cy="5212080"/>
+          </a:xfrm>
+          <a:prstGeom prst="rect">
+            <a:avLst/>
+          </a:prstGeom>
+        </p:spPr>
+      </p:pic>
+      <p:pic>
+        <p:nvPicPr>
           <p:cNvPr id="2" name="Picture 1" descr="image.png"/>
           <p:cNvPicPr>
             <a:picLocks noChangeAspect="1"/>
@@ -7387,7 +7747,7 @@
               <a:buNone/>
             </a:pPr>
             <a:r>
-              <a:rPr sz="3000" b="1">
+              <a:rPr sz="3400" b="1">
                 <a:solidFill>
                   <a:srgbClr val="1757AC"/>
                 </a:solidFill>
@@ -7429,7 +7789,7 @@
               <a:buChar char="•"/>
             </a:pPr>
             <a:r>
-              <a:rPr sz="2000">
+              <a:rPr sz="2400">
                 <a:solidFill>
                   <a:srgbClr val="000000"/>
                 </a:solidFill>
@@ -7446,7 +7806,7 @@
               <a:buChar char="•"/>
             </a:pPr>
             <a:r>
-              <a:rPr sz="2000">
+              <a:rPr sz="2400">
                 <a:solidFill>
                   <a:srgbClr val="000000"/>
                 </a:solidFill>
@@ -7463,7 +7823,7 @@
               <a:buChar char="•"/>
             </a:pPr>
             <a:r>
-              <a:rPr sz="2000">
+              <a:rPr sz="2400">
                 <a:solidFill>
                   <a:srgbClr val="000000"/>
                 </a:solidFill>
@@ -7480,7 +7840,7 @@
               <a:buChar char="•"/>
             </a:pPr>
             <a:r>
-              <a:rPr sz="2000">
+              <a:rPr sz="2400">
                 <a:solidFill>
                   <a:srgbClr val="000000"/>
                 </a:solidFill>
@@ -7497,7 +7857,7 @@
               <a:buChar char="•"/>
             </a:pPr>
             <a:r>
-              <a:rPr sz="2000">
+              <a:rPr sz="2400">
                 <a:solidFill>
                   <a:srgbClr val="000000"/>
                 </a:solidFill>
@@ -7528,6 +7888,30 @@
       <p:grpSpPr/>
       <p:pic>
         <p:nvPicPr>
+          <p:cNvPr id="10" name="Picture 9" descr="syncura-watermark.png"/>
+          <p:cNvPicPr>
+            <a:picLocks noChangeAspect="1"/>
+          </p:cNvPicPr>
+          <p:nvPr/>
+        </p:nvPicPr>
+        <p:blipFill>
+          <a:blip r:embed="rId7"/>
+          <a:stretch>
+            <a:fillRect/>
+          </a:stretch>
+        </p:blipFill>
+        <p:spPr>
+          <a:xfrm>
+            <a:off x="6675120" y="2743200"/>
+            <a:ext cx="5212080" cy="5212080"/>
+          </a:xfrm>
+          <a:prstGeom prst="rect">
+            <a:avLst/>
+          </a:prstGeom>
+        </p:spPr>
+      </p:pic>
+      <p:pic>
+        <p:nvPicPr>
           <p:cNvPr id="2" name="Picture 1" descr="image.png"/>
           <p:cNvPicPr>
             <a:picLocks noChangeAspect="1"/>
@@ -7646,7 +8030,7 @@
               <a:buNone/>
             </a:pPr>
             <a:r>
-              <a:rPr sz="3000" b="1">
+              <a:rPr sz="3400" b="1">
                 <a:solidFill>
                   <a:srgbClr val="1757AC"/>
                 </a:solidFill>
@@ -7688,7 +8072,7 @@
               <a:buChar char="•"/>
             </a:pPr>
             <a:r>
-              <a:rPr sz="1700">
+              <a:rPr sz="2000">
                 <a:solidFill>
                   <a:srgbClr val="000000"/>
                 </a:solidFill>
@@ -7705,7 +8089,7 @@
               <a:buChar char="•"/>
             </a:pPr>
             <a:r>
-              <a:rPr sz="1700">
+              <a:rPr sz="2000">
                 <a:solidFill>
                   <a:srgbClr val="000000"/>
                 </a:solidFill>
@@ -7722,7 +8106,7 @@
               <a:buChar char="•"/>
             </a:pPr>
             <a:r>
-              <a:rPr sz="1700">
+              <a:rPr sz="2000">
                 <a:solidFill>
                   <a:srgbClr val="000000"/>
                 </a:solidFill>

</xml_diff>

<commit_message>
refine Deck V3 FINAL for projector presentation
</commit_message>
<xml_diff>
--- a/ppt/SynCura_Deck_V3_FINAL.pptx
+++ b/ppt/SynCura_Deck_V3_FINAL.pptx
@@ -5,24 +5,24 @@
     <p:sldMasterId id="2147483648" r:id="rId1"/>
   </p:sldMasterIdLst>
   <p:sldIdLst>
-    <p:sldId id="256" r:id="rId7"/>
-    <p:sldId id="257" r:id="rId8"/>
-    <p:sldId id="258" r:id="rId9"/>
-    <p:sldId id="259" r:id="rId10"/>
-    <p:sldId id="260" r:id="rId11"/>
-    <p:sldId id="261" r:id="rId12"/>
-    <p:sldId id="262" r:id="rId13"/>
-    <p:sldId id="263" r:id="rId14"/>
-    <p:sldId id="264" r:id="rId15"/>
-    <p:sldId id="265" r:id="rId16"/>
-    <p:sldId id="266" r:id="rId17"/>
-    <p:sldId id="267" r:id="rId18"/>
-    <p:sldId id="269" r:id="rId20"/>
-    <p:sldId id="272" r:id="rId19"/>
-    <p:sldId id="270" r:id="rId21"/>
-    <p:sldId id="271" r:id="rId22"/>
+    <p:sldId id="256" r:id="rId2"/>
+    <p:sldId id="257" r:id="rId3"/>
+    <p:sldId id="258" r:id="rId4"/>
+    <p:sldId id="259" r:id="rId5"/>
+    <p:sldId id="260" r:id="rId6"/>
+    <p:sldId id="261" r:id="rId7"/>
+    <p:sldId id="262" r:id="rId8"/>
+    <p:sldId id="263" r:id="rId9"/>
+    <p:sldId id="264" r:id="rId10"/>
+    <p:sldId id="265" r:id="rId11"/>
+    <p:sldId id="266" r:id="rId12"/>
+    <p:sldId id="267" r:id="rId13"/>
+    <p:sldId id="269" r:id="rId14"/>
+    <p:sldId id="272" r:id="rId15"/>
+    <p:sldId id="270" r:id="rId16"/>
+    <p:sldId id="271" r:id="rId17"/>
   </p:sldIdLst>
-  <p:sldSz cx="18288000" cy="10287000" type="screen4x3"/>
+  <p:sldSz cx="18288000" cy="10287000"/>
   <p:notesSz cx="6858000" cy="9144000"/>
   <p:defaultTextStyle>
     <a:defPPr>
@@ -119,6 +119,22 @@
       </a:defRPr>
     </a:lvl9pPr>
   </p:defaultTextStyle>
+  <p:extLst>
+    <p:ext uri="{EFAFB233-063F-42B5-8137-9DF3F51BA10A}">
+      <p15:sldGuideLst xmlns:p15="http://schemas.microsoft.com/office/powerpoint/2012/main">
+        <p15:guide id="1" orient="horz" pos="2160">
+          <p15:clr>
+            <a:srgbClr val="A4A3A4"/>
+          </p15:clr>
+        </p15:guide>
+        <p15:guide id="2" pos="2880">
+          <p15:clr>
+            <a:srgbClr val="A4A3A4"/>
+          </p15:clr>
+        </p15:guide>
+      </p15:sldGuideLst>
+    </p:ext>
+  </p:extLst>
 </p:presentation>
 </file>
 
@@ -160,10 +176,9 @@
           <a:lstStyle/>
           <a:p>
             <a:r>
-              <a:rPr lang="en-US" smtClean="0"/>
+              <a:rPr lang="en-US"/>
               <a:t>Click to edit Master title style</a:t>
             </a:r>
-            <a:endParaRPr lang="en-US"/>
           </a:p>
         </p:txBody>
       </p:sp>
@@ -279,10 +294,9 @@
           </a:lstStyle>
           <a:p>
             <a:r>
-              <a:rPr lang="en-US" smtClean="0"/>
+              <a:rPr lang="en-US"/>
               <a:t>Click to edit Master subtitle style</a:t>
             </a:r>
-            <a:endParaRPr lang="en-US"/>
           </a:p>
         </p:txBody>
       </p:sp>
@@ -303,7 +317,7 @@
           <a:p>
             <a:fld id="{5BCAD085-E8A6-8845-BD4E-CB4CCA059FC4}" type="datetimeFigureOut">
               <a:rPr lang="en-US" smtClean="0"/>
-              <a:t>1/27/13</a:t>
+              <a:t>9/17/2026</a:t>
             </a:fld>
             <a:endParaRPr lang="en-US"/>
           </a:p>
@@ -397,10 +411,9 @@
           <a:lstStyle/>
           <a:p>
             <a:r>
-              <a:rPr lang="en-US" smtClean="0"/>
+              <a:rPr lang="en-US"/>
               <a:t>Click to edit Master title style</a:t>
             </a:r>
-            <a:endParaRPr lang="en-US"/>
           </a:p>
         </p:txBody>
       </p:sp>
@@ -421,38 +434,37 @@
           <a:p>
             <a:pPr lvl="0"/>
             <a:r>
-              <a:rPr lang="en-US" smtClean="0"/>
+              <a:rPr lang="en-US"/>
               <a:t>Click to edit Master text styles</a:t>
             </a:r>
           </a:p>
           <a:p>
             <a:pPr lvl="1"/>
             <a:r>
-              <a:rPr lang="en-US" smtClean="0"/>
+              <a:rPr lang="en-US"/>
               <a:t>Second level</a:t>
             </a:r>
           </a:p>
           <a:p>
             <a:pPr lvl="2"/>
             <a:r>
-              <a:rPr lang="en-US" smtClean="0"/>
+              <a:rPr lang="en-US"/>
               <a:t>Third level</a:t>
             </a:r>
           </a:p>
           <a:p>
             <a:pPr lvl="3"/>
             <a:r>
-              <a:rPr lang="en-US" smtClean="0"/>
+              <a:rPr lang="en-US"/>
               <a:t>Fourth level</a:t>
             </a:r>
           </a:p>
           <a:p>
             <a:pPr lvl="4"/>
             <a:r>
-              <a:rPr lang="en-US" smtClean="0"/>
+              <a:rPr lang="en-US"/>
               <a:t>Fifth level</a:t>
             </a:r>
-            <a:endParaRPr lang="en-US"/>
           </a:p>
         </p:txBody>
       </p:sp>
@@ -473,7 +485,7 @@
           <a:p>
             <a:fld id="{5BCAD085-E8A6-8845-BD4E-CB4CCA059FC4}" type="datetimeFigureOut">
               <a:rPr lang="en-US" smtClean="0"/>
-              <a:t>1/27/13</a:t>
+              <a:t>9/17/2026</a:t>
             </a:fld>
             <a:endParaRPr lang="en-US"/>
           </a:p>
@@ -572,10 +584,9 @@
           <a:lstStyle/>
           <a:p>
             <a:r>
-              <a:rPr lang="en-US" smtClean="0"/>
+              <a:rPr lang="en-US"/>
               <a:t>Click to edit Master title style</a:t>
             </a:r>
-            <a:endParaRPr lang="en-US"/>
           </a:p>
         </p:txBody>
       </p:sp>
@@ -601,38 +612,37 @@
           <a:p>
             <a:pPr lvl="0"/>
             <a:r>
-              <a:rPr lang="en-US" smtClean="0"/>
+              <a:rPr lang="en-US"/>
               <a:t>Click to edit Master text styles</a:t>
             </a:r>
           </a:p>
           <a:p>
             <a:pPr lvl="1"/>
             <a:r>
-              <a:rPr lang="en-US" smtClean="0"/>
+              <a:rPr lang="en-US"/>
               <a:t>Second level</a:t>
             </a:r>
           </a:p>
           <a:p>
             <a:pPr lvl="2"/>
             <a:r>
-              <a:rPr lang="en-US" smtClean="0"/>
+              <a:rPr lang="en-US"/>
               <a:t>Third level</a:t>
             </a:r>
           </a:p>
           <a:p>
             <a:pPr lvl="3"/>
             <a:r>
-              <a:rPr lang="en-US" smtClean="0"/>
+              <a:rPr lang="en-US"/>
               <a:t>Fourth level</a:t>
             </a:r>
           </a:p>
           <a:p>
             <a:pPr lvl="4"/>
             <a:r>
-              <a:rPr lang="en-US" smtClean="0"/>
+              <a:rPr lang="en-US"/>
               <a:t>Fifth level</a:t>
             </a:r>
-            <a:endParaRPr lang="en-US"/>
           </a:p>
         </p:txBody>
       </p:sp>
@@ -653,7 +663,7 @@
           <a:p>
             <a:fld id="{5BCAD085-E8A6-8845-BD4E-CB4CCA059FC4}" type="datetimeFigureOut">
               <a:rPr lang="en-US" smtClean="0"/>
-              <a:t>1/27/13</a:t>
+              <a:t>9/17/2026</a:t>
             </a:fld>
             <a:endParaRPr lang="en-US"/>
           </a:p>
@@ -747,10 +757,9 @@
           <a:lstStyle/>
           <a:p>
             <a:r>
-              <a:rPr lang="en-US" smtClean="0"/>
+              <a:rPr lang="en-US"/>
               <a:t>Click to edit Master title style</a:t>
             </a:r>
-            <a:endParaRPr lang="en-US"/>
           </a:p>
         </p:txBody>
       </p:sp>
@@ -771,38 +780,37 @@
           <a:p>
             <a:pPr lvl="0"/>
             <a:r>
-              <a:rPr lang="en-US" smtClean="0"/>
+              <a:rPr lang="en-US"/>
               <a:t>Click to edit Master text styles</a:t>
             </a:r>
           </a:p>
           <a:p>
             <a:pPr lvl="1"/>
             <a:r>
-              <a:rPr lang="en-US" smtClean="0"/>
+              <a:rPr lang="en-US"/>
               <a:t>Second level</a:t>
             </a:r>
           </a:p>
           <a:p>
             <a:pPr lvl="2"/>
             <a:r>
-              <a:rPr lang="en-US" smtClean="0"/>
+              <a:rPr lang="en-US"/>
               <a:t>Third level</a:t>
             </a:r>
           </a:p>
           <a:p>
             <a:pPr lvl="3"/>
             <a:r>
-              <a:rPr lang="en-US" smtClean="0"/>
+              <a:rPr lang="en-US"/>
               <a:t>Fourth level</a:t>
             </a:r>
           </a:p>
           <a:p>
             <a:pPr lvl="4"/>
             <a:r>
-              <a:rPr lang="en-US" smtClean="0"/>
+              <a:rPr lang="en-US"/>
               <a:t>Fifth level</a:t>
             </a:r>
-            <a:endParaRPr lang="en-US"/>
           </a:p>
         </p:txBody>
       </p:sp>
@@ -823,7 +831,7 @@
           <a:p>
             <a:fld id="{5BCAD085-E8A6-8845-BD4E-CB4CCA059FC4}" type="datetimeFigureOut">
               <a:rPr lang="en-US" smtClean="0"/>
-              <a:t>1/27/13</a:t>
+              <a:t>9/17/2026</a:t>
             </a:fld>
             <a:endParaRPr lang="en-US"/>
           </a:p>
@@ -926,10 +934,9 @@
           </a:lstStyle>
           <a:p>
             <a:r>
-              <a:rPr lang="en-US" smtClean="0"/>
+              <a:rPr lang="en-US"/>
               <a:t>Click to edit Master title style</a:t>
             </a:r>
-            <a:endParaRPr lang="en-US"/>
           </a:p>
         </p:txBody>
       </p:sp>
@@ -1046,7 +1053,7 @@
           <a:p>
             <a:pPr lvl="0"/>
             <a:r>
-              <a:rPr lang="en-US" smtClean="0"/>
+              <a:rPr lang="en-US"/>
               <a:t>Click to edit Master text styles</a:t>
             </a:r>
           </a:p>
@@ -1069,7 +1076,7 @@
           <a:p>
             <a:fld id="{5BCAD085-E8A6-8845-BD4E-CB4CCA059FC4}" type="datetimeFigureOut">
               <a:rPr lang="en-US" smtClean="0"/>
-              <a:t>1/27/13</a:t>
+              <a:t>9/17/2026</a:t>
             </a:fld>
             <a:endParaRPr lang="en-US"/>
           </a:p>
@@ -1163,10 +1170,9 @@
           <a:lstStyle/>
           <a:p>
             <a:r>
-              <a:rPr lang="en-US" smtClean="0"/>
+              <a:rPr lang="en-US"/>
               <a:t>Click to edit Master title style</a:t>
             </a:r>
-            <a:endParaRPr lang="en-US"/>
           </a:p>
         </p:txBody>
       </p:sp>
@@ -1220,38 +1226,37 @@
           <a:p>
             <a:pPr lvl="0"/>
             <a:r>
-              <a:rPr lang="en-US" smtClean="0"/>
+              <a:rPr lang="en-US"/>
               <a:t>Click to edit Master text styles</a:t>
             </a:r>
           </a:p>
           <a:p>
             <a:pPr lvl="1"/>
             <a:r>
-              <a:rPr lang="en-US" smtClean="0"/>
+              <a:rPr lang="en-US"/>
               <a:t>Second level</a:t>
             </a:r>
           </a:p>
           <a:p>
             <a:pPr lvl="2"/>
             <a:r>
-              <a:rPr lang="en-US" smtClean="0"/>
+              <a:rPr lang="en-US"/>
               <a:t>Third level</a:t>
             </a:r>
           </a:p>
           <a:p>
             <a:pPr lvl="3"/>
             <a:r>
-              <a:rPr lang="en-US" smtClean="0"/>
+              <a:rPr lang="en-US"/>
               <a:t>Fourth level</a:t>
             </a:r>
           </a:p>
           <a:p>
             <a:pPr lvl="4"/>
             <a:r>
-              <a:rPr lang="en-US" smtClean="0"/>
+              <a:rPr lang="en-US"/>
               <a:t>Fifth level</a:t>
             </a:r>
-            <a:endParaRPr lang="en-US"/>
           </a:p>
         </p:txBody>
       </p:sp>
@@ -1305,38 +1310,37 @@
           <a:p>
             <a:pPr lvl="0"/>
             <a:r>
-              <a:rPr lang="en-US" smtClean="0"/>
+              <a:rPr lang="en-US"/>
               <a:t>Click to edit Master text styles</a:t>
             </a:r>
           </a:p>
           <a:p>
             <a:pPr lvl="1"/>
             <a:r>
-              <a:rPr lang="en-US" smtClean="0"/>
+              <a:rPr lang="en-US"/>
               <a:t>Second level</a:t>
             </a:r>
           </a:p>
           <a:p>
             <a:pPr lvl="2"/>
             <a:r>
-              <a:rPr lang="en-US" smtClean="0"/>
+              <a:rPr lang="en-US"/>
               <a:t>Third level</a:t>
             </a:r>
           </a:p>
           <a:p>
             <a:pPr lvl="3"/>
             <a:r>
-              <a:rPr lang="en-US" smtClean="0"/>
+              <a:rPr lang="en-US"/>
               <a:t>Fourth level</a:t>
             </a:r>
           </a:p>
           <a:p>
             <a:pPr lvl="4"/>
             <a:r>
-              <a:rPr lang="en-US" smtClean="0"/>
+              <a:rPr lang="en-US"/>
               <a:t>Fifth level</a:t>
             </a:r>
-            <a:endParaRPr lang="en-US"/>
           </a:p>
         </p:txBody>
       </p:sp>
@@ -1357,7 +1361,7 @@
           <a:p>
             <a:fld id="{5BCAD085-E8A6-8845-BD4E-CB4CCA059FC4}" type="datetimeFigureOut">
               <a:rPr lang="en-US" smtClean="0"/>
-              <a:t>1/27/13</a:t>
+              <a:t>9/17/2026</a:t>
             </a:fld>
             <a:endParaRPr lang="en-US"/>
           </a:p>
@@ -1455,10 +1459,9 @@
           </a:lstStyle>
           <a:p>
             <a:r>
-              <a:rPr lang="en-US" smtClean="0"/>
+              <a:rPr lang="en-US"/>
               <a:t>Click to edit Master title style</a:t>
             </a:r>
-            <a:endParaRPr lang="en-US"/>
           </a:p>
         </p:txBody>
       </p:sp>
@@ -1521,7 +1524,7 @@
           <a:p>
             <a:pPr lvl="0"/>
             <a:r>
-              <a:rPr lang="en-US" smtClean="0"/>
+              <a:rPr lang="en-US"/>
               <a:t>Click to edit Master text styles</a:t>
             </a:r>
           </a:p>
@@ -1577,38 +1580,37 @@
           <a:p>
             <a:pPr lvl="0"/>
             <a:r>
-              <a:rPr lang="en-US" smtClean="0"/>
+              <a:rPr lang="en-US"/>
               <a:t>Click to edit Master text styles</a:t>
             </a:r>
           </a:p>
           <a:p>
             <a:pPr lvl="1"/>
             <a:r>
-              <a:rPr lang="en-US" smtClean="0"/>
+              <a:rPr lang="en-US"/>
               <a:t>Second level</a:t>
             </a:r>
           </a:p>
           <a:p>
             <a:pPr lvl="2"/>
             <a:r>
-              <a:rPr lang="en-US" smtClean="0"/>
+              <a:rPr lang="en-US"/>
               <a:t>Third level</a:t>
             </a:r>
           </a:p>
           <a:p>
             <a:pPr lvl="3"/>
             <a:r>
-              <a:rPr lang="en-US" smtClean="0"/>
+              <a:rPr lang="en-US"/>
               <a:t>Fourth level</a:t>
             </a:r>
           </a:p>
           <a:p>
             <a:pPr lvl="4"/>
             <a:r>
-              <a:rPr lang="en-US" smtClean="0"/>
+              <a:rPr lang="en-US"/>
               <a:t>Fifth level</a:t>
             </a:r>
-            <a:endParaRPr lang="en-US"/>
           </a:p>
         </p:txBody>
       </p:sp>
@@ -1671,7 +1673,7 @@
           <a:p>
             <a:pPr lvl="0"/>
             <a:r>
-              <a:rPr lang="en-US" smtClean="0"/>
+              <a:rPr lang="en-US"/>
               <a:t>Click to edit Master text styles</a:t>
             </a:r>
           </a:p>
@@ -1727,38 +1729,37 @@
           <a:p>
             <a:pPr lvl="0"/>
             <a:r>
-              <a:rPr lang="en-US" smtClean="0"/>
+              <a:rPr lang="en-US"/>
               <a:t>Click to edit Master text styles</a:t>
             </a:r>
           </a:p>
           <a:p>
             <a:pPr lvl="1"/>
             <a:r>
-              <a:rPr lang="en-US" smtClean="0"/>
+              <a:rPr lang="en-US"/>
               <a:t>Second level</a:t>
             </a:r>
           </a:p>
           <a:p>
             <a:pPr lvl="2"/>
             <a:r>
-              <a:rPr lang="en-US" smtClean="0"/>
+              <a:rPr lang="en-US"/>
               <a:t>Third level</a:t>
             </a:r>
           </a:p>
           <a:p>
             <a:pPr lvl="3"/>
             <a:r>
-              <a:rPr lang="en-US" smtClean="0"/>
+              <a:rPr lang="en-US"/>
               <a:t>Fourth level</a:t>
             </a:r>
           </a:p>
           <a:p>
             <a:pPr lvl="4"/>
             <a:r>
-              <a:rPr lang="en-US" smtClean="0"/>
+              <a:rPr lang="en-US"/>
               <a:t>Fifth level</a:t>
             </a:r>
-            <a:endParaRPr lang="en-US"/>
           </a:p>
         </p:txBody>
       </p:sp>
@@ -1779,7 +1780,7 @@
           <a:p>
             <a:fld id="{5BCAD085-E8A6-8845-BD4E-CB4CCA059FC4}" type="datetimeFigureOut">
               <a:rPr lang="en-US" smtClean="0"/>
-              <a:t>1/27/13</a:t>
+              <a:t>9/17/2026</a:t>
             </a:fld>
             <a:endParaRPr lang="en-US"/>
           </a:p>
@@ -1873,10 +1874,9 @@
           <a:lstStyle/>
           <a:p>
             <a:r>
-              <a:rPr lang="en-US" smtClean="0"/>
+              <a:rPr lang="en-US"/>
               <a:t>Click to edit Master title style</a:t>
             </a:r>
-            <a:endParaRPr lang="en-US"/>
           </a:p>
         </p:txBody>
       </p:sp>
@@ -1897,7 +1897,7 @@
           <a:p>
             <a:fld id="{5BCAD085-E8A6-8845-BD4E-CB4CCA059FC4}" type="datetimeFigureOut">
               <a:rPr lang="en-US" smtClean="0"/>
-              <a:t>1/27/13</a:t>
+              <a:t>9/17/2026</a:t>
             </a:fld>
             <a:endParaRPr lang="en-US"/>
           </a:p>
@@ -1992,7 +1992,7 @@
           <a:p>
             <a:fld id="{5BCAD085-E8A6-8845-BD4E-CB4CCA059FC4}" type="datetimeFigureOut">
               <a:rPr lang="en-US" smtClean="0"/>
-              <a:t>1/27/13</a:t>
+              <a:t>9/17/2026</a:t>
             </a:fld>
             <a:endParaRPr lang="en-US"/>
           </a:p>
@@ -2095,10 +2095,9 @@
           </a:lstStyle>
           <a:p>
             <a:r>
-              <a:rPr lang="en-US" smtClean="0"/>
+              <a:rPr lang="en-US"/>
               <a:t>Click to edit Master title style</a:t>
             </a:r>
-            <a:endParaRPr lang="en-US"/>
           </a:p>
         </p:txBody>
       </p:sp>
@@ -2152,38 +2151,37 @@
           <a:p>
             <a:pPr lvl="0"/>
             <a:r>
-              <a:rPr lang="en-US" smtClean="0"/>
+              <a:rPr lang="en-US"/>
               <a:t>Click to edit Master text styles</a:t>
             </a:r>
           </a:p>
           <a:p>
             <a:pPr lvl="1"/>
             <a:r>
-              <a:rPr lang="en-US" smtClean="0"/>
+              <a:rPr lang="en-US"/>
               <a:t>Second level</a:t>
             </a:r>
           </a:p>
           <a:p>
             <a:pPr lvl="2"/>
             <a:r>
-              <a:rPr lang="en-US" smtClean="0"/>
+              <a:rPr lang="en-US"/>
               <a:t>Third level</a:t>
             </a:r>
           </a:p>
           <a:p>
             <a:pPr lvl="3"/>
             <a:r>
-              <a:rPr lang="en-US" smtClean="0"/>
+              <a:rPr lang="en-US"/>
               <a:t>Fourth level</a:t>
             </a:r>
           </a:p>
           <a:p>
             <a:pPr lvl="4"/>
             <a:r>
-              <a:rPr lang="en-US" smtClean="0"/>
+              <a:rPr lang="en-US"/>
               <a:t>Fifth level</a:t>
             </a:r>
-            <a:endParaRPr lang="en-US"/>
           </a:p>
         </p:txBody>
       </p:sp>
@@ -2246,7 +2244,7 @@
           <a:p>
             <a:pPr lvl="0"/>
             <a:r>
-              <a:rPr lang="en-US" smtClean="0"/>
+              <a:rPr lang="en-US"/>
               <a:t>Click to edit Master text styles</a:t>
             </a:r>
           </a:p>
@@ -2269,7 +2267,7 @@
           <a:p>
             <a:fld id="{5BCAD085-E8A6-8845-BD4E-CB4CCA059FC4}" type="datetimeFigureOut">
               <a:rPr lang="en-US" smtClean="0"/>
-              <a:t>1/27/13</a:t>
+              <a:t>9/17/2026</a:t>
             </a:fld>
             <a:endParaRPr lang="en-US"/>
           </a:p>
@@ -2372,10 +2370,9 @@
           </a:lstStyle>
           <a:p>
             <a:r>
-              <a:rPr lang="en-US" smtClean="0"/>
+              <a:rPr lang="en-US"/>
               <a:t>Click to edit Master title style</a:t>
             </a:r>
-            <a:endParaRPr lang="en-US"/>
           </a:p>
         </p:txBody>
       </p:sp>
@@ -2499,7 +2496,7 @@
           <a:p>
             <a:pPr lvl="0"/>
             <a:r>
-              <a:rPr lang="en-US" smtClean="0"/>
+              <a:rPr lang="en-US"/>
               <a:t>Click to edit Master text styles</a:t>
             </a:r>
           </a:p>
@@ -2522,7 +2519,7 @@
           <a:p>
             <a:fld id="{5BCAD085-E8A6-8845-BD4E-CB4CCA059FC4}" type="datetimeFigureOut">
               <a:rPr lang="en-US" smtClean="0"/>
-              <a:t>1/27/13</a:t>
+              <a:t>9/17/2026</a:t>
             </a:fld>
             <a:endParaRPr lang="en-US"/>
           </a:p>
@@ -2631,10 +2628,9 @@
           <a:lstStyle/>
           <a:p>
             <a:r>
-              <a:rPr lang="en-US" smtClean="0"/>
+              <a:rPr lang="en-US"/>
               <a:t>Click to edit Master title style</a:t>
             </a:r>
-            <a:endParaRPr lang="en-US"/>
           </a:p>
         </p:txBody>
       </p:sp>
@@ -2665,38 +2661,37 @@
           <a:p>
             <a:pPr lvl="0"/>
             <a:r>
-              <a:rPr lang="en-US" smtClean="0"/>
+              <a:rPr lang="en-US"/>
               <a:t>Click to edit Master text styles</a:t>
             </a:r>
           </a:p>
           <a:p>
             <a:pPr lvl="1"/>
             <a:r>
-              <a:rPr lang="en-US" smtClean="0"/>
+              <a:rPr lang="en-US"/>
               <a:t>Second level</a:t>
             </a:r>
           </a:p>
           <a:p>
             <a:pPr lvl="2"/>
             <a:r>
-              <a:rPr lang="en-US" smtClean="0"/>
+              <a:rPr lang="en-US"/>
               <a:t>Third level</a:t>
             </a:r>
           </a:p>
           <a:p>
             <a:pPr lvl="3"/>
             <a:r>
-              <a:rPr lang="en-US" smtClean="0"/>
+              <a:rPr lang="en-US"/>
               <a:t>Fourth level</a:t>
             </a:r>
           </a:p>
           <a:p>
             <a:pPr lvl="4"/>
             <a:r>
-              <a:rPr lang="en-US" smtClean="0"/>
+              <a:rPr lang="en-US"/>
               <a:t>Fifth level</a:t>
             </a:r>
-            <a:endParaRPr lang="en-US"/>
           </a:p>
         </p:txBody>
       </p:sp>
@@ -2735,7 +2730,7 @@
           <a:p>
             <a:fld id="{5BCAD085-E8A6-8845-BD4E-CB4CCA059FC4}" type="datetimeFigureOut">
               <a:rPr lang="en-US" smtClean="0"/>
-              <a:t>1/27/13</a:t>
+              <a:t>9/17/2026</a:t>
             </a:fld>
             <a:endParaRPr lang="en-US"/>
           </a:p>
@@ -3094,7 +3089,7 @@
 </file>
 
 <file path=ppt/slides/slide1.xml><?xml version="1.0" encoding="utf-8"?>
-<p:sld xmlns:a="http://schemas.openxmlformats.org/drawingml/2006/main" xmlns:p="http://schemas.openxmlformats.org/presentationml/2006/main" xmlns:r="http://schemas.openxmlformats.org/officeDocument/2006/relationships">
+<p:sld xmlns:a="http://schemas.openxmlformats.org/drawingml/2006/main" xmlns:r="http://schemas.openxmlformats.org/officeDocument/2006/relationships" xmlns:p="http://schemas.openxmlformats.org/presentationml/2006/main">
   <p:cSld>
     <p:spTree>
       <p:nvGrpSpPr>
@@ -3102,10 +3097,65 @@
         <p:cNvGrpSpPr/>
         <p:nvPr/>
       </p:nvGrpSpPr>
-      <p:grpSpPr/>
+      <p:grpSpPr>
+        <a:xfrm>
+          <a:off x="0" y="0"/>
+          <a:ext cx="0" cy="0"/>
+          <a:chOff x="0" y="0"/>
+          <a:chExt cx="0" cy="0"/>
+        </a:xfrm>
+      </p:grpSpPr>
       <p:pic>
         <p:nvPicPr>
           <p:cNvPr id="9" name="Picture 8" descr="syncura-watermark.png"/>
+          <p:cNvPicPr>
+            <a:picLocks noChangeAspect="1"/>
+          </p:cNvPicPr>
+          <p:nvPr/>
+        </p:nvPicPr>
+        <p:blipFill>
+          <a:blip r:embed="rId2"/>
+          <a:stretch>
+            <a:fillRect/>
+          </a:stretch>
+        </p:blipFill>
+        <p:spPr>
+          <a:xfrm>
+            <a:off x="6675120" y="2743200"/>
+            <a:ext cx="5212080" cy="5212080"/>
+          </a:xfrm>
+          <a:prstGeom prst="rect">
+            <a:avLst/>
+          </a:prstGeom>
+        </p:spPr>
+      </p:pic>
+      <p:pic>
+        <p:nvPicPr>
+          <p:cNvPr id="2" name="Picture 1" descr="image.png"/>
+          <p:cNvPicPr>
+            <a:picLocks noChangeAspect="1"/>
+          </p:cNvPicPr>
+          <p:nvPr/>
+        </p:nvPicPr>
+        <p:blipFill>
+          <a:blip r:embed="rId3"/>
+          <a:stretch>
+            <a:fillRect/>
+          </a:stretch>
+        </p:blipFill>
+        <p:spPr>
+          <a:xfrm>
+            <a:off x="137160" y="109728"/>
+            <a:ext cx="1463040" cy="1463040"/>
+          </a:xfrm>
+          <a:prstGeom prst="rect">
+            <a:avLst/>
+          </a:prstGeom>
+        </p:spPr>
+      </p:pic>
+      <p:pic>
+        <p:nvPicPr>
+          <p:cNvPr id="3" name="Picture 2" descr="image.png"/>
           <p:cNvPicPr>
             <a:picLocks noChangeAspect="1"/>
           </p:cNvPicPr>
@@ -3119,54 +3169,6 @@
         </p:blipFill>
         <p:spPr>
           <a:xfrm>
-            <a:off x="6675120" y="2743200"/>
-            <a:ext cx="5212080" cy="5212080"/>
-          </a:xfrm>
-          <a:prstGeom prst="rect">
-            <a:avLst/>
-          </a:prstGeom>
-        </p:spPr>
-      </p:pic>
-      <p:pic>
-        <p:nvPicPr>
-          <p:cNvPr id="2" name="Picture 1" descr="image.png"/>
-          <p:cNvPicPr>
-            <a:picLocks noChangeAspect="1"/>
-          </p:cNvPicPr>
-          <p:nvPr/>
-        </p:nvPicPr>
-        <p:blipFill>
-          <a:blip r:embed="rId2"/>
-          <a:stretch>
-            <a:fillRect/>
-          </a:stretch>
-        </p:blipFill>
-        <p:spPr>
-          <a:xfrm>
-            <a:off x="137160" y="109728"/>
-            <a:ext cx="1463040" cy="1463040"/>
-          </a:xfrm>
-          <a:prstGeom prst="rect">
-            <a:avLst/>
-          </a:prstGeom>
-        </p:spPr>
-      </p:pic>
-      <p:pic>
-        <p:nvPicPr>
-          <p:cNvPr id="3" name="Picture 2" descr="image.png"/>
-          <p:cNvPicPr>
-            <a:picLocks noChangeAspect="1"/>
-          </p:cNvPicPr>
-          <p:nvPr/>
-        </p:nvPicPr>
-        <p:blipFill>
-          <a:blip r:embed="rId3"/>
-          <a:stretch>
-            <a:fillRect/>
-          </a:stretch>
-        </p:blipFill>
-        <p:spPr>
-          <a:xfrm>
             <a:off x="16687800" y="109728"/>
             <a:ext cx="1463040" cy="1463040"/>
           </a:xfrm>
@@ -3183,7 +3185,7 @@
         </p:nvSpPr>
         <p:spPr>
           <a:xfrm>
-            <a:off x="4073652" y="886054"/>
+            <a:off x="2743200" y="0"/>
             <a:ext cx="12801600" cy="1234440"/>
           </a:xfrm>
           <a:prstGeom prst="rect">
@@ -3195,30 +3197,21 @@
           <a:bodyPr wrap="square"/>
           <a:lstStyle/>
           <a:p>
-            <a:pPr algn="ctr" indent="0" marL="0">
+            <a:pPr marL="0" indent="0" algn="ctr">
               <a:lnSpc>
                 <a:spcPct val="150000"/>
               </a:lnSpc>
               <a:buNone/>
             </a:pPr>
             <a:r>
-              <a:rPr sz="2000" b="1">
+              <a:rPr sz="3600" b="1" dirty="0">
                 <a:solidFill>
                   <a:srgbClr val="000000"/>
                 </a:solidFill>
                 <a:latin typeface="Calibri"/>
               </a:rPr>
               <a:t>P.A. COLLEGE OF ENGINEERING
-</a:t>
-            </a:r>
-            <a:r>
-              <a:rPr sz="2000" b="1">
-                <a:solidFill>
-                  <a:srgbClr val="000000"/>
-                </a:solidFill>
-                <a:latin typeface="Calibri"/>
-              </a:rPr>
-              <a:t>DEPARTMENT OF COMPUTER SCIENCE &amp; ENGINEERING</a:t>
+DEPARTMENT OF COMPUTER SCIENCE &amp; ENGINEERING</a:t>
             </a:r>
           </a:p>
         </p:txBody>
@@ -3243,11 +3236,11 @@
           <a:bodyPr wrap="square"/>
           <a:lstStyle/>
           <a:p>
-            <a:pPr algn="ctr" indent="0" marL="0">
+            <a:pPr marL="0" indent="0" algn="ctr">
               <a:buNone/>
             </a:pPr>
             <a:r>
-              <a:rPr sz="6000" b="1">
+              <a:rPr sz="6000" b="1" dirty="0" err="1">
                 <a:solidFill>
                   <a:srgbClr val="000000"/>
                 </a:solidFill>
@@ -3255,6 +3248,12 @@
               </a:rPr>
               <a:t>SynCura</a:t>
             </a:r>
+            <a:endParaRPr sz="6000" b="1" dirty="0">
+              <a:solidFill>
+                <a:srgbClr val="000000"/>
+              </a:solidFill>
+              <a:latin typeface="Calibri"/>
+            </a:endParaRPr>
           </a:p>
         </p:txBody>
       </p:sp>
@@ -3278,14 +3277,14 @@
           <a:bodyPr wrap="square"/>
           <a:lstStyle/>
           <a:p>
-            <a:pPr algn="ctr" indent="0" marL="0">
+            <a:pPr marL="0" indent="0" algn="ctr">
               <a:lnSpc>
                 <a:spcPct val="150000"/>
               </a:lnSpc>
               <a:buNone/>
             </a:pPr>
             <a:r>
-              <a:rPr sz="3400" b="1">
+              <a:rPr sz="3400" b="1" dirty="0">
                 <a:solidFill>
                   <a:srgbClr val="000000"/>
                 </a:solidFill>
@@ -3316,7 +3315,7 @@
           <a:bodyPr wrap="square"/>
           <a:lstStyle/>
           <a:p>
-            <a:pPr indent="0" marL="0">
+            <a:pPr marL="0" indent="0">
               <a:lnSpc>
                 <a:spcPct val="150000"/>
               </a:lnSpc>
@@ -3340,26 +3339,8 @@
                 <a:latin typeface="Calibri"/>
               </a:rPr>
               <a:t>Abdul Ahad Ikkeri – 4PA24CS002
-</a:t>
-            </a:r>
-            <a:r>
-              <a:rPr sz="3000">
-                <a:solidFill>
-                  <a:srgbClr val="000000"/>
-                </a:solidFill>
-                <a:latin typeface="Calibri"/>
-              </a:rPr>
-              <a:t>Fathima Reeha – 4PA24CS026
-</a:t>
-            </a:r>
-            <a:r>
-              <a:rPr sz="3000">
-                <a:solidFill>
-                  <a:srgbClr val="000000"/>
-                </a:solidFill>
-                <a:latin typeface="Calibri"/>
-              </a:rPr>
-              <a:t>Fizan Feroz – 4PA24CS032</a:t>
+Fathima Reeha – 4PA24CS026
+Fizan Feroz – 4PA24CS032</a:t>
             </a:r>
           </a:p>
         </p:txBody>
@@ -3384,7 +3365,7 @@
           <a:bodyPr wrap="square"/>
           <a:lstStyle/>
           <a:p>
-            <a:pPr/>
+            <a:endParaRPr/>
           </a:p>
         </p:txBody>
       </p:sp>
@@ -3397,7 +3378,7 @@
 </file>
 
 <file path=ppt/slides/slide10.xml><?xml version="1.0" encoding="utf-8"?>
-<p:sld xmlns:a="http://schemas.openxmlformats.org/drawingml/2006/main" xmlns:p="http://schemas.openxmlformats.org/presentationml/2006/main" xmlns:r="http://schemas.openxmlformats.org/officeDocument/2006/relationships">
+<p:sld xmlns:a="http://schemas.openxmlformats.org/drawingml/2006/main" xmlns:r="http://schemas.openxmlformats.org/officeDocument/2006/relationships" xmlns:p="http://schemas.openxmlformats.org/presentationml/2006/main">
   <p:cSld>
     <p:spTree>
       <p:nvGrpSpPr>
@@ -3405,10 +3386,65 @@
         <p:cNvGrpSpPr/>
         <p:nvPr/>
       </p:nvGrpSpPr>
-      <p:grpSpPr/>
+      <p:grpSpPr>
+        <a:xfrm>
+          <a:off x="0" y="0"/>
+          <a:ext cx="0" cy="0"/>
+          <a:chOff x="0" y="0"/>
+          <a:chExt cx="0" cy="0"/>
+        </a:xfrm>
+      </p:grpSpPr>
       <p:pic>
         <p:nvPicPr>
           <p:cNvPr id="7" name="Picture 6" descr="syncura-watermark.png"/>
+          <p:cNvPicPr>
+            <a:picLocks noChangeAspect="1"/>
+          </p:cNvPicPr>
+          <p:nvPr/>
+        </p:nvPicPr>
+        <p:blipFill>
+          <a:blip r:embed="rId2"/>
+          <a:stretch>
+            <a:fillRect/>
+          </a:stretch>
+        </p:blipFill>
+        <p:spPr>
+          <a:xfrm>
+            <a:off x="6675120" y="2743200"/>
+            <a:ext cx="5212080" cy="5212080"/>
+          </a:xfrm>
+          <a:prstGeom prst="rect">
+            <a:avLst/>
+          </a:prstGeom>
+        </p:spPr>
+      </p:pic>
+      <p:pic>
+        <p:nvPicPr>
+          <p:cNvPr id="2" name="Picture 1" descr="image.png"/>
+          <p:cNvPicPr>
+            <a:picLocks noChangeAspect="1"/>
+          </p:cNvPicPr>
+          <p:nvPr/>
+        </p:nvPicPr>
+        <p:blipFill>
+          <a:blip r:embed="rId3"/>
+          <a:stretch>
+            <a:fillRect/>
+          </a:stretch>
+        </p:blipFill>
+        <p:spPr>
+          <a:xfrm>
+            <a:off x="137160" y="109728"/>
+            <a:ext cx="1463040" cy="1463040"/>
+          </a:xfrm>
+          <a:prstGeom prst="rect">
+            <a:avLst/>
+          </a:prstGeom>
+        </p:spPr>
+      </p:pic>
+      <p:pic>
+        <p:nvPicPr>
+          <p:cNvPr id="3" name="Picture 2" descr="image.png"/>
           <p:cNvPicPr>
             <a:picLocks noChangeAspect="1"/>
           </p:cNvPicPr>
@@ -3422,54 +3458,6 @@
         </p:blipFill>
         <p:spPr>
           <a:xfrm>
-            <a:off x="6675120" y="2743200"/>
-            <a:ext cx="5212080" cy="5212080"/>
-          </a:xfrm>
-          <a:prstGeom prst="rect">
-            <a:avLst/>
-          </a:prstGeom>
-        </p:spPr>
-      </p:pic>
-      <p:pic>
-        <p:nvPicPr>
-          <p:cNvPr id="2" name="Picture 1" descr="image.png"/>
-          <p:cNvPicPr>
-            <a:picLocks noChangeAspect="1"/>
-          </p:cNvPicPr>
-          <p:nvPr/>
-        </p:nvPicPr>
-        <p:blipFill>
-          <a:blip r:embed="rId2"/>
-          <a:stretch>
-            <a:fillRect/>
-          </a:stretch>
-        </p:blipFill>
-        <p:spPr>
-          <a:xfrm>
-            <a:off x="137160" y="109728"/>
-            <a:ext cx="1463040" cy="1463040"/>
-          </a:xfrm>
-          <a:prstGeom prst="rect">
-            <a:avLst/>
-          </a:prstGeom>
-        </p:spPr>
-      </p:pic>
-      <p:pic>
-        <p:nvPicPr>
-          <p:cNvPr id="3" name="Picture 2" descr="image.png"/>
-          <p:cNvPicPr>
-            <a:picLocks noChangeAspect="1"/>
-          </p:cNvPicPr>
-          <p:nvPr/>
-        </p:nvPicPr>
-        <p:blipFill>
-          <a:blip r:embed="rId3"/>
-          <a:stretch>
-            <a:fillRect/>
-          </a:stretch>
-        </p:blipFill>
-        <p:spPr>
-          <a:xfrm>
             <a:off x="16687800" y="109728"/>
             <a:ext cx="1463040" cy="1463040"/>
           </a:xfrm>
@@ -3498,7 +3486,7 @@
           <a:bodyPr wrap="square"/>
           <a:lstStyle/>
           <a:p>
-            <a:pPr algn="ctr" indent="0" marL="0">
+            <a:pPr marL="0" indent="0" algn="ctr">
               <a:lnSpc>
                 <a:spcPct val="150000"/>
               </a:lnSpc>
@@ -3512,16 +3500,7 @@
                 <a:latin typeface="Calibri"/>
               </a:rPr>
               <a:t>P.A. COLLEGE OF ENGINEERING
-</a:t>
-            </a:r>
-            <a:r>
-              <a:rPr sz="2000" b="1">
-                <a:solidFill>
-                  <a:srgbClr val="000000"/>
-                </a:solidFill>
-                <a:latin typeface="Calibri"/>
-              </a:rPr>
-              <a:t>DEPARTMENT OF COMPUTER SCIENCE &amp; ENGINEERING</a:t>
+DEPARTMENT OF COMPUTER SCIENCE &amp; ENGINEERING</a:t>
             </a:r>
           </a:p>
         </p:txBody>
@@ -3546,7 +3525,7 @@
           <a:bodyPr wrap="square"/>
           <a:lstStyle/>
           <a:p>
-            <a:pPr algn="ctr" indent="0" marL="0">
+            <a:pPr marL="0" indent="0" algn="ctr">
               <a:buNone/>
             </a:pPr>
             <a:r>
@@ -3663,7 +3642,7 @@
 </file>
 
 <file path=ppt/slides/slide11.xml><?xml version="1.0" encoding="utf-8"?>
-<p:sld xmlns:a="http://schemas.openxmlformats.org/drawingml/2006/main" xmlns:p="http://schemas.openxmlformats.org/presentationml/2006/main" xmlns:r="http://schemas.openxmlformats.org/officeDocument/2006/relationships">
+<p:sld xmlns:a="http://schemas.openxmlformats.org/drawingml/2006/main" xmlns:r="http://schemas.openxmlformats.org/officeDocument/2006/relationships" xmlns:p="http://schemas.openxmlformats.org/presentationml/2006/main">
   <p:cSld>
     <p:spTree>
       <p:nvGrpSpPr>
@@ -3671,10 +3650,65 @@
         <p:cNvGrpSpPr/>
         <p:nvPr/>
       </p:nvGrpSpPr>
-      <p:grpSpPr/>
+      <p:grpSpPr>
+        <a:xfrm>
+          <a:off x="0" y="0"/>
+          <a:ext cx="0" cy="0"/>
+          <a:chOff x="0" y="0"/>
+          <a:chExt cx="0" cy="0"/>
+        </a:xfrm>
+      </p:grpSpPr>
       <p:pic>
         <p:nvPicPr>
           <p:cNvPr id="21" name="Picture 20" descr="syncura-watermark.png"/>
+          <p:cNvPicPr>
+            <a:picLocks noChangeAspect="1"/>
+          </p:cNvPicPr>
+          <p:nvPr/>
+        </p:nvPicPr>
+        <p:blipFill>
+          <a:blip r:embed="rId2"/>
+          <a:stretch>
+            <a:fillRect/>
+          </a:stretch>
+        </p:blipFill>
+        <p:spPr>
+          <a:xfrm>
+            <a:off x="6675120" y="2743200"/>
+            <a:ext cx="5212080" cy="5212080"/>
+          </a:xfrm>
+          <a:prstGeom prst="rect">
+            <a:avLst/>
+          </a:prstGeom>
+        </p:spPr>
+      </p:pic>
+      <p:pic>
+        <p:nvPicPr>
+          <p:cNvPr id="2" name="Picture 1" descr="image.png"/>
+          <p:cNvPicPr>
+            <a:picLocks noChangeAspect="1"/>
+          </p:cNvPicPr>
+          <p:nvPr/>
+        </p:nvPicPr>
+        <p:blipFill>
+          <a:blip r:embed="rId3"/>
+          <a:stretch>
+            <a:fillRect/>
+          </a:stretch>
+        </p:blipFill>
+        <p:spPr>
+          <a:xfrm>
+            <a:off x="137160" y="109728"/>
+            <a:ext cx="1463040" cy="1463040"/>
+          </a:xfrm>
+          <a:prstGeom prst="rect">
+            <a:avLst/>
+          </a:prstGeom>
+        </p:spPr>
+      </p:pic>
+      <p:pic>
+        <p:nvPicPr>
+          <p:cNvPr id="3" name="Picture 2" descr="image.png"/>
           <p:cNvPicPr>
             <a:picLocks noChangeAspect="1"/>
           </p:cNvPicPr>
@@ -3688,54 +3722,6 @@
         </p:blipFill>
         <p:spPr>
           <a:xfrm>
-            <a:off x="6675120" y="2743200"/>
-            <a:ext cx="5212080" cy="5212080"/>
-          </a:xfrm>
-          <a:prstGeom prst="rect">
-            <a:avLst/>
-          </a:prstGeom>
-        </p:spPr>
-      </p:pic>
-      <p:pic>
-        <p:nvPicPr>
-          <p:cNvPr id="2" name="Picture 1" descr="image.png"/>
-          <p:cNvPicPr>
-            <a:picLocks noChangeAspect="1"/>
-          </p:cNvPicPr>
-          <p:nvPr/>
-        </p:nvPicPr>
-        <p:blipFill>
-          <a:blip r:embed="rId2"/>
-          <a:stretch>
-            <a:fillRect/>
-          </a:stretch>
-        </p:blipFill>
-        <p:spPr>
-          <a:xfrm>
-            <a:off x="137160" y="109728"/>
-            <a:ext cx="1463040" cy="1463040"/>
-          </a:xfrm>
-          <a:prstGeom prst="rect">
-            <a:avLst/>
-          </a:prstGeom>
-        </p:spPr>
-      </p:pic>
-      <p:pic>
-        <p:nvPicPr>
-          <p:cNvPr id="3" name="Picture 2" descr="image.png"/>
-          <p:cNvPicPr>
-            <a:picLocks noChangeAspect="1"/>
-          </p:cNvPicPr>
-          <p:nvPr/>
-        </p:nvPicPr>
-        <p:blipFill>
-          <a:blip r:embed="rId3"/>
-          <a:stretch>
-            <a:fillRect/>
-          </a:stretch>
-        </p:blipFill>
-        <p:spPr>
-          <a:xfrm>
             <a:off x="16687800" y="109728"/>
             <a:ext cx="1463040" cy="1463040"/>
           </a:xfrm>
@@ -3764,7 +3750,7 @@
           <a:bodyPr wrap="square"/>
           <a:lstStyle/>
           <a:p>
-            <a:pPr algn="ctr" indent="0" marL="0">
+            <a:pPr marL="0" indent="0" algn="ctr">
               <a:lnSpc>
                 <a:spcPct val="150000"/>
               </a:lnSpc>
@@ -3778,16 +3764,7 @@
                 <a:latin typeface="Calibri"/>
               </a:rPr>
               <a:t>P.A. COLLEGE OF ENGINEERING
-</a:t>
-            </a:r>
-            <a:r>
-              <a:rPr sz="2000" b="1">
-                <a:solidFill>
-                  <a:srgbClr val="000000"/>
-                </a:solidFill>
-                <a:latin typeface="Calibri"/>
-              </a:rPr>
-              <a:t>DEPARTMENT OF COMPUTER SCIENCE &amp; ENGINEERING</a:t>
+DEPARTMENT OF COMPUTER SCIENCE &amp; ENGINEERING</a:t>
             </a:r>
           </a:p>
         </p:txBody>
@@ -3812,7 +3789,7 @@
           <a:bodyPr wrap="square"/>
           <a:lstStyle/>
           <a:p>
-            <a:pPr algn="ctr" indent="0" marL="0">
+            <a:pPr marL="0" indent="0" algn="ctr">
               <a:buNone/>
             </a:pPr>
             <a:r>
@@ -3928,7 +3905,7 @@
           </a:fontRef>
         </p:style>
         <p:txBody>
-          <a:bodyPr rtlCol="0" anchor="ctr" wrap="square"/>
+          <a:bodyPr wrap="square" rtlCol="0" anchor="ctr"/>
           <a:lstStyle/>
           <a:p>
             <a:pPr algn="ctr"/>
@@ -4000,6 +3977,7 @@
           <a:lstStyle/>
           <a:p>
             <a:pPr algn="ctr"/>
+            <a:endParaRPr/>
           </a:p>
         </p:txBody>
       </p:sp>
@@ -4041,7 +4019,7 @@
           </a:fontRef>
         </p:style>
         <p:txBody>
-          <a:bodyPr rtlCol="0" anchor="ctr" wrap="square"/>
+          <a:bodyPr wrap="square" rtlCol="0" anchor="ctr"/>
           <a:lstStyle/>
           <a:p>
             <a:pPr algn="ctr"/>
@@ -4113,6 +4091,7 @@
           <a:lstStyle/>
           <a:p>
             <a:pPr algn="ctr"/>
+            <a:endParaRPr/>
           </a:p>
         </p:txBody>
       </p:sp>
@@ -4154,7 +4133,7 @@
           </a:fontRef>
         </p:style>
         <p:txBody>
-          <a:bodyPr rtlCol="0" anchor="ctr" wrap="square"/>
+          <a:bodyPr wrap="square" rtlCol="0" anchor="ctr"/>
           <a:lstStyle/>
           <a:p>
             <a:pPr algn="ctr"/>
@@ -4226,6 +4205,7 @@
           <a:lstStyle/>
           <a:p>
             <a:pPr algn="ctr"/>
+            <a:endParaRPr/>
           </a:p>
         </p:txBody>
       </p:sp>
@@ -4267,7 +4247,7 @@
           </a:fontRef>
         </p:style>
         <p:txBody>
-          <a:bodyPr rtlCol="0" anchor="ctr" wrap="square"/>
+          <a:bodyPr wrap="square" rtlCol="0" anchor="ctr"/>
           <a:lstStyle/>
           <a:p>
             <a:pPr algn="ctr"/>
@@ -4308,7 +4288,7 @@
 </file>
 
 <file path=ppt/slides/slide12.xml><?xml version="1.0" encoding="utf-8"?>
-<p:sld xmlns:a="http://schemas.openxmlformats.org/drawingml/2006/main" xmlns:p="http://schemas.openxmlformats.org/presentationml/2006/main" xmlns:r="http://schemas.openxmlformats.org/officeDocument/2006/relationships">
+<p:sld xmlns:a="http://schemas.openxmlformats.org/drawingml/2006/main" xmlns:r="http://schemas.openxmlformats.org/officeDocument/2006/relationships" xmlns:p="http://schemas.openxmlformats.org/presentationml/2006/main">
   <p:cSld>
     <p:spTree>
       <p:nvGrpSpPr>
@@ -4316,10 +4296,65 @@
         <p:cNvGrpSpPr/>
         <p:nvPr/>
       </p:nvGrpSpPr>
-      <p:grpSpPr/>
+      <p:grpSpPr>
+        <a:xfrm>
+          <a:off x="0" y="0"/>
+          <a:ext cx="0" cy="0"/>
+          <a:chOff x="0" y="0"/>
+          <a:chExt cx="0" cy="0"/>
+        </a:xfrm>
+      </p:grpSpPr>
       <p:pic>
         <p:nvPicPr>
           <p:cNvPr id="7" name="Picture 6" descr="syncura-watermark.png"/>
+          <p:cNvPicPr>
+            <a:picLocks noChangeAspect="1"/>
+          </p:cNvPicPr>
+          <p:nvPr/>
+        </p:nvPicPr>
+        <p:blipFill>
+          <a:blip r:embed="rId2"/>
+          <a:stretch>
+            <a:fillRect/>
+          </a:stretch>
+        </p:blipFill>
+        <p:spPr>
+          <a:xfrm>
+            <a:off x="6675120" y="2743200"/>
+            <a:ext cx="5212080" cy="5212080"/>
+          </a:xfrm>
+          <a:prstGeom prst="rect">
+            <a:avLst/>
+          </a:prstGeom>
+        </p:spPr>
+      </p:pic>
+      <p:pic>
+        <p:nvPicPr>
+          <p:cNvPr id="2" name="Picture 1" descr="image.png"/>
+          <p:cNvPicPr>
+            <a:picLocks noChangeAspect="1"/>
+          </p:cNvPicPr>
+          <p:nvPr/>
+        </p:nvPicPr>
+        <p:blipFill>
+          <a:blip r:embed="rId3"/>
+          <a:stretch>
+            <a:fillRect/>
+          </a:stretch>
+        </p:blipFill>
+        <p:spPr>
+          <a:xfrm>
+            <a:off x="137160" y="109728"/>
+            <a:ext cx="1463040" cy="1463040"/>
+          </a:xfrm>
+          <a:prstGeom prst="rect">
+            <a:avLst/>
+          </a:prstGeom>
+        </p:spPr>
+      </p:pic>
+      <p:pic>
+        <p:nvPicPr>
+          <p:cNvPr id="3" name="Picture 2" descr="image.png"/>
           <p:cNvPicPr>
             <a:picLocks noChangeAspect="1"/>
           </p:cNvPicPr>
@@ -4333,54 +4368,6 @@
         </p:blipFill>
         <p:spPr>
           <a:xfrm>
-            <a:off x="6675120" y="2743200"/>
-            <a:ext cx="5212080" cy="5212080"/>
-          </a:xfrm>
-          <a:prstGeom prst="rect">
-            <a:avLst/>
-          </a:prstGeom>
-        </p:spPr>
-      </p:pic>
-      <p:pic>
-        <p:nvPicPr>
-          <p:cNvPr id="2" name="Picture 1" descr="image.png"/>
-          <p:cNvPicPr>
-            <a:picLocks noChangeAspect="1"/>
-          </p:cNvPicPr>
-          <p:nvPr/>
-        </p:nvPicPr>
-        <p:blipFill>
-          <a:blip r:embed="rId2"/>
-          <a:stretch>
-            <a:fillRect/>
-          </a:stretch>
-        </p:blipFill>
-        <p:spPr>
-          <a:xfrm>
-            <a:off x="137160" y="109728"/>
-            <a:ext cx="1463040" cy="1463040"/>
-          </a:xfrm>
-          <a:prstGeom prst="rect">
-            <a:avLst/>
-          </a:prstGeom>
-        </p:spPr>
-      </p:pic>
-      <p:pic>
-        <p:nvPicPr>
-          <p:cNvPr id="3" name="Picture 2" descr="image.png"/>
-          <p:cNvPicPr>
-            <a:picLocks noChangeAspect="1"/>
-          </p:cNvPicPr>
-          <p:nvPr/>
-        </p:nvPicPr>
-        <p:blipFill>
-          <a:blip r:embed="rId3"/>
-          <a:stretch>
-            <a:fillRect/>
-          </a:stretch>
-        </p:blipFill>
-        <p:spPr>
-          <a:xfrm>
             <a:off x="16687800" y="109728"/>
             <a:ext cx="1463040" cy="1463040"/>
           </a:xfrm>
@@ -4409,7 +4396,7 @@
           <a:bodyPr wrap="square"/>
           <a:lstStyle/>
           <a:p>
-            <a:pPr algn="ctr" indent="0" marL="0">
+            <a:pPr marL="0" indent="0" algn="ctr">
               <a:lnSpc>
                 <a:spcPct val="150000"/>
               </a:lnSpc>
@@ -4423,16 +4410,7 @@
                 <a:latin typeface="Calibri"/>
               </a:rPr>
               <a:t>P.A. COLLEGE OF ENGINEERING
-</a:t>
-            </a:r>
-            <a:r>
-              <a:rPr sz="2000" b="1">
-                <a:solidFill>
-                  <a:srgbClr val="000000"/>
-                </a:solidFill>
-                <a:latin typeface="Calibri"/>
-              </a:rPr>
-              <a:t>DEPARTMENT OF COMPUTER SCIENCE &amp; ENGINEERING</a:t>
+DEPARTMENT OF COMPUTER SCIENCE &amp; ENGINEERING</a:t>
             </a:r>
           </a:p>
         </p:txBody>
@@ -4457,7 +4435,7 @@
           <a:bodyPr wrap="square"/>
           <a:lstStyle/>
           <a:p>
-            <a:pPr algn="ctr" indent="0" marL="0">
+            <a:pPr marL="0" indent="0" algn="ctr">
               <a:buNone/>
             </a:pPr>
             <a:r>
@@ -4513,7 +4491,6 @@
             </a:r>
           </a:p>
           <a:p>
-            <a:pPr/>
             <a:r>
               <a:rPr sz="2400">
                 <a:solidFill>
@@ -4535,7 +4512,7 @@
 </file>
 
 <file path=ppt/slides/slide13.xml><?xml version="1.0" encoding="utf-8"?>
-<p:sld xmlns:a="http://schemas.openxmlformats.org/drawingml/2006/main" xmlns:p="http://schemas.openxmlformats.org/presentationml/2006/main" xmlns:r="http://schemas.openxmlformats.org/officeDocument/2006/relationships">
+<p:sld xmlns:a="http://schemas.openxmlformats.org/drawingml/2006/main" xmlns:r="http://schemas.openxmlformats.org/officeDocument/2006/relationships" xmlns:p="http://schemas.openxmlformats.org/presentationml/2006/main">
   <p:cSld>
     <p:spTree>
       <p:nvGrpSpPr>
@@ -4543,10 +4520,65 @@
         <p:cNvGrpSpPr/>
         <p:nvPr/>
       </p:nvGrpSpPr>
-      <p:grpSpPr/>
+      <p:grpSpPr>
+        <a:xfrm>
+          <a:off x="0" y="0"/>
+          <a:ext cx="0" cy="0"/>
+          <a:chOff x="0" y="0"/>
+          <a:chExt cx="0" cy="0"/>
+        </a:xfrm>
+      </p:grpSpPr>
       <p:pic>
         <p:nvPicPr>
           <p:cNvPr id="7" name="Picture 6" descr="syncura-watermark.png"/>
+          <p:cNvPicPr>
+            <a:picLocks noChangeAspect="1"/>
+          </p:cNvPicPr>
+          <p:nvPr/>
+        </p:nvPicPr>
+        <p:blipFill>
+          <a:blip r:embed="rId2"/>
+          <a:stretch>
+            <a:fillRect/>
+          </a:stretch>
+        </p:blipFill>
+        <p:spPr>
+          <a:xfrm>
+            <a:off x="6675120" y="2743200"/>
+            <a:ext cx="5212080" cy="5212080"/>
+          </a:xfrm>
+          <a:prstGeom prst="rect">
+            <a:avLst/>
+          </a:prstGeom>
+        </p:spPr>
+      </p:pic>
+      <p:pic>
+        <p:nvPicPr>
+          <p:cNvPr id="2" name="Picture 1" descr="image.png"/>
+          <p:cNvPicPr>
+            <a:picLocks noChangeAspect="1"/>
+          </p:cNvPicPr>
+          <p:nvPr/>
+        </p:nvPicPr>
+        <p:blipFill>
+          <a:blip r:embed="rId3"/>
+          <a:stretch>
+            <a:fillRect/>
+          </a:stretch>
+        </p:blipFill>
+        <p:spPr>
+          <a:xfrm>
+            <a:off x="137160" y="109728"/>
+            <a:ext cx="1463040" cy="1463040"/>
+          </a:xfrm>
+          <a:prstGeom prst="rect">
+            <a:avLst/>
+          </a:prstGeom>
+        </p:spPr>
+      </p:pic>
+      <p:pic>
+        <p:nvPicPr>
+          <p:cNvPr id="3" name="Picture 2" descr="image.png"/>
           <p:cNvPicPr>
             <a:picLocks noChangeAspect="1"/>
           </p:cNvPicPr>
@@ -4560,54 +4592,6 @@
         </p:blipFill>
         <p:spPr>
           <a:xfrm>
-            <a:off x="6675120" y="2743200"/>
-            <a:ext cx="5212080" cy="5212080"/>
-          </a:xfrm>
-          <a:prstGeom prst="rect">
-            <a:avLst/>
-          </a:prstGeom>
-        </p:spPr>
-      </p:pic>
-      <p:pic>
-        <p:nvPicPr>
-          <p:cNvPr id="2" name="Picture 1" descr="image.png"/>
-          <p:cNvPicPr>
-            <a:picLocks noChangeAspect="1"/>
-          </p:cNvPicPr>
-          <p:nvPr/>
-        </p:nvPicPr>
-        <p:blipFill>
-          <a:blip r:embed="rId2"/>
-          <a:stretch>
-            <a:fillRect/>
-          </a:stretch>
-        </p:blipFill>
-        <p:spPr>
-          <a:xfrm>
-            <a:off x="137160" y="109728"/>
-            <a:ext cx="1463040" cy="1463040"/>
-          </a:xfrm>
-          <a:prstGeom prst="rect">
-            <a:avLst/>
-          </a:prstGeom>
-        </p:spPr>
-      </p:pic>
-      <p:pic>
-        <p:nvPicPr>
-          <p:cNvPr id="3" name="Picture 2" descr="image.png"/>
-          <p:cNvPicPr>
-            <a:picLocks noChangeAspect="1"/>
-          </p:cNvPicPr>
-          <p:nvPr/>
-        </p:nvPicPr>
-        <p:blipFill>
-          <a:blip r:embed="rId3"/>
-          <a:stretch>
-            <a:fillRect/>
-          </a:stretch>
-        </p:blipFill>
-        <p:spPr>
-          <a:xfrm>
             <a:off x="16687800" y="109728"/>
             <a:ext cx="1463040" cy="1463040"/>
           </a:xfrm>
@@ -4636,7 +4620,7 @@
           <a:bodyPr wrap="square"/>
           <a:lstStyle/>
           <a:p>
-            <a:pPr algn="ctr" indent="0" marL="0">
+            <a:pPr marL="0" indent="0" algn="ctr">
               <a:lnSpc>
                 <a:spcPct val="150000"/>
               </a:lnSpc>
@@ -4650,16 +4634,7 @@
                 <a:latin typeface="Calibri"/>
               </a:rPr>
               <a:t>P.A. COLLEGE OF ENGINEERING
-</a:t>
-            </a:r>
-            <a:r>
-              <a:rPr sz="2000" b="1">
-                <a:solidFill>
-                  <a:srgbClr val="000000"/>
-                </a:solidFill>
-                <a:latin typeface="Calibri"/>
-              </a:rPr>
-              <a:t>DEPARTMENT OF COMPUTER SCIENCE &amp; ENGINEERING</a:t>
+DEPARTMENT OF COMPUTER SCIENCE &amp; ENGINEERING</a:t>
             </a:r>
           </a:p>
         </p:txBody>
@@ -4816,7 +4791,7 @@
 </file>
 
 <file path=ppt/slides/slide14.xml><?xml version="1.0" encoding="utf-8"?>
-<p:sld xmlns:a="http://schemas.openxmlformats.org/drawingml/2006/main" xmlns:p="http://schemas.openxmlformats.org/presentationml/2006/main" xmlns:r="http://schemas.openxmlformats.org/officeDocument/2006/relationships">
+<p:sld xmlns:a="http://schemas.openxmlformats.org/drawingml/2006/main" xmlns:r="http://schemas.openxmlformats.org/officeDocument/2006/relationships" xmlns:p="http://schemas.openxmlformats.org/presentationml/2006/main">
   <p:cSld>
     <p:spTree>
       <p:nvGrpSpPr>
@@ -4824,7 +4799,14 @@
         <p:cNvGrpSpPr/>
         <p:nvPr/>
       </p:nvGrpSpPr>
-      <p:grpSpPr/>
+      <p:grpSpPr>
+        <a:xfrm>
+          <a:off x="0" y="0"/>
+          <a:ext cx="0" cy="0"/>
+          <a:chOff x="0" y="0"/>
+          <a:chExt cx="0" cy="0"/>
+        </a:xfrm>
+      </p:grpSpPr>
       <p:pic>
         <p:nvPicPr>
           <p:cNvPr id="7" name="Picture 6" descr="syncura-watermark.png"/>
@@ -4834,7 +4816,7 @@
           <p:nvPr/>
         </p:nvPicPr>
         <p:blipFill>
-          <a:blip r:embed="rId4"/>
+          <a:blip r:embed="rId2"/>
           <a:stretch>
             <a:fillRect/>
           </a:stretch>
@@ -4858,7 +4840,7 @@
           <p:nvPr/>
         </p:nvPicPr>
         <p:blipFill>
-          <a:blip r:embed="rId2"/>
+          <a:blip r:embed="rId3"/>
           <a:stretch>
             <a:fillRect/>
           </a:stretch>
@@ -4882,7 +4864,7 @@
           <p:nvPr/>
         </p:nvPicPr>
         <p:blipFill>
-          <a:blip r:embed="rId3"/>
+          <a:blip r:embed="rId4"/>
           <a:stretch>
             <a:fillRect/>
           </a:stretch>
@@ -5079,7 +5061,7 @@
 </file>
 
 <file path=ppt/slides/slide15.xml><?xml version="1.0" encoding="utf-8"?>
-<p:sld xmlns:a="http://schemas.openxmlformats.org/drawingml/2006/main" xmlns:p="http://schemas.openxmlformats.org/presentationml/2006/main" xmlns:r="http://schemas.openxmlformats.org/officeDocument/2006/relationships">
+<p:sld xmlns:a="http://schemas.openxmlformats.org/drawingml/2006/main" xmlns:r="http://schemas.openxmlformats.org/officeDocument/2006/relationships" xmlns:p="http://schemas.openxmlformats.org/presentationml/2006/main">
   <p:cSld>
     <p:spTree>
       <p:nvGrpSpPr>
@@ -5087,10 +5069,65 @@
         <p:cNvGrpSpPr/>
         <p:nvPr/>
       </p:nvGrpSpPr>
-      <p:grpSpPr/>
+      <p:grpSpPr>
+        <a:xfrm>
+          <a:off x="0" y="0"/>
+          <a:ext cx="0" cy="0"/>
+          <a:chOff x="0" y="0"/>
+          <a:chExt cx="0" cy="0"/>
+        </a:xfrm>
+      </p:grpSpPr>
       <p:pic>
         <p:nvPicPr>
           <p:cNvPr id="7" name="Picture 6" descr="syncura-watermark.png"/>
+          <p:cNvPicPr>
+            <a:picLocks noChangeAspect="1"/>
+          </p:cNvPicPr>
+          <p:nvPr/>
+        </p:nvPicPr>
+        <p:blipFill>
+          <a:blip r:embed="rId2"/>
+          <a:stretch>
+            <a:fillRect/>
+          </a:stretch>
+        </p:blipFill>
+        <p:spPr>
+          <a:xfrm>
+            <a:off x="6675120" y="2743200"/>
+            <a:ext cx="5212080" cy="5212080"/>
+          </a:xfrm>
+          <a:prstGeom prst="rect">
+            <a:avLst/>
+          </a:prstGeom>
+        </p:spPr>
+      </p:pic>
+      <p:pic>
+        <p:nvPicPr>
+          <p:cNvPr id="2" name="Picture 1" descr="image.png"/>
+          <p:cNvPicPr>
+            <a:picLocks noChangeAspect="1"/>
+          </p:cNvPicPr>
+          <p:nvPr/>
+        </p:nvPicPr>
+        <p:blipFill>
+          <a:blip r:embed="rId3"/>
+          <a:stretch>
+            <a:fillRect/>
+          </a:stretch>
+        </p:blipFill>
+        <p:spPr>
+          <a:xfrm>
+            <a:off x="137160" y="109728"/>
+            <a:ext cx="1463040" cy="1463040"/>
+          </a:xfrm>
+          <a:prstGeom prst="rect">
+            <a:avLst/>
+          </a:prstGeom>
+        </p:spPr>
+      </p:pic>
+      <p:pic>
+        <p:nvPicPr>
+          <p:cNvPr id="3" name="Picture 2" descr="image.png"/>
           <p:cNvPicPr>
             <a:picLocks noChangeAspect="1"/>
           </p:cNvPicPr>
@@ -5104,54 +5141,6 @@
         </p:blipFill>
         <p:spPr>
           <a:xfrm>
-            <a:off x="6675120" y="2743200"/>
-            <a:ext cx="5212080" cy="5212080"/>
-          </a:xfrm>
-          <a:prstGeom prst="rect">
-            <a:avLst/>
-          </a:prstGeom>
-        </p:spPr>
-      </p:pic>
-      <p:pic>
-        <p:nvPicPr>
-          <p:cNvPr id="2" name="Picture 1" descr="image.png"/>
-          <p:cNvPicPr>
-            <a:picLocks noChangeAspect="1"/>
-          </p:cNvPicPr>
-          <p:nvPr/>
-        </p:nvPicPr>
-        <p:blipFill>
-          <a:blip r:embed="rId2"/>
-          <a:stretch>
-            <a:fillRect/>
-          </a:stretch>
-        </p:blipFill>
-        <p:spPr>
-          <a:xfrm>
-            <a:off x="137160" y="109728"/>
-            <a:ext cx="1463040" cy="1463040"/>
-          </a:xfrm>
-          <a:prstGeom prst="rect">
-            <a:avLst/>
-          </a:prstGeom>
-        </p:spPr>
-      </p:pic>
-      <p:pic>
-        <p:nvPicPr>
-          <p:cNvPr id="3" name="Picture 2" descr="image.png"/>
-          <p:cNvPicPr>
-            <a:picLocks noChangeAspect="1"/>
-          </p:cNvPicPr>
-          <p:nvPr/>
-        </p:nvPicPr>
-        <p:blipFill>
-          <a:blip r:embed="rId3"/>
-          <a:stretch>
-            <a:fillRect/>
-          </a:stretch>
-        </p:blipFill>
-        <p:spPr>
-          <a:xfrm>
             <a:off x="16687800" y="109728"/>
             <a:ext cx="1463040" cy="1463040"/>
           </a:xfrm>
@@ -5180,7 +5169,7 @@
           <a:bodyPr wrap="square"/>
           <a:lstStyle/>
           <a:p>
-            <a:pPr algn="ctr" indent="0" marL="0">
+            <a:pPr marL="0" indent="0" algn="ctr">
               <a:lnSpc>
                 <a:spcPct val="150000"/>
               </a:lnSpc>
@@ -5194,16 +5183,7 @@
                 <a:latin typeface="Calibri"/>
               </a:rPr>
               <a:t>P.A. COLLEGE OF ENGINEERING
-</a:t>
-            </a:r>
-            <a:r>
-              <a:rPr sz="2000" b="1">
-                <a:solidFill>
-                  <a:srgbClr val="000000"/>
-                </a:solidFill>
-                <a:latin typeface="Calibri"/>
-              </a:rPr>
-              <a:t>DEPARTMENT OF COMPUTER SCIENCE &amp; ENGINEERING</a:t>
+DEPARTMENT OF COMPUTER SCIENCE &amp; ENGINEERING</a:t>
             </a:r>
           </a:p>
         </p:txBody>
@@ -5228,7 +5208,7 @@
           <a:bodyPr wrap="square"/>
           <a:lstStyle/>
           <a:p>
-            <a:pPr algn="ctr" indent="0" marL="0">
+            <a:pPr marL="0" indent="0" algn="ctr">
               <a:buNone/>
             </a:pPr>
             <a:r>
@@ -5355,7 +5335,7 @@
 </file>
 
 <file path=ppt/slides/slide16.xml><?xml version="1.0" encoding="utf-8"?>
-<p:sld xmlns:a="http://schemas.openxmlformats.org/drawingml/2006/main" xmlns:p="http://schemas.openxmlformats.org/presentationml/2006/main" xmlns:r="http://schemas.openxmlformats.org/officeDocument/2006/relationships">
+<p:sld xmlns:a="http://schemas.openxmlformats.org/drawingml/2006/main" xmlns:r="http://schemas.openxmlformats.org/officeDocument/2006/relationships" xmlns:p="http://schemas.openxmlformats.org/presentationml/2006/main">
   <p:cSld>
     <p:spTree>
       <p:nvGrpSpPr>
@@ -5363,10 +5343,65 @@
         <p:cNvGrpSpPr/>
         <p:nvPr/>
       </p:nvGrpSpPr>
-      <p:grpSpPr/>
+      <p:grpSpPr>
+        <a:xfrm>
+          <a:off x="0" y="0"/>
+          <a:ext cx="0" cy="0"/>
+          <a:chOff x="0" y="0"/>
+          <a:chExt cx="0" cy="0"/>
+        </a:xfrm>
+      </p:grpSpPr>
       <p:pic>
         <p:nvPicPr>
           <p:cNvPr id="6" name="Picture 5" descr="syncura-watermark.png"/>
+          <p:cNvPicPr>
+            <a:picLocks noChangeAspect="1"/>
+          </p:cNvPicPr>
+          <p:nvPr/>
+        </p:nvPicPr>
+        <p:blipFill>
+          <a:blip r:embed="rId2"/>
+          <a:stretch>
+            <a:fillRect/>
+          </a:stretch>
+        </p:blipFill>
+        <p:spPr>
+          <a:xfrm>
+            <a:off x="6675120" y="2743200"/>
+            <a:ext cx="5212080" cy="5212080"/>
+          </a:xfrm>
+          <a:prstGeom prst="rect">
+            <a:avLst/>
+          </a:prstGeom>
+        </p:spPr>
+      </p:pic>
+      <p:pic>
+        <p:nvPicPr>
+          <p:cNvPr id="2" name="Picture 1" descr="image.png"/>
+          <p:cNvPicPr>
+            <a:picLocks noChangeAspect="1"/>
+          </p:cNvPicPr>
+          <p:nvPr/>
+        </p:nvPicPr>
+        <p:blipFill>
+          <a:blip r:embed="rId3"/>
+          <a:stretch>
+            <a:fillRect/>
+          </a:stretch>
+        </p:blipFill>
+        <p:spPr>
+          <a:xfrm>
+            <a:off x="137160" y="109728"/>
+            <a:ext cx="1463040" cy="1463040"/>
+          </a:xfrm>
+          <a:prstGeom prst="rect">
+            <a:avLst/>
+          </a:prstGeom>
+        </p:spPr>
+      </p:pic>
+      <p:pic>
+        <p:nvPicPr>
+          <p:cNvPr id="3" name="Picture 2" descr="image.png"/>
           <p:cNvPicPr>
             <a:picLocks noChangeAspect="1"/>
           </p:cNvPicPr>
@@ -5380,54 +5415,6 @@
         </p:blipFill>
         <p:spPr>
           <a:xfrm>
-            <a:off x="6675120" y="2743200"/>
-            <a:ext cx="5212080" cy="5212080"/>
-          </a:xfrm>
-          <a:prstGeom prst="rect">
-            <a:avLst/>
-          </a:prstGeom>
-        </p:spPr>
-      </p:pic>
-      <p:pic>
-        <p:nvPicPr>
-          <p:cNvPr id="2" name="Picture 1" descr="image.png"/>
-          <p:cNvPicPr>
-            <a:picLocks noChangeAspect="1"/>
-          </p:cNvPicPr>
-          <p:nvPr/>
-        </p:nvPicPr>
-        <p:blipFill>
-          <a:blip r:embed="rId2"/>
-          <a:stretch>
-            <a:fillRect/>
-          </a:stretch>
-        </p:blipFill>
-        <p:spPr>
-          <a:xfrm>
-            <a:off x="137160" y="109728"/>
-            <a:ext cx="1463040" cy="1463040"/>
-          </a:xfrm>
-          <a:prstGeom prst="rect">
-            <a:avLst/>
-          </a:prstGeom>
-        </p:spPr>
-      </p:pic>
-      <p:pic>
-        <p:nvPicPr>
-          <p:cNvPr id="3" name="Picture 2" descr="image.png"/>
-          <p:cNvPicPr>
-            <a:picLocks noChangeAspect="1"/>
-          </p:cNvPicPr>
-          <p:nvPr/>
-        </p:nvPicPr>
-        <p:blipFill>
-          <a:blip r:embed="rId3"/>
-          <a:stretch>
-            <a:fillRect/>
-          </a:stretch>
-        </p:blipFill>
-        <p:spPr>
-          <a:xfrm>
             <a:off x="16687800" y="109728"/>
             <a:ext cx="1463040" cy="1463040"/>
           </a:xfrm>
@@ -5456,7 +5443,7 @@
           <a:bodyPr wrap="square"/>
           <a:lstStyle/>
           <a:p>
-            <a:pPr algn="ctr" indent="0" marL="0">
+            <a:pPr marL="0" indent="0" algn="ctr">
               <a:lnSpc>
                 <a:spcPct val="150000"/>
               </a:lnSpc>
@@ -5470,16 +5457,7 @@
                 <a:latin typeface="Calibri"/>
               </a:rPr>
               <a:t>P.A. COLLEGE OF ENGINEERING
-</a:t>
-            </a:r>
-            <a:r>
-              <a:rPr sz="2000" b="1">
-                <a:solidFill>
-                  <a:srgbClr val="000000"/>
-                </a:solidFill>
-                <a:latin typeface="Calibri"/>
-              </a:rPr>
-              <a:t>DEPARTMENT OF COMPUTER SCIENCE &amp; ENGINEERING</a:t>
+DEPARTMENT OF COMPUTER SCIENCE &amp; ENGINEERING</a:t>
             </a:r>
           </a:p>
         </p:txBody>
@@ -5504,7 +5482,7 @@
           <a:bodyPr wrap="square"/>
           <a:lstStyle/>
           <a:p>
-            <a:pPr algn="ctr" indent="0" marL="0">
+            <a:pPr marL="0" indent="0" algn="ctr">
               <a:buNone/>
             </a:pPr>
             <a:r>
@@ -5528,7 +5506,7 @@
 </file>
 
 <file path=ppt/slides/slide2.xml><?xml version="1.0" encoding="utf-8"?>
-<p:sld xmlns:a="http://schemas.openxmlformats.org/drawingml/2006/main" xmlns:p="http://schemas.openxmlformats.org/presentationml/2006/main" xmlns:r="http://schemas.openxmlformats.org/officeDocument/2006/relationships">
+<p:sld xmlns:a="http://schemas.openxmlformats.org/drawingml/2006/main" xmlns:r="http://schemas.openxmlformats.org/officeDocument/2006/relationships" xmlns:p="http://schemas.openxmlformats.org/presentationml/2006/main">
   <p:cSld>
     <p:spTree>
       <p:nvGrpSpPr>
@@ -5536,10 +5514,65 @@
         <p:cNvGrpSpPr/>
         <p:nvPr/>
       </p:nvGrpSpPr>
-      <p:grpSpPr/>
+      <p:grpSpPr>
+        <a:xfrm>
+          <a:off x="0" y="0"/>
+          <a:ext cx="0" cy="0"/>
+          <a:chOff x="0" y="0"/>
+          <a:chExt cx="0" cy="0"/>
+        </a:xfrm>
+      </p:grpSpPr>
       <p:pic>
         <p:nvPicPr>
           <p:cNvPr id="7" name="Picture 6" descr="syncura-watermark.png"/>
+          <p:cNvPicPr>
+            <a:picLocks noChangeAspect="1"/>
+          </p:cNvPicPr>
+          <p:nvPr/>
+        </p:nvPicPr>
+        <p:blipFill>
+          <a:blip r:embed="rId2"/>
+          <a:stretch>
+            <a:fillRect/>
+          </a:stretch>
+        </p:blipFill>
+        <p:spPr>
+          <a:xfrm>
+            <a:off x="6675120" y="2743200"/>
+            <a:ext cx="5212080" cy="5212080"/>
+          </a:xfrm>
+          <a:prstGeom prst="rect">
+            <a:avLst/>
+          </a:prstGeom>
+        </p:spPr>
+      </p:pic>
+      <p:pic>
+        <p:nvPicPr>
+          <p:cNvPr id="2" name="Picture 1" descr="image.png"/>
+          <p:cNvPicPr>
+            <a:picLocks noChangeAspect="1"/>
+          </p:cNvPicPr>
+          <p:nvPr/>
+        </p:nvPicPr>
+        <p:blipFill>
+          <a:blip r:embed="rId3"/>
+          <a:stretch>
+            <a:fillRect/>
+          </a:stretch>
+        </p:blipFill>
+        <p:spPr>
+          <a:xfrm>
+            <a:off x="137160" y="109728"/>
+            <a:ext cx="1463040" cy="1463040"/>
+          </a:xfrm>
+          <a:prstGeom prst="rect">
+            <a:avLst/>
+          </a:prstGeom>
+        </p:spPr>
+      </p:pic>
+      <p:pic>
+        <p:nvPicPr>
+          <p:cNvPr id="3" name="Picture 2" descr="image.png"/>
           <p:cNvPicPr>
             <a:picLocks noChangeAspect="1"/>
           </p:cNvPicPr>
@@ -5553,54 +5586,6 @@
         </p:blipFill>
         <p:spPr>
           <a:xfrm>
-            <a:off x="6675120" y="2743200"/>
-            <a:ext cx="5212080" cy="5212080"/>
-          </a:xfrm>
-          <a:prstGeom prst="rect">
-            <a:avLst/>
-          </a:prstGeom>
-        </p:spPr>
-      </p:pic>
-      <p:pic>
-        <p:nvPicPr>
-          <p:cNvPr id="2" name="Picture 1" descr="image.png"/>
-          <p:cNvPicPr>
-            <a:picLocks noChangeAspect="1"/>
-          </p:cNvPicPr>
-          <p:nvPr/>
-        </p:nvPicPr>
-        <p:blipFill>
-          <a:blip r:embed="rId2"/>
-          <a:stretch>
-            <a:fillRect/>
-          </a:stretch>
-        </p:blipFill>
-        <p:spPr>
-          <a:xfrm>
-            <a:off x="137160" y="109728"/>
-            <a:ext cx="1463040" cy="1463040"/>
-          </a:xfrm>
-          <a:prstGeom prst="rect">
-            <a:avLst/>
-          </a:prstGeom>
-        </p:spPr>
-      </p:pic>
-      <p:pic>
-        <p:nvPicPr>
-          <p:cNvPr id="3" name="Picture 2" descr="image.png"/>
-          <p:cNvPicPr>
-            <a:picLocks noChangeAspect="1"/>
-          </p:cNvPicPr>
-          <p:nvPr/>
-        </p:nvPicPr>
-        <p:blipFill>
-          <a:blip r:embed="rId3"/>
-          <a:stretch>
-            <a:fillRect/>
-          </a:stretch>
-        </p:blipFill>
-        <p:spPr>
-          <a:xfrm>
             <a:off x="16687800" y="109728"/>
             <a:ext cx="1463040" cy="1463040"/>
           </a:xfrm>
@@ -5629,7 +5614,7 @@
           <a:bodyPr wrap="square"/>
           <a:lstStyle/>
           <a:p>
-            <a:pPr algn="ctr" indent="0" marL="0">
+            <a:pPr marL="0" indent="0" algn="ctr">
               <a:lnSpc>
                 <a:spcPct val="150000"/>
               </a:lnSpc>
@@ -5643,16 +5628,7 @@
                 <a:latin typeface="Calibri"/>
               </a:rPr>
               <a:t>P.A. COLLEGE OF ENGINEERING
-</a:t>
-            </a:r>
-            <a:r>
-              <a:rPr sz="2000" b="1">
-                <a:solidFill>
-                  <a:srgbClr val="000000"/>
-                </a:solidFill>
-                <a:latin typeface="Calibri"/>
-              </a:rPr>
-              <a:t>DEPARTMENT OF COMPUTER SCIENCE &amp; ENGINEERING</a:t>
+DEPARTMENT OF COMPUTER SCIENCE &amp; ENGINEERING</a:t>
             </a:r>
           </a:p>
         </p:txBody>
@@ -5677,7 +5653,7 @@
           <a:bodyPr wrap="square"/>
           <a:lstStyle/>
           <a:p>
-            <a:pPr algn="ctr" indent="0" marL="0">
+            <a:pPr marL="0" indent="0" algn="ctr">
               <a:buNone/>
             </a:pPr>
             <a:r>
@@ -5712,7 +5688,7 @@
           <a:bodyPr wrap="square"/>
           <a:lstStyle/>
           <a:p>
-            <a:pPr indent="0" marL="0">
+            <a:pPr marL="0" indent="0">
               <a:lnSpc>
                 <a:spcPct val="150000"/>
               </a:lnSpc>
@@ -5729,7 +5705,7 @@
             </a:r>
           </a:p>
           <a:p>
-            <a:pPr indent="0" marL="0">
+            <a:pPr marL="0" indent="0">
               <a:lnSpc>
                 <a:spcPct val="150000"/>
               </a:lnSpc>
@@ -5746,7 +5722,7 @@
             </a:r>
           </a:p>
           <a:p>
-            <a:pPr indent="0" marL="0">
+            <a:pPr marL="0" indent="0">
               <a:lnSpc>
                 <a:spcPct val="150000"/>
               </a:lnSpc>
@@ -5763,7 +5739,7 @@
             </a:r>
           </a:p>
           <a:p>
-            <a:pPr indent="0" marL="0">
+            <a:pPr marL="0" indent="0">
               <a:lnSpc>
                 <a:spcPct val="150000"/>
               </a:lnSpc>
@@ -5790,7 +5766,7 @@
 </file>
 
 <file path=ppt/slides/slide3.xml><?xml version="1.0" encoding="utf-8"?>
-<p:sld xmlns:a="http://schemas.openxmlformats.org/drawingml/2006/main" xmlns:p="http://schemas.openxmlformats.org/presentationml/2006/main" xmlns:r="http://schemas.openxmlformats.org/officeDocument/2006/relationships">
+<p:sld xmlns:a="http://schemas.openxmlformats.org/drawingml/2006/main" xmlns:r="http://schemas.openxmlformats.org/officeDocument/2006/relationships" xmlns:p="http://schemas.openxmlformats.org/presentationml/2006/main">
   <p:cSld>
     <p:spTree>
       <p:nvGrpSpPr>
@@ -5798,10 +5774,65 @@
         <p:cNvGrpSpPr/>
         <p:nvPr/>
       </p:nvGrpSpPr>
-      <p:grpSpPr/>
+      <p:grpSpPr>
+        <a:xfrm>
+          <a:off x="0" y="0"/>
+          <a:ext cx="0" cy="0"/>
+          <a:chOff x="0" y="0"/>
+          <a:chExt cx="0" cy="0"/>
+        </a:xfrm>
+      </p:grpSpPr>
       <p:pic>
         <p:nvPicPr>
           <p:cNvPr id="7" name="Picture 6" descr="syncura-watermark.png"/>
+          <p:cNvPicPr>
+            <a:picLocks noChangeAspect="1"/>
+          </p:cNvPicPr>
+          <p:nvPr/>
+        </p:nvPicPr>
+        <p:blipFill>
+          <a:blip r:embed="rId2"/>
+          <a:stretch>
+            <a:fillRect/>
+          </a:stretch>
+        </p:blipFill>
+        <p:spPr>
+          <a:xfrm>
+            <a:off x="6675120" y="2743200"/>
+            <a:ext cx="5212080" cy="5212080"/>
+          </a:xfrm>
+          <a:prstGeom prst="rect">
+            <a:avLst/>
+          </a:prstGeom>
+        </p:spPr>
+      </p:pic>
+      <p:pic>
+        <p:nvPicPr>
+          <p:cNvPr id="2" name="Picture 1" descr="image.png"/>
+          <p:cNvPicPr>
+            <a:picLocks noChangeAspect="1"/>
+          </p:cNvPicPr>
+          <p:nvPr/>
+        </p:nvPicPr>
+        <p:blipFill>
+          <a:blip r:embed="rId3"/>
+          <a:stretch>
+            <a:fillRect/>
+          </a:stretch>
+        </p:blipFill>
+        <p:spPr>
+          <a:xfrm>
+            <a:off x="137160" y="109728"/>
+            <a:ext cx="1463040" cy="1463040"/>
+          </a:xfrm>
+          <a:prstGeom prst="rect">
+            <a:avLst/>
+          </a:prstGeom>
+        </p:spPr>
+      </p:pic>
+      <p:pic>
+        <p:nvPicPr>
+          <p:cNvPr id="3" name="Picture 2" descr="image.png"/>
           <p:cNvPicPr>
             <a:picLocks noChangeAspect="1"/>
           </p:cNvPicPr>
@@ -5815,54 +5846,6 @@
         </p:blipFill>
         <p:spPr>
           <a:xfrm>
-            <a:off x="6675120" y="2743200"/>
-            <a:ext cx="5212080" cy="5212080"/>
-          </a:xfrm>
-          <a:prstGeom prst="rect">
-            <a:avLst/>
-          </a:prstGeom>
-        </p:spPr>
-      </p:pic>
-      <p:pic>
-        <p:nvPicPr>
-          <p:cNvPr id="2" name="Picture 1" descr="image.png"/>
-          <p:cNvPicPr>
-            <a:picLocks noChangeAspect="1"/>
-          </p:cNvPicPr>
-          <p:nvPr/>
-        </p:nvPicPr>
-        <p:blipFill>
-          <a:blip r:embed="rId2"/>
-          <a:stretch>
-            <a:fillRect/>
-          </a:stretch>
-        </p:blipFill>
-        <p:spPr>
-          <a:xfrm>
-            <a:off x="137160" y="109728"/>
-            <a:ext cx="1463040" cy="1463040"/>
-          </a:xfrm>
-          <a:prstGeom prst="rect">
-            <a:avLst/>
-          </a:prstGeom>
-        </p:spPr>
-      </p:pic>
-      <p:pic>
-        <p:nvPicPr>
-          <p:cNvPr id="3" name="Picture 2" descr="image.png"/>
-          <p:cNvPicPr>
-            <a:picLocks noChangeAspect="1"/>
-          </p:cNvPicPr>
-          <p:nvPr/>
-        </p:nvPicPr>
-        <p:blipFill>
-          <a:blip r:embed="rId3"/>
-          <a:stretch>
-            <a:fillRect/>
-          </a:stretch>
-        </p:blipFill>
-        <p:spPr>
-          <a:xfrm>
             <a:off x="16687800" y="109728"/>
             <a:ext cx="1463040" cy="1463040"/>
           </a:xfrm>
@@ -5891,7 +5874,7 @@
           <a:bodyPr wrap="square"/>
           <a:lstStyle/>
           <a:p>
-            <a:pPr algn="ctr" indent="0" marL="0">
+            <a:pPr marL="0" indent="0" algn="ctr">
               <a:lnSpc>
                 <a:spcPct val="150000"/>
               </a:lnSpc>
@@ -5905,16 +5888,7 @@
                 <a:latin typeface="Calibri"/>
               </a:rPr>
               <a:t>P.A. COLLEGE OF ENGINEERING
-</a:t>
-            </a:r>
-            <a:r>
-              <a:rPr sz="2000" b="1">
-                <a:solidFill>
-                  <a:srgbClr val="000000"/>
-                </a:solidFill>
-                <a:latin typeface="Calibri"/>
-              </a:rPr>
-              <a:t>DEPARTMENT OF COMPUTER SCIENCE &amp; ENGINEERING</a:t>
+DEPARTMENT OF COMPUTER SCIENCE &amp; ENGINEERING</a:t>
             </a:r>
           </a:p>
         </p:txBody>
@@ -5939,7 +5913,7 @@
           <a:bodyPr wrap="square"/>
           <a:lstStyle/>
           <a:p>
-            <a:pPr algn="ctr" indent="0" marL="0">
+            <a:pPr marL="0" indent="0" algn="ctr">
               <a:buNone/>
             </a:pPr>
             <a:r>
@@ -5995,7 +5969,6 @@
             </a:r>
           </a:p>
           <a:p>
-            <a:pPr/>
             <a:r>
               <a:rPr sz="2400">
                 <a:solidFill>
@@ -6007,7 +5980,6 @@
             </a:r>
           </a:p>
           <a:p>
-            <a:pPr/>
             <a:r>
               <a:rPr sz="2400">
                 <a:solidFill>
@@ -6019,7 +5991,6 @@
             </a:r>
           </a:p>
           <a:p>
-            <a:pPr/>
             <a:r>
               <a:rPr sz="2400">
                 <a:solidFill>
@@ -6041,7 +6012,7 @@
 </file>
 
 <file path=ppt/slides/slide4.xml><?xml version="1.0" encoding="utf-8"?>
-<p:sld xmlns:a="http://schemas.openxmlformats.org/drawingml/2006/main" xmlns:p="http://schemas.openxmlformats.org/presentationml/2006/main" xmlns:r="http://schemas.openxmlformats.org/officeDocument/2006/relationships">
+<p:sld xmlns:a="http://schemas.openxmlformats.org/drawingml/2006/main" xmlns:r="http://schemas.openxmlformats.org/officeDocument/2006/relationships" xmlns:p="http://schemas.openxmlformats.org/presentationml/2006/main">
   <p:cSld>
     <p:spTree>
       <p:nvGrpSpPr>
@@ -6049,10 +6020,65 @@
         <p:cNvGrpSpPr/>
         <p:nvPr/>
       </p:nvGrpSpPr>
-      <p:grpSpPr/>
+      <p:grpSpPr>
+        <a:xfrm>
+          <a:off x="0" y="0"/>
+          <a:ext cx="0" cy="0"/>
+          <a:chOff x="0" y="0"/>
+          <a:chExt cx="0" cy="0"/>
+        </a:xfrm>
+      </p:grpSpPr>
       <p:pic>
         <p:nvPicPr>
           <p:cNvPr id="7" name="Picture 6" descr="syncura-watermark.png"/>
+          <p:cNvPicPr>
+            <a:picLocks noChangeAspect="1"/>
+          </p:cNvPicPr>
+          <p:nvPr/>
+        </p:nvPicPr>
+        <p:blipFill>
+          <a:blip r:embed="rId2"/>
+          <a:stretch>
+            <a:fillRect/>
+          </a:stretch>
+        </p:blipFill>
+        <p:spPr>
+          <a:xfrm>
+            <a:off x="6675120" y="2743200"/>
+            <a:ext cx="5212080" cy="5212080"/>
+          </a:xfrm>
+          <a:prstGeom prst="rect">
+            <a:avLst/>
+          </a:prstGeom>
+        </p:spPr>
+      </p:pic>
+      <p:pic>
+        <p:nvPicPr>
+          <p:cNvPr id="2" name="Picture 1" descr="image.png"/>
+          <p:cNvPicPr>
+            <a:picLocks noChangeAspect="1"/>
+          </p:cNvPicPr>
+          <p:nvPr/>
+        </p:nvPicPr>
+        <p:blipFill>
+          <a:blip r:embed="rId3"/>
+          <a:stretch>
+            <a:fillRect/>
+          </a:stretch>
+        </p:blipFill>
+        <p:spPr>
+          <a:xfrm>
+            <a:off x="137160" y="109728"/>
+            <a:ext cx="1463040" cy="1463040"/>
+          </a:xfrm>
+          <a:prstGeom prst="rect">
+            <a:avLst/>
+          </a:prstGeom>
+        </p:spPr>
+      </p:pic>
+      <p:pic>
+        <p:nvPicPr>
+          <p:cNvPr id="3" name="Picture 2" descr="image.png"/>
           <p:cNvPicPr>
             <a:picLocks noChangeAspect="1"/>
           </p:cNvPicPr>
@@ -6066,54 +6092,6 @@
         </p:blipFill>
         <p:spPr>
           <a:xfrm>
-            <a:off x="6675120" y="2743200"/>
-            <a:ext cx="5212080" cy="5212080"/>
-          </a:xfrm>
-          <a:prstGeom prst="rect">
-            <a:avLst/>
-          </a:prstGeom>
-        </p:spPr>
-      </p:pic>
-      <p:pic>
-        <p:nvPicPr>
-          <p:cNvPr id="2" name="Picture 1" descr="image.png"/>
-          <p:cNvPicPr>
-            <a:picLocks noChangeAspect="1"/>
-          </p:cNvPicPr>
-          <p:nvPr/>
-        </p:nvPicPr>
-        <p:blipFill>
-          <a:blip r:embed="rId2"/>
-          <a:stretch>
-            <a:fillRect/>
-          </a:stretch>
-        </p:blipFill>
-        <p:spPr>
-          <a:xfrm>
-            <a:off x="137160" y="109728"/>
-            <a:ext cx="1463040" cy="1463040"/>
-          </a:xfrm>
-          <a:prstGeom prst="rect">
-            <a:avLst/>
-          </a:prstGeom>
-        </p:spPr>
-      </p:pic>
-      <p:pic>
-        <p:nvPicPr>
-          <p:cNvPr id="3" name="Picture 2" descr="image.png"/>
-          <p:cNvPicPr>
-            <a:picLocks noChangeAspect="1"/>
-          </p:cNvPicPr>
-          <p:nvPr/>
-        </p:nvPicPr>
-        <p:blipFill>
-          <a:blip r:embed="rId3"/>
-          <a:stretch>
-            <a:fillRect/>
-          </a:stretch>
-        </p:blipFill>
-        <p:spPr>
-          <a:xfrm>
             <a:off x="16687800" y="109728"/>
             <a:ext cx="1463040" cy="1463040"/>
           </a:xfrm>
@@ -6142,7 +6120,7 @@
           <a:bodyPr wrap="square"/>
           <a:lstStyle/>
           <a:p>
-            <a:pPr algn="ctr" indent="0" marL="0">
+            <a:pPr marL="0" indent="0" algn="ctr">
               <a:lnSpc>
                 <a:spcPct val="150000"/>
               </a:lnSpc>
@@ -6156,16 +6134,7 @@
                 <a:latin typeface="Calibri"/>
               </a:rPr>
               <a:t>P.A. COLLEGE OF ENGINEERING
-</a:t>
-            </a:r>
-            <a:r>
-              <a:rPr sz="2000" b="1">
-                <a:solidFill>
-                  <a:srgbClr val="000000"/>
-                </a:solidFill>
-                <a:latin typeface="Calibri"/>
-              </a:rPr>
-              <a:t>DEPARTMENT OF COMPUTER SCIENCE &amp; ENGINEERING</a:t>
+DEPARTMENT OF COMPUTER SCIENCE &amp; ENGINEERING</a:t>
             </a:r>
           </a:p>
         </p:txBody>
@@ -6190,7 +6159,7 @@
           <a:bodyPr wrap="square"/>
           <a:lstStyle/>
           <a:p>
-            <a:pPr algn="ctr" indent="0" marL="0">
+            <a:pPr marL="0" indent="0" algn="ctr">
               <a:buNone/>
             </a:pPr>
             <a:r>
@@ -6317,7 +6286,7 @@
 </file>
 
 <file path=ppt/slides/slide5.xml><?xml version="1.0" encoding="utf-8"?>
-<p:sld xmlns:a="http://schemas.openxmlformats.org/drawingml/2006/main" xmlns:p="http://schemas.openxmlformats.org/presentationml/2006/main" xmlns:r="http://schemas.openxmlformats.org/officeDocument/2006/relationships">
+<p:sld xmlns:a="http://schemas.openxmlformats.org/drawingml/2006/main" xmlns:r="http://schemas.openxmlformats.org/officeDocument/2006/relationships" xmlns:p="http://schemas.openxmlformats.org/presentationml/2006/main">
   <p:cSld>
     <p:spTree>
       <p:nvGrpSpPr>
@@ -6325,10 +6294,65 @@
         <p:cNvGrpSpPr/>
         <p:nvPr/>
       </p:nvGrpSpPr>
-      <p:grpSpPr/>
+      <p:grpSpPr>
+        <a:xfrm>
+          <a:off x="0" y="0"/>
+          <a:ext cx="0" cy="0"/>
+          <a:chOff x="0" y="0"/>
+          <a:chExt cx="0" cy="0"/>
+        </a:xfrm>
+      </p:grpSpPr>
       <p:pic>
         <p:nvPicPr>
           <p:cNvPr id="7" name="Picture 6" descr="syncura-watermark.png"/>
+          <p:cNvPicPr>
+            <a:picLocks noChangeAspect="1"/>
+          </p:cNvPicPr>
+          <p:nvPr/>
+        </p:nvPicPr>
+        <p:blipFill>
+          <a:blip r:embed="rId2"/>
+          <a:stretch>
+            <a:fillRect/>
+          </a:stretch>
+        </p:blipFill>
+        <p:spPr>
+          <a:xfrm>
+            <a:off x="6675120" y="2743200"/>
+            <a:ext cx="5212080" cy="5212080"/>
+          </a:xfrm>
+          <a:prstGeom prst="rect">
+            <a:avLst/>
+          </a:prstGeom>
+        </p:spPr>
+      </p:pic>
+      <p:pic>
+        <p:nvPicPr>
+          <p:cNvPr id="2" name="Picture 1" descr="image.png"/>
+          <p:cNvPicPr>
+            <a:picLocks noChangeAspect="1"/>
+          </p:cNvPicPr>
+          <p:nvPr/>
+        </p:nvPicPr>
+        <p:blipFill>
+          <a:blip r:embed="rId3"/>
+          <a:stretch>
+            <a:fillRect/>
+          </a:stretch>
+        </p:blipFill>
+        <p:spPr>
+          <a:xfrm>
+            <a:off x="137160" y="109728"/>
+            <a:ext cx="1463040" cy="1463040"/>
+          </a:xfrm>
+          <a:prstGeom prst="rect">
+            <a:avLst/>
+          </a:prstGeom>
+        </p:spPr>
+      </p:pic>
+      <p:pic>
+        <p:nvPicPr>
+          <p:cNvPr id="3" name="Picture 2" descr="image.png"/>
           <p:cNvPicPr>
             <a:picLocks noChangeAspect="1"/>
           </p:cNvPicPr>
@@ -6342,54 +6366,6 @@
         </p:blipFill>
         <p:spPr>
           <a:xfrm>
-            <a:off x="6675120" y="2743200"/>
-            <a:ext cx="5212080" cy="5212080"/>
-          </a:xfrm>
-          <a:prstGeom prst="rect">
-            <a:avLst/>
-          </a:prstGeom>
-        </p:spPr>
-      </p:pic>
-      <p:pic>
-        <p:nvPicPr>
-          <p:cNvPr id="2" name="Picture 1" descr="image.png"/>
-          <p:cNvPicPr>
-            <a:picLocks noChangeAspect="1"/>
-          </p:cNvPicPr>
-          <p:nvPr/>
-        </p:nvPicPr>
-        <p:blipFill>
-          <a:blip r:embed="rId2"/>
-          <a:stretch>
-            <a:fillRect/>
-          </a:stretch>
-        </p:blipFill>
-        <p:spPr>
-          <a:xfrm>
-            <a:off x="137160" y="109728"/>
-            <a:ext cx="1463040" cy="1463040"/>
-          </a:xfrm>
-          <a:prstGeom prst="rect">
-            <a:avLst/>
-          </a:prstGeom>
-        </p:spPr>
-      </p:pic>
-      <p:pic>
-        <p:nvPicPr>
-          <p:cNvPr id="3" name="Picture 2" descr="image.png"/>
-          <p:cNvPicPr>
-            <a:picLocks noChangeAspect="1"/>
-          </p:cNvPicPr>
-          <p:nvPr/>
-        </p:nvPicPr>
-        <p:blipFill>
-          <a:blip r:embed="rId3"/>
-          <a:stretch>
-            <a:fillRect/>
-          </a:stretch>
-        </p:blipFill>
-        <p:spPr>
-          <a:xfrm>
             <a:off x="16687800" y="109728"/>
             <a:ext cx="1463040" cy="1463040"/>
           </a:xfrm>
@@ -6418,7 +6394,7 @@
           <a:bodyPr wrap="square"/>
           <a:lstStyle/>
           <a:p>
-            <a:pPr algn="ctr" indent="0" marL="0">
+            <a:pPr marL="0" indent="0" algn="ctr">
               <a:lnSpc>
                 <a:spcPct val="150000"/>
               </a:lnSpc>
@@ -6432,16 +6408,7 @@
                 <a:latin typeface="Calibri"/>
               </a:rPr>
               <a:t>P.A. COLLEGE OF ENGINEERING
-</a:t>
-            </a:r>
-            <a:r>
-              <a:rPr sz="2000" b="1">
-                <a:solidFill>
-                  <a:srgbClr val="000000"/>
-                </a:solidFill>
-                <a:latin typeface="Calibri"/>
-              </a:rPr>
-              <a:t>DEPARTMENT OF COMPUTER SCIENCE &amp; ENGINEERING</a:t>
+DEPARTMENT OF COMPUTER SCIENCE &amp; ENGINEERING</a:t>
             </a:r>
           </a:p>
         </p:txBody>
@@ -6466,7 +6433,7 @@
           <a:bodyPr wrap="square"/>
           <a:lstStyle/>
           <a:p>
-            <a:pPr algn="ctr" indent="0" marL="0">
+            <a:pPr marL="0" indent="0" algn="ctr">
               <a:buNone/>
             </a:pPr>
             <a:r>
@@ -6569,7 +6536,7 @@
 </file>
 
 <file path=ppt/slides/slide6.xml><?xml version="1.0" encoding="utf-8"?>
-<p:sld xmlns:a="http://schemas.openxmlformats.org/drawingml/2006/main" xmlns:p="http://schemas.openxmlformats.org/presentationml/2006/main" xmlns:r="http://schemas.openxmlformats.org/officeDocument/2006/relationships">
+<p:sld xmlns:a="http://schemas.openxmlformats.org/drawingml/2006/main" xmlns:r="http://schemas.openxmlformats.org/officeDocument/2006/relationships" xmlns:p="http://schemas.openxmlformats.org/presentationml/2006/main">
   <p:cSld>
     <p:spTree>
       <p:nvGrpSpPr>
@@ -6577,7 +6544,14 @@
         <p:cNvGrpSpPr/>
         <p:nvPr/>
       </p:nvGrpSpPr>
-      <p:grpSpPr/>
+      <p:grpSpPr>
+        <a:xfrm>
+          <a:off x="0" y="0"/>
+          <a:ext cx="0" cy="0"/>
+          <a:chOff x="0" y="0"/>
+          <a:chExt cx="0" cy="0"/>
+        </a:xfrm>
+      </p:grpSpPr>
       <p:pic>
         <p:nvPicPr>
           <p:cNvPr id="8" name="Picture 7" descr="syncura-watermark.png"/>
@@ -6587,7 +6561,7 @@
           <p:nvPr/>
         </p:nvPicPr>
         <p:blipFill>
-          <a:blip r:embed="rId5"/>
+          <a:blip r:embed="rId2"/>
           <a:stretch>
             <a:fillRect/>
           </a:stretch>
@@ -6611,7 +6585,7 @@
           <p:nvPr/>
         </p:nvPicPr>
         <p:blipFill>
-          <a:blip r:embed="rId2"/>
+          <a:blip r:embed="rId3"/>
           <a:stretch>
             <a:fillRect/>
           </a:stretch>
@@ -6635,7 +6609,7 @@
           <p:nvPr/>
         </p:nvPicPr>
         <p:blipFill>
-          <a:blip r:embed="rId3"/>
+          <a:blip r:embed="rId4"/>
           <a:stretch>
             <a:fillRect/>
           </a:stretch>
@@ -6670,7 +6644,7 @@
           <a:bodyPr wrap="square"/>
           <a:lstStyle/>
           <a:p>
-            <a:pPr algn="ctr" indent="0" marL="0">
+            <a:pPr marL="0" indent="0" algn="ctr">
               <a:lnSpc>
                 <a:spcPct val="150000"/>
               </a:lnSpc>
@@ -6684,16 +6658,7 @@
                 <a:latin typeface="Calibri"/>
               </a:rPr>
               <a:t>P.A. COLLEGE OF ENGINEERING
-</a:t>
-            </a:r>
-            <a:r>
-              <a:rPr sz="2000" b="1">
-                <a:solidFill>
-                  <a:srgbClr val="000000"/>
-                </a:solidFill>
-                <a:latin typeface="Calibri"/>
-              </a:rPr>
-              <a:t>DEPARTMENT OF COMPUTER SCIENCE &amp; ENGINEERING</a:t>
+DEPARTMENT OF COMPUTER SCIENCE &amp; ENGINEERING</a:t>
             </a:r>
           </a:p>
         </p:txBody>
@@ -6718,7 +6683,7 @@
           <a:bodyPr wrap="square"/>
           <a:lstStyle/>
           <a:p>
-            <a:pPr algn="ctr" indent="0" marL="0">
+            <a:pPr marL="0" indent="0" algn="ctr">
               <a:buNone/>
             </a:pPr>
             <a:r>
@@ -6835,7 +6800,7 @@
           <p:nvPr/>
         </p:nvPicPr>
         <p:blipFill>
-          <a:blip r:embed="rId4"/>
+          <a:blip r:embed="rId5"/>
           <a:stretch>
             <a:fillRect/>
           </a:stretch>
@@ -6859,7 +6824,7 @@
 </file>
 
 <file path=ppt/slides/slide7.xml><?xml version="1.0" encoding="utf-8"?>
-<p:sld xmlns:a="http://schemas.openxmlformats.org/drawingml/2006/main" xmlns:p="http://schemas.openxmlformats.org/presentationml/2006/main" xmlns:r="http://schemas.openxmlformats.org/officeDocument/2006/relationships">
+<p:sld xmlns:a="http://schemas.openxmlformats.org/drawingml/2006/main" xmlns:r="http://schemas.openxmlformats.org/officeDocument/2006/relationships" xmlns:p="http://schemas.openxmlformats.org/presentationml/2006/main">
   <p:cSld>
     <p:spTree>
       <p:nvGrpSpPr>
@@ -6867,10 +6832,65 @@
         <p:cNvGrpSpPr/>
         <p:nvPr/>
       </p:nvGrpSpPr>
-      <p:grpSpPr/>
+      <p:grpSpPr>
+        <a:xfrm>
+          <a:off x="0" y="0"/>
+          <a:ext cx="0" cy="0"/>
+          <a:chOff x="0" y="0"/>
+          <a:chExt cx="0" cy="0"/>
+        </a:xfrm>
+      </p:grpSpPr>
       <p:pic>
         <p:nvPicPr>
           <p:cNvPr id="16" name="Picture 15" descr="syncura-watermark.png"/>
+          <p:cNvPicPr>
+            <a:picLocks noChangeAspect="1"/>
+          </p:cNvPicPr>
+          <p:nvPr/>
+        </p:nvPicPr>
+        <p:blipFill>
+          <a:blip r:embed="rId2"/>
+          <a:stretch>
+            <a:fillRect/>
+          </a:stretch>
+        </p:blipFill>
+        <p:spPr>
+          <a:xfrm>
+            <a:off x="6675120" y="2743200"/>
+            <a:ext cx="5212080" cy="5212080"/>
+          </a:xfrm>
+          <a:prstGeom prst="rect">
+            <a:avLst/>
+          </a:prstGeom>
+        </p:spPr>
+      </p:pic>
+      <p:pic>
+        <p:nvPicPr>
+          <p:cNvPr id="2" name="Picture 1" descr="image.png"/>
+          <p:cNvPicPr>
+            <a:picLocks noChangeAspect="1"/>
+          </p:cNvPicPr>
+          <p:nvPr/>
+        </p:nvPicPr>
+        <p:blipFill>
+          <a:blip r:embed="rId3"/>
+          <a:stretch>
+            <a:fillRect/>
+          </a:stretch>
+        </p:blipFill>
+        <p:spPr>
+          <a:xfrm>
+            <a:off x="137160" y="109728"/>
+            <a:ext cx="1463040" cy="1463040"/>
+          </a:xfrm>
+          <a:prstGeom prst="rect">
+            <a:avLst/>
+          </a:prstGeom>
+        </p:spPr>
+      </p:pic>
+      <p:pic>
+        <p:nvPicPr>
+          <p:cNvPr id="3" name="Picture 2" descr="image.png"/>
           <p:cNvPicPr>
             <a:picLocks noChangeAspect="1"/>
           </p:cNvPicPr>
@@ -6884,54 +6904,6 @@
         </p:blipFill>
         <p:spPr>
           <a:xfrm>
-            <a:off x="6675120" y="2743200"/>
-            <a:ext cx="5212080" cy="5212080"/>
-          </a:xfrm>
-          <a:prstGeom prst="rect">
-            <a:avLst/>
-          </a:prstGeom>
-        </p:spPr>
-      </p:pic>
-      <p:pic>
-        <p:nvPicPr>
-          <p:cNvPr id="2" name="Picture 1" descr="image.png"/>
-          <p:cNvPicPr>
-            <a:picLocks noChangeAspect="1"/>
-          </p:cNvPicPr>
-          <p:nvPr/>
-        </p:nvPicPr>
-        <p:blipFill>
-          <a:blip r:embed="rId2"/>
-          <a:stretch>
-            <a:fillRect/>
-          </a:stretch>
-        </p:blipFill>
-        <p:spPr>
-          <a:xfrm>
-            <a:off x="137160" y="109728"/>
-            <a:ext cx="1463040" cy="1463040"/>
-          </a:xfrm>
-          <a:prstGeom prst="rect">
-            <a:avLst/>
-          </a:prstGeom>
-        </p:spPr>
-      </p:pic>
-      <p:pic>
-        <p:nvPicPr>
-          <p:cNvPr id="3" name="Picture 2" descr="image.png"/>
-          <p:cNvPicPr>
-            <a:picLocks noChangeAspect="1"/>
-          </p:cNvPicPr>
-          <p:nvPr/>
-        </p:nvPicPr>
-        <p:blipFill>
-          <a:blip r:embed="rId3"/>
-          <a:stretch>
-            <a:fillRect/>
-          </a:stretch>
-        </p:blipFill>
-        <p:spPr>
-          <a:xfrm>
             <a:off x="16687800" y="109728"/>
             <a:ext cx="1463040" cy="1463040"/>
           </a:xfrm>
@@ -6960,7 +6932,7 @@
           <a:bodyPr wrap="square"/>
           <a:lstStyle/>
           <a:p>
-            <a:pPr algn="ctr" indent="0" marL="0">
+            <a:pPr marL="0" indent="0" algn="ctr">
               <a:lnSpc>
                 <a:spcPct val="150000"/>
               </a:lnSpc>
@@ -6974,16 +6946,7 @@
                 <a:latin typeface="Calibri"/>
               </a:rPr>
               <a:t>P.A. COLLEGE OF ENGINEERING
-</a:t>
-            </a:r>
-            <a:r>
-              <a:rPr sz="2000" b="1">
-                <a:solidFill>
-                  <a:srgbClr val="000000"/>
-                </a:solidFill>
-                <a:latin typeface="Calibri"/>
-              </a:rPr>
-              <a:t>DEPARTMENT OF COMPUTER SCIENCE &amp; ENGINEERING</a:t>
+DEPARTMENT OF COMPUTER SCIENCE &amp; ENGINEERING</a:t>
             </a:r>
           </a:p>
         </p:txBody>
@@ -7008,7 +6971,7 @@
           <a:bodyPr wrap="square"/>
           <a:lstStyle/>
           <a:p>
-            <a:pPr algn="ctr" indent="0" marL="0">
+            <a:pPr marL="0" indent="0" algn="ctr">
               <a:buNone/>
             </a:pPr>
             <a:r>
@@ -7061,7 +7024,7 @@
           </a:fontRef>
         </p:style>
         <p:txBody>
-          <a:bodyPr rtlCol="0" anchor="ctr" wrap="square"/>
+          <a:bodyPr wrap="square" rtlCol="0" anchor="ctr"/>
           <a:lstStyle/>
           <a:p>
             <a:pPr algn="ctr"/>
@@ -7134,6 +7097,7 @@
           <a:lstStyle/>
           <a:p>
             <a:pPr algn="ctr"/>
+            <a:endParaRPr/>
           </a:p>
         </p:txBody>
       </p:sp>
@@ -7175,7 +7139,7 @@
           </a:fontRef>
         </p:style>
         <p:txBody>
-          <a:bodyPr rtlCol="0" anchor="ctr" wrap="square"/>
+          <a:bodyPr wrap="square" rtlCol="0" anchor="ctr"/>
           <a:lstStyle/>
           <a:p>
             <a:pPr algn="ctr"/>
@@ -7248,6 +7212,7 @@
           <a:lstStyle/>
           <a:p>
             <a:pPr algn="ctr"/>
+            <a:endParaRPr/>
           </a:p>
         </p:txBody>
       </p:sp>
@@ -7289,7 +7254,7 @@
           </a:fontRef>
         </p:style>
         <p:txBody>
-          <a:bodyPr rtlCol="0" anchor="ctr" wrap="square"/>
+          <a:bodyPr wrap="square" rtlCol="0" anchor="ctr"/>
           <a:lstStyle/>
           <a:p>
             <a:pPr algn="ctr"/>
@@ -7362,6 +7327,7 @@
           <a:lstStyle/>
           <a:p>
             <a:pPr algn="ctr"/>
+            <a:endParaRPr/>
           </a:p>
         </p:txBody>
       </p:sp>
@@ -7403,7 +7369,7 @@
           </a:fontRef>
         </p:style>
         <p:txBody>
-          <a:bodyPr rtlCol="0" anchor="ctr" wrap="square"/>
+          <a:bodyPr wrap="square" rtlCol="0" anchor="ctr"/>
           <a:lstStyle/>
           <a:p>
             <a:pPr algn="ctr"/>
@@ -7476,6 +7442,7 @@
           <a:lstStyle/>
           <a:p>
             <a:pPr algn="ctr"/>
+            <a:endParaRPr/>
           </a:p>
         </p:txBody>
       </p:sp>
@@ -7517,7 +7484,7 @@
           </a:fontRef>
         </p:style>
         <p:txBody>
-          <a:bodyPr rtlCol="0" anchor="ctr" wrap="square"/>
+          <a:bodyPr wrap="square" rtlCol="0" anchor="ctr"/>
           <a:lstStyle/>
           <a:p>
             <a:pPr algn="ctr"/>
@@ -7594,7 +7561,7 @@
 </file>
 
 <file path=ppt/slides/slide8.xml><?xml version="1.0" encoding="utf-8"?>
-<p:sld xmlns:a="http://schemas.openxmlformats.org/drawingml/2006/main" xmlns:p="http://schemas.openxmlformats.org/presentationml/2006/main" xmlns:r="http://schemas.openxmlformats.org/officeDocument/2006/relationships">
+<p:sld xmlns:a="http://schemas.openxmlformats.org/drawingml/2006/main" xmlns:r="http://schemas.openxmlformats.org/officeDocument/2006/relationships" xmlns:p="http://schemas.openxmlformats.org/presentationml/2006/main">
   <p:cSld>
     <p:spTree>
       <p:nvGrpSpPr>
@@ -7602,10 +7569,65 @@
         <p:cNvGrpSpPr/>
         <p:nvPr/>
       </p:nvGrpSpPr>
-      <p:grpSpPr/>
+      <p:grpSpPr>
+        <a:xfrm>
+          <a:off x="0" y="0"/>
+          <a:ext cx="0" cy="0"/>
+          <a:chOff x="0" y="0"/>
+          <a:chExt cx="0" cy="0"/>
+        </a:xfrm>
+      </p:grpSpPr>
       <p:pic>
         <p:nvPicPr>
           <p:cNvPr id="7" name="Picture 6" descr="syncura-watermark.png"/>
+          <p:cNvPicPr>
+            <a:picLocks noChangeAspect="1"/>
+          </p:cNvPicPr>
+          <p:nvPr/>
+        </p:nvPicPr>
+        <p:blipFill>
+          <a:blip r:embed="rId2"/>
+          <a:stretch>
+            <a:fillRect/>
+          </a:stretch>
+        </p:blipFill>
+        <p:spPr>
+          <a:xfrm>
+            <a:off x="6675120" y="2743200"/>
+            <a:ext cx="5212080" cy="5212080"/>
+          </a:xfrm>
+          <a:prstGeom prst="rect">
+            <a:avLst/>
+          </a:prstGeom>
+        </p:spPr>
+      </p:pic>
+      <p:pic>
+        <p:nvPicPr>
+          <p:cNvPr id="2" name="Picture 1" descr="image.png"/>
+          <p:cNvPicPr>
+            <a:picLocks noChangeAspect="1"/>
+          </p:cNvPicPr>
+          <p:nvPr/>
+        </p:nvPicPr>
+        <p:blipFill>
+          <a:blip r:embed="rId3"/>
+          <a:stretch>
+            <a:fillRect/>
+          </a:stretch>
+        </p:blipFill>
+        <p:spPr>
+          <a:xfrm>
+            <a:off x="137160" y="109728"/>
+            <a:ext cx="1463040" cy="1463040"/>
+          </a:xfrm>
+          <a:prstGeom prst="rect">
+            <a:avLst/>
+          </a:prstGeom>
+        </p:spPr>
+      </p:pic>
+      <p:pic>
+        <p:nvPicPr>
+          <p:cNvPr id="3" name="Picture 2" descr="image.png"/>
           <p:cNvPicPr>
             <a:picLocks noChangeAspect="1"/>
           </p:cNvPicPr>
@@ -7619,54 +7641,6 @@
         </p:blipFill>
         <p:spPr>
           <a:xfrm>
-            <a:off x="6675120" y="2743200"/>
-            <a:ext cx="5212080" cy="5212080"/>
-          </a:xfrm>
-          <a:prstGeom prst="rect">
-            <a:avLst/>
-          </a:prstGeom>
-        </p:spPr>
-      </p:pic>
-      <p:pic>
-        <p:nvPicPr>
-          <p:cNvPr id="2" name="Picture 1" descr="image.png"/>
-          <p:cNvPicPr>
-            <a:picLocks noChangeAspect="1"/>
-          </p:cNvPicPr>
-          <p:nvPr/>
-        </p:nvPicPr>
-        <p:blipFill>
-          <a:blip r:embed="rId2"/>
-          <a:stretch>
-            <a:fillRect/>
-          </a:stretch>
-        </p:blipFill>
-        <p:spPr>
-          <a:xfrm>
-            <a:off x="137160" y="109728"/>
-            <a:ext cx="1463040" cy="1463040"/>
-          </a:xfrm>
-          <a:prstGeom prst="rect">
-            <a:avLst/>
-          </a:prstGeom>
-        </p:spPr>
-      </p:pic>
-      <p:pic>
-        <p:nvPicPr>
-          <p:cNvPr id="3" name="Picture 2" descr="image.png"/>
-          <p:cNvPicPr>
-            <a:picLocks noChangeAspect="1"/>
-          </p:cNvPicPr>
-          <p:nvPr/>
-        </p:nvPicPr>
-        <p:blipFill>
-          <a:blip r:embed="rId3"/>
-          <a:stretch>
-            <a:fillRect/>
-          </a:stretch>
-        </p:blipFill>
-        <p:spPr>
-          <a:xfrm>
             <a:off x="16687800" y="109728"/>
             <a:ext cx="1463040" cy="1463040"/>
           </a:xfrm>
@@ -7695,7 +7669,7 @@
           <a:bodyPr wrap="square"/>
           <a:lstStyle/>
           <a:p>
-            <a:pPr algn="ctr" indent="0" marL="0">
+            <a:pPr marL="0" indent="0" algn="ctr">
               <a:lnSpc>
                 <a:spcPct val="150000"/>
               </a:lnSpc>
@@ -7709,16 +7683,7 @@
                 <a:latin typeface="Calibri"/>
               </a:rPr>
               <a:t>P.A. COLLEGE OF ENGINEERING
-</a:t>
-            </a:r>
-            <a:r>
-              <a:rPr sz="2000" b="1">
-                <a:solidFill>
-                  <a:srgbClr val="000000"/>
-                </a:solidFill>
-                <a:latin typeface="Calibri"/>
-              </a:rPr>
-              <a:t>DEPARTMENT OF COMPUTER SCIENCE &amp; ENGINEERING</a:t>
+DEPARTMENT OF COMPUTER SCIENCE &amp; ENGINEERING</a:t>
             </a:r>
           </a:p>
         </p:txBody>
@@ -7743,7 +7708,7 @@
           <a:bodyPr wrap="square"/>
           <a:lstStyle/>
           <a:p>
-            <a:pPr algn="ctr" indent="0" marL="0">
+            <a:pPr marL="0" indent="0" algn="ctr">
               <a:buNone/>
             </a:pPr>
             <a:r>
@@ -7877,7 +7842,7 @@
 </file>
 
 <file path=ppt/slides/slide9.xml><?xml version="1.0" encoding="utf-8"?>
-<p:sld xmlns:a="http://schemas.openxmlformats.org/drawingml/2006/main" xmlns:p="http://schemas.openxmlformats.org/presentationml/2006/main" xmlns:r="http://schemas.openxmlformats.org/officeDocument/2006/relationships">
+<p:sld xmlns:a="http://schemas.openxmlformats.org/drawingml/2006/main" xmlns:r="http://schemas.openxmlformats.org/officeDocument/2006/relationships" xmlns:p="http://schemas.openxmlformats.org/presentationml/2006/main">
   <p:cSld>
     <p:spTree>
       <p:nvGrpSpPr>
@@ -7885,7 +7850,14 @@
         <p:cNvGrpSpPr/>
         <p:nvPr/>
       </p:nvGrpSpPr>
-      <p:grpSpPr/>
+      <p:grpSpPr>
+        <a:xfrm>
+          <a:off x="0" y="0"/>
+          <a:ext cx="0" cy="0"/>
+          <a:chOff x="0" y="0"/>
+          <a:chExt cx="0" cy="0"/>
+        </a:xfrm>
+      </p:grpSpPr>
       <p:pic>
         <p:nvPicPr>
           <p:cNvPr id="10" name="Picture 9" descr="syncura-watermark.png"/>
@@ -7895,7 +7867,7 @@
           <p:nvPr/>
         </p:nvPicPr>
         <p:blipFill>
-          <a:blip r:embed="rId7"/>
+          <a:blip r:embed="rId2"/>
           <a:stretch>
             <a:fillRect/>
           </a:stretch>
@@ -7919,7 +7891,7 @@
           <p:nvPr/>
         </p:nvPicPr>
         <p:blipFill>
-          <a:blip r:embed="rId2"/>
+          <a:blip r:embed="rId3"/>
           <a:stretch>
             <a:fillRect/>
           </a:stretch>
@@ -7943,7 +7915,7 @@
           <p:nvPr/>
         </p:nvPicPr>
         <p:blipFill>
-          <a:blip r:embed="rId3"/>
+          <a:blip r:embed="rId4"/>
           <a:stretch>
             <a:fillRect/>
           </a:stretch>
@@ -7978,7 +7950,7 @@
           <a:bodyPr wrap="square"/>
           <a:lstStyle/>
           <a:p>
-            <a:pPr algn="ctr" indent="0" marL="0">
+            <a:pPr marL="0" indent="0" algn="ctr">
               <a:lnSpc>
                 <a:spcPct val="150000"/>
               </a:lnSpc>
@@ -7992,16 +7964,7 @@
                 <a:latin typeface="Calibri"/>
               </a:rPr>
               <a:t>P.A. COLLEGE OF ENGINEERING
-</a:t>
-            </a:r>
-            <a:r>
-              <a:rPr sz="2000" b="1">
-                <a:solidFill>
-                  <a:srgbClr val="000000"/>
-                </a:solidFill>
-                <a:latin typeface="Calibri"/>
-              </a:rPr>
-              <a:t>DEPARTMENT OF COMPUTER SCIENCE &amp; ENGINEERING</a:t>
+DEPARTMENT OF COMPUTER SCIENCE &amp; ENGINEERING</a:t>
             </a:r>
           </a:p>
         </p:txBody>
@@ -8026,7 +7989,7 @@
           <a:bodyPr wrap="square"/>
           <a:lstStyle/>
           <a:p>
-            <a:pPr algn="ctr" indent="0" marL="0">
+            <a:pPr marL="0" indent="0" algn="ctr">
               <a:buNone/>
             </a:pPr>
             <a:r>

</xml_diff>

<commit_message>
match slide headers for projection
</commit_message>
<xml_diff>
--- a/ppt/SynCura_Deck_V3_FINAL.pptx
+++ b/ppt/SynCura_Deck_V3_FINAL.pptx
@@ -3474,7 +3474,7 @@
         </p:nvSpPr>
         <p:spPr>
           <a:xfrm>
-            <a:off x="4073652" y="886054"/>
+            <a:off x="2743200" y="0"/>
             <a:ext cx="12801600" cy="1234440"/>
           </a:xfrm>
           <a:prstGeom prst="rect">
@@ -3483,24 +3483,28 @@
           <a:noFill/>
         </p:spPr>
         <p:txBody>
-          <a:bodyPr wrap="square"/>
-          <a:lstStyle/>
-          <a:p>
-            <a:pPr marL="0" indent="0" algn="ctr">
-              <a:lnSpc>
-                <a:spcPct val="150000"/>
-              </a:lnSpc>
-              <a:buNone/>
-            </a:pPr>
-            <a:r>
-              <a:rPr sz="2000" b="1">
+          <a:bodyPr wrap="none" anchor="t"/>
+          <a:lstStyle/>
+          <a:p>
+            <a:pPr algn="ctr"/>
+            <a:r>
+              <a:rPr sz="3600" b="1">
                 <a:solidFill>
                   <a:srgbClr val="000000"/>
                 </a:solidFill>
                 <a:latin typeface="Calibri"/>
               </a:rPr>
-              <a:t>P.A. COLLEGE OF ENGINEERING
-DEPARTMENT OF COMPUTER SCIENCE &amp; ENGINEERING</a:t>
+              <a:t>P.A. COLLEGE OF ENGINEERING</a:t>
+            </a:r>
+            <a:br/>
+            <a:r>
+              <a:rPr sz="3600" b="1">
+                <a:solidFill>
+                  <a:srgbClr val="000000"/>
+                </a:solidFill>
+                <a:latin typeface="Calibri"/>
+              </a:rPr>
+              <a:t>DEPARTMENT OF COMPUTER SCIENCE &amp; ENGINEERING</a:t>
             </a:r>
           </a:p>
         </p:txBody>
@@ -3738,7 +3742,7 @@
         </p:nvSpPr>
         <p:spPr>
           <a:xfrm>
-            <a:off x="4073652" y="886054"/>
+            <a:off x="2743200" y="0"/>
             <a:ext cx="12801600" cy="1234440"/>
           </a:xfrm>
           <a:prstGeom prst="rect">
@@ -3747,24 +3751,28 @@
           <a:noFill/>
         </p:spPr>
         <p:txBody>
-          <a:bodyPr wrap="square"/>
-          <a:lstStyle/>
-          <a:p>
-            <a:pPr marL="0" indent="0" algn="ctr">
-              <a:lnSpc>
-                <a:spcPct val="150000"/>
-              </a:lnSpc>
-              <a:buNone/>
-            </a:pPr>
-            <a:r>
-              <a:rPr sz="2000" b="1">
+          <a:bodyPr wrap="none" anchor="t"/>
+          <a:lstStyle/>
+          <a:p>
+            <a:pPr algn="ctr"/>
+            <a:r>
+              <a:rPr sz="3600" b="1">
                 <a:solidFill>
                   <a:srgbClr val="000000"/>
                 </a:solidFill>
                 <a:latin typeface="Calibri"/>
               </a:rPr>
-              <a:t>P.A. COLLEGE OF ENGINEERING
-DEPARTMENT OF COMPUTER SCIENCE &amp; ENGINEERING</a:t>
+              <a:t>P.A. COLLEGE OF ENGINEERING</a:t>
+            </a:r>
+            <a:br/>
+            <a:r>
+              <a:rPr sz="3600" b="1">
+                <a:solidFill>
+                  <a:srgbClr val="000000"/>
+                </a:solidFill>
+                <a:latin typeface="Calibri"/>
+              </a:rPr>
+              <a:t>DEPARTMENT OF COMPUTER SCIENCE &amp; ENGINEERING</a:t>
             </a:r>
           </a:p>
         </p:txBody>
@@ -4384,7 +4392,7 @@
         </p:nvSpPr>
         <p:spPr>
           <a:xfrm>
-            <a:off x="4073652" y="886054"/>
+            <a:off x="2743200" y="0"/>
             <a:ext cx="12801600" cy="1234440"/>
           </a:xfrm>
           <a:prstGeom prst="rect">
@@ -4393,24 +4401,28 @@
           <a:noFill/>
         </p:spPr>
         <p:txBody>
-          <a:bodyPr wrap="square"/>
-          <a:lstStyle/>
-          <a:p>
-            <a:pPr marL="0" indent="0" algn="ctr">
-              <a:lnSpc>
-                <a:spcPct val="150000"/>
-              </a:lnSpc>
-              <a:buNone/>
-            </a:pPr>
-            <a:r>
-              <a:rPr sz="2000" b="1">
+          <a:bodyPr wrap="none" anchor="t"/>
+          <a:lstStyle/>
+          <a:p>
+            <a:pPr algn="ctr"/>
+            <a:r>
+              <a:rPr sz="3600" b="1">
                 <a:solidFill>
                   <a:srgbClr val="000000"/>
                 </a:solidFill>
                 <a:latin typeface="Calibri"/>
               </a:rPr>
-              <a:t>P.A. COLLEGE OF ENGINEERING
-DEPARTMENT OF COMPUTER SCIENCE &amp; ENGINEERING</a:t>
+              <a:t>P.A. COLLEGE OF ENGINEERING</a:t>
+            </a:r>
+            <a:br/>
+            <a:r>
+              <a:rPr sz="3600" b="1">
+                <a:solidFill>
+                  <a:srgbClr val="000000"/>
+                </a:solidFill>
+                <a:latin typeface="Calibri"/>
+              </a:rPr>
+              <a:t>DEPARTMENT OF COMPUTER SCIENCE &amp; ENGINEERING</a:t>
             </a:r>
           </a:p>
         </p:txBody>
@@ -4608,7 +4620,7 @@
         </p:nvSpPr>
         <p:spPr>
           <a:xfrm>
-            <a:off x="4073652" y="886054"/>
+            <a:off x="2743200" y="0"/>
             <a:ext cx="12801600" cy="1234440"/>
           </a:xfrm>
           <a:prstGeom prst="rect">
@@ -4617,24 +4629,28 @@
           <a:noFill/>
         </p:spPr>
         <p:txBody>
-          <a:bodyPr wrap="square"/>
-          <a:lstStyle/>
-          <a:p>
-            <a:pPr marL="0" indent="0" algn="ctr">
-              <a:lnSpc>
-                <a:spcPct val="150000"/>
-              </a:lnSpc>
-              <a:buNone/>
-            </a:pPr>
-            <a:r>
-              <a:rPr sz="2000" b="1">
+          <a:bodyPr wrap="none" anchor="t"/>
+          <a:lstStyle/>
+          <a:p>
+            <a:pPr algn="ctr"/>
+            <a:r>
+              <a:rPr sz="3600" b="1">
                 <a:solidFill>
                   <a:srgbClr val="000000"/>
                 </a:solidFill>
                 <a:latin typeface="Calibri"/>
               </a:rPr>
-              <a:t>P.A. COLLEGE OF ENGINEERING
-DEPARTMENT OF COMPUTER SCIENCE &amp; ENGINEERING</a:t>
+              <a:t>P.A. COLLEGE OF ENGINEERING</a:t>
+            </a:r>
+            <a:br/>
+            <a:r>
+              <a:rPr sz="3600" b="1">
+                <a:solidFill>
+                  <a:srgbClr val="000000"/>
+                </a:solidFill>
+                <a:latin typeface="Calibri"/>
+              </a:rPr>
+              <a:t>DEPARTMENT OF COMPUTER SCIENCE &amp; ENGINEERING</a:t>
             </a:r>
           </a:p>
         </p:txBody>
@@ -4887,8 +4903,8 @@
         </p:nvSpPr>
         <p:spPr>
           <a:xfrm>
-            <a:off x="4114800" y="914400"/>
-            <a:ext cx="12801600" cy="1280160"/>
+            <a:off x="2743200" y="0"/>
+            <a:ext cx="12801600" cy="1234440"/>
           </a:xfrm>
           <a:prstGeom prst="rect">
             <a:avLst/>
@@ -4896,14 +4912,14 @@
           <a:noFill/>
         </p:spPr>
         <p:txBody>
-          <a:bodyPr wrap="none">
+          <a:bodyPr wrap="none" anchor="t">
             <a:spAutoFit/>
           </a:bodyPr>
           <a:lstStyle/>
           <a:p>
             <a:pPr algn="ctr"/>
             <a:r>
-              <a:rPr sz="2800" b="1">
+              <a:rPr sz="3600" b="1">
                 <a:solidFill>
                   <a:srgbClr val="000000"/>
                 </a:solidFill>
@@ -4911,11 +4927,9 @@
               </a:rPr>
               <a:t>P.A. COLLEGE OF ENGINEERING</a:t>
             </a:r>
-          </a:p>
-          <a:p>
-            <a:pPr algn="ctr"/>
-            <a:r>
-              <a:rPr sz="2000" b="1">
+            <a:br/>
+            <a:r>
+              <a:rPr sz="3600" b="1">
                 <a:solidFill>
                   <a:srgbClr val="000000"/>
                 </a:solidFill>
@@ -5157,7 +5171,7 @@
         </p:nvSpPr>
         <p:spPr>
           <a:xfrm>
-            <a:off x="4073652" y="886054"/>
+            <a:off x="2743200" y="0"/>
             <a:ext cx="12801600" cy="1234440"/>
           </a:xfrm>
           <a:prstGeom prst="rect">
@@ -5166,24 +5180,28 @@
           <a:noFill/>
         </p:spPr>
         <p:txBody>
-          <a:bodyPr wrap="square"/>
-          <a:lstStyle/>
-          <a:p>
-            <a:pPr marL="0" indent="0" algn="ctr">
-              <a:lnSpc>
-                <a:spcPct val="150000"/>
-              </a:lnSpc>
-              <a:buNone/>
-            </a:pPr>
-            <a:r>
-              <a:rPr sz="2000" b="1">
+          <a:bodyPr wrap="none" anchor="t"/>
+          <a:lstStyle/>
+          <a:p>
+            <a:pPr algn="ctr"/>
+            <a:r>
+              <a:rPr sz="3600" b="1">
                 <a:solidFill>
                   <a:srgbClr val="000000"/>
                 </a:solidFill>
                 <a:latin typeface="Calibri"/>
               </a:rPr>
-              <a:t>P.A. COLLEGE OF ENGINEERING
-DEPARTMENT OF COMPUTER SCIENCE &amp; ENGINEERING</a:t>
+              <a:t>P.A. COLLEGE OF ENGINEERING</a:t>
+            </a:r>
+            <a:br/>
+            <a:r>
+              <a:rPr sz="3600" b="1">
+                <a:solidFill>
+                  <a:srgbClr val="000000"/>
+                </a:solidFill>
+                <a:latin typeface="Calibri"/>
+              </a:rPr>
+              <a:t>DEPARTMENT OF COMPUTER SCIENCE &amp; ENGINEERING</a:t>
             </a:r>
           </a:p>
         </p:txBody>
@@ -5431,7 +5449,7 @@
         </p:nvSpPr>
         <p:spPr>
           <a:xfrm>
-            <a:off x="4073652" y="886054"/>
+            <a:off x="2743200" y="0"/>
             <a:ext cx="12801600" cy="1234440"/>
           </a:xfrm>
           <a:prstGeom prst="rect">
@@ -5440,24 +5458,28 @@
           <a:noFill/>
         </p:spPr>
         <p:txBody>
-          <a:bodyPr wrap="square"/>
-          <a:lstStyle/>
-          <a:p>
-            <a:pPr marL="0" indent="0" algn="ctr">
-              <a:lnSpc>
-                <a:spcPct val="150000"/>
-              </a:lnSpc>
-              <a:buNone/>
-            </a:pPr>
-            <a:r>
-              <a:rPr sz="2000" b="1">
+          <a:bodyPr wrap="none" anchor="t"/>
+          <a:lstStyle/>
+          <a:p>
+            <a:pPr algn="ctr"/>
+            <a:r>
+              <a:rPr sz="3600" b="1">
                 <a:solidFill>
                   <a:srgbClr val="000000"/>
                 </a:solidFill>
                 <a:latin typeface="Calibri"/>
               </a:rPr>
-              <a:t>P.A. COLLEGE OF ENGINEERING
-DEPARTMENT OF COMPUTER SCIENCE &amp; ENGINEERING</a:t>
+              <a:t>P.A. COLLEGE OF ENGINEERING</a:t>
+            </a:r>
+            <a:br/>
+            <a:r>
+              <a:rPr sz="3600" b="1">
+                <a:solidFill>
+                  <a:srgbClr val="000000"/>
+                </a:solidFill>
+                <a:latin typeface="Calibri"/>
+              </a:rPr>
+              <a:t>DEPARTMENT OF COMPUTER SCIENCE &amp; ENGINEERING</a:t>
             </a:r>
           </a:p>
         </p:txBody>
@@ -5602,7 +5624,7 @@
         </p:nvSpPr>
         <p:spPr>
           <a:xfrm>
-            <a:off x="4073652" y="886054"/>
+            <a:off x="2743200" y="0"/>
             <a:ext cx="12801600" cy="1234440"/>
           </a:xfrm>
           <a:prstGeom prst="rect">
@@ -5611,24 +5633,28 @@
           <a:noFill/>
         </p:spPr>
         <p:txBody>
-          <a:bodyPr wrap="square"/>
-          <a:lstStyle/>
-          <a:p>
-            <a:pPr marL="0" indent="0" algn="ctr">
-              <a:lnSpc>
-                <a:spcPct val="150000"/>
-              </a:lnSpc>
-              <a:buNone/>
-            </a:pPr>
-            <a:r>
-              <a:rPr sz="2000" b="1">
+          <a:bodyPr wrap="none" anchor="t"/>
+          <a:lstStyle/>
+          <a:p>
+            <a:pPr algn="ctr"/>
+            <a:r>
+              <a:rPr sz="3600" b="1">
                 <a:solidFill>
                   <a:srgbClr val="000000"/>
                 </a:solidFill>
                 <a:latin typeface="Calibri"/>
               </a:rPr>
-              <a:t>P.A. COLLEGE OF ENGINEERING
-DEPARTMENT OF COMPUTER SCIENCE &amp; ENGINEERING</a:t>
+              <a:t>P.A. COLLEGE OF ENGINEERING</a:t>
+            </a:r>
+            <a:br/>
+            <a:r>
+              <a:rPr sz="3600" b="1">
+                <a:solidFill>
+                  <a:srgbClr val="000000"/>
+                </a:solidFill>
+                <a:latin typeface="Calibri"/>
+              </a:rPr>
+              <a:t>DEPARTMENT OF COMPUTER SCIENCE &amp; ENGINEERING</a:t>
             </a:r>
           </a:p>
         </p:txBody>
@@ -5862,7 +5888,7 @@
         </p:nvSpPr>
         <p:spPr>
           <a:xfrm>
-            <a:off x="4073652" y="886054"/>
+            <a:off x="2743200" y="0"/>
             <a:ext cx="12801600" cy="1234440"/>
           </a:xfrm>
           <a:prstGeom prst="rect">
@@ -5871,24 +5897,28 @@
           <a:noFill/>
         </p:spPr>
         <p:txBody>
-          <a:bodyPr wrap="square"/>
-          <a:lstStyle/>
-          <a:p>
-            <a:pPr marL="0" indent="0" algn="ctr">
-              <a:lnSpc>
-                <a:spcPct val="150000"/>
-              </a:lnSpc>
-              <a:buNone/>
-            </a:pPr>
-            <a:r>
-              <a:rPr sz="2000" b="1">
+          <a:bodyPr wrap="none" anchor="t"/>
+          <a:lstStyle/>
+          <a:p>
+            <a:pPr algn="ctr"/>
+            <a:r>
+              <a:rPr sz="3600" b="1">
                 <a:solidFill>
                   <a:srgbClr val="000000"/>
                 </a:solidFill>
                 <a:latin typeface="Calibri"/>
               </a:rPr>
-              <a:t>P.A. COLLEGE OF ENGINEERING
-DEPARTMENT OF COMPUTER SCIENCE &amp; ENGINEERING</a:t>
+              <a:t>P.A. COLLEGE OF ENGINEERING</a:t>
+            </a:r>
+            <a:br/>
+            <a:r>
+              <a:rPr sz="3600" b="1">
+                <a:solidFill>
+                  <a:srgbClr val="000000"/>
+                </a:solidFill>
+                <a:latin typeface="Calibri"/>
+              </a:rPr>
+              <a:t>DEPARTMENT OF COMPUTER SCIENCE &amp; ENGINEERING</a:t>
             </a:r>
           </a:p>
         </p:txBody>
@@ -6108,7 +6138,7 @@
         </p:nvSpPr>
         <p:spPr>
           <a:xfrm>
-            <a:off x="4073652" y="886054"/>
+            <a:off x="2743200" y="0"/>
             <a:ext cx="12801600" cy="1234440"/>
           </a:xfrm>
           <a:prstGeom prst="rect">
@@ -6117,24 +6147,28 @@
           <a:noFill/>
         </p:spPr>
         <p:txBody>
-          <a:bodyPr wrap="square"/>
-          <a:lstStyle/>
-          <a:p>
-            <a:pPr marL="0" indent="0" algn="ctr">
-              <a:lnSpc>
-                <a:spcPct val="150000"/>
-              </a:lnSpc>
-              <a:buNone/>
-            </a:pPr>
-            <a:r>
-              <a:rPr sz="2000" b="1">
+          <a:bodyPr wrap="none" anchor="t"/>
+          <a:lstStyle/>
+          <a:p>
+            <a:pPr algn="ctr"/>
+            <a:r>
+              <a:rPr sz="3600" b="1">
                 <a:solidFill>
                   <a:srgbClr val="000000"/>
                 </a:solidFill>
                 <a:latin typeface="Calibri"/>
               </a:rPr>
-              <a:t>P.A. COLLEGE OF ENGINEERING
-DEPARTMENT OF COMPUTER SCIENCE &amp; ENGINEERING</a:t>
+              <a:t>P.A. COLLEGE OF ENGINEERING</a:t>
+            </a:r>
+            <a:br/>
+            <a:r>
+              <a:rPr sz="3600" b="1">
+                <a:solidFill>
+                  <a:srgbClr val="000000"/>
+                </a:solidFill>
+                <a:latin typeface="Calibri"/>
+              </a:rPr>
+              <a:t>DEPARTMENT OF COMPUTER SCIENCE &amp; ENGINEERING</a:t>
             </a:r>
           </a:p>
         </p:txBody>
@@ -6382,7 +6416,7 @@
         </p:nvSpPr>
         <p:spPr>
           <a:xfrm>
-            <a:off x="4073652" y="886054"/>
+            <a:off x="2743200" y="0"/>
             <a:ext cx="12801600" cy="1234440"/>
           </a:xfrm>
           <a:prstGeom prst="rect">
@@ -6391,24 +6425,28 @@
           <a:noFill/>
         </p:spPr>
         <p:txBody>
-          <a:bodyPr wrap="square"/>
-          <a:lstStyle/>
-          <a:p>
-            <a:pPr marL="0" indent="0" algn="ctr">
-              <a:lnSpc>
-                <a:spcPct val="150000"/>
-              </a:lnSpc>
-              <a:buNone/>
-            </a:pPr>
-            <a:r>
-              <a:rPr sz="2000" b="1">
+          <a:bodyPr wrap="none" anchor="t"/>
+          <a:lstStyle/>
+          <a:p>
+            <a:pPr algn="ctr"/>
+            <a:r>
+              <a:rPr sz="3600" b="1">
                 <a:solidFill>
                   <a:srgbClr val="000000"/>
                 </a:solidFill>
                 <a:latin typeface="Calibri"/>
               </a:rPr>
-              <a:t>P.A. COLLEGE OF ENGINEERING
-DEPARTMENT OF COMPUTER SCIENCE &amp; ENGINEERING</a:t>
+              <a:t>P.A. COLLEGE OF ENGINEERING</a:t>
+            </a:r>
+            <a:br/>
+            <a:r>
+              <a:rPr sz="3600" b="1">
+                <a:solidFill>
+                  <a:srgbClr val="000000"/>
+                </a:solidFill>
+                <a:latin typeface="Calibri"/>
+              </a:rPr>
+              <a:t>DEPARTMENT OF COMPUTER SCIENCE &amp; ENGINEERING</a:t>
             </a:r>
           </a:p>
         </p:txBody>
@@ -6632,7 +6670,7 @@
         </p:nvSpPr>
         <p:spPr>
           <a:xfrm>
-            <a:off x="4073652" y="886054"/>
+            <a:off x="2743200" y="0"/>
             <a:ext cx="12801600" cy="1234440"/>
           </a:xfrm>
           <a:prstGeom prst="rect">
@@ -6641,24 +6679,28 @@
           <a:noFill/>
         </p:spPr>
         <p:txBody>
-          <a:bodyPr wrap="square"/>
-          <a:lstStyle/>
-          <a:p>
-            <a:pPr marL="0" indent="0" algn="ctr">
-              <a:lnSpc>
-                <a:spcPct val="150000"/>
-              </a:lnSpc>
-              <a:buNone/>
-            </a:pPr>
-            <a:r>
-              <a:rPr sz="2000" b="1">
+          <a:bodyPr wrap="none" anchor="t"/>
+          <a:lstStyle/>
+          <a:p>
+            <a:pPr algn="ctr"/>
+            <a:r>
+              <a:rPr sz="3600" b="1">
                 <a:solidFill>
                   <a:srgbClr val="000000"/>
                 </a:solidFill>
                 <a:latin typeface="Calibri"/>
               </a:rPr>
-              <a:t>P.A. COLLEGE OF ENGINEERING
-DEPARTMENT OF COMPUTER SCIENCE &amp; ENGINEERING</a:t>
+              <a:t>P.A. COLLEGE OF ENGINEERING</a:t>
+            </a:r>
+            <a:br/>
+            <a:r>
+              <a:rPr sz="3600" b="1">
+                <a:solidFill>
+                  <a:srgbClr val="000000"/>
+                </a:solidFill>
+                <a:latin typeface="Calibri"/>
+              </a:rPr>
+              <a:t>DEPARTMENT OF COMPUTER SCIENCE &amp; ENGINEERING</a:t>
             </a:r>
           </a:p>
         </p:txBody>
@@ -6920,7 +6962,7 @@
         </p:nvSpPr>
         <p:spPr>
           <a:xfrm>
-            <a:off x="4073652" y="886054"/>
+            <a:off x="2743200" y="0"/>
             <a:ext cx="12801600" cy="1234440"/>
           </a:xfrm>
           <a:prstGeom prst="rect">
@@ -6929,24 +6971,28 @@
           <a:noFill/>
         </p:spPr>
         <p:txBody>
-          <a:bodyPr wrap="square"/>
-          <a:lstStyle/>
-          <a:p>
-            <a:pPr marL="0" indent="0" algn="ctr">
-              <a:lnSpc>
-                <a:spcPct val="150000"/>
-              </a:lnSpc>
-              <a:buNone/>
-            </a:pPr>
-            <a:r>
-              <a:rPr sz="2000" b="1">
+          <a:bodyPr wrap="none" anchor="t"/>
+          <a:lstStyle/>
+          <a:p>
+            <a:pPr algn="ctr"/>
+            <a:r>
+              <a:rPr sz="3600" b="1">
                 <a:solidFill>
                   <a:srgbClr val="000000"/>
                 </a:solidFill>
                 <a:latin typeface="Calibri"/>
               </a:rPr>
-              <a:t>P.A. COLLEGE OF ENGINEERING
-DEPARTMENT OF COMPUTER SCIENCE &amp; ENGINEERING</a:t>
+              <a:t>P.A. COLLEGE OF ENGINEERING</a:t>
+            </a:r>
+            <a:br/>
+            <a:r>
+              <a:rPr sz="3600" b="1">
+                <a:solidFill>
+                  <a:srgbClr val="000000"/>
+                </a:solidFill>
+                <a:latin typeface="Calibri"/>
+              </a:rPr>
+              <a:t>DEPARTMENT OF COMPUTER SCIENCE &amp; ENGINEERING</a:t>
             </a:r>
           </a:p>
         </p:txBody>
@@ -7657,7 +7703,7 @@
         </p:nvSpPr>
         <p:spPr>
           <a:xfrm>
-            <a:off x="4073652" y="886054"/>
+            <a:off x="2743200" y="0"/>
             <a:ext cx="12801600" cy="1234440"/>
           </a:xfrm>
           <a:prstGeom prst="rect">
@@ -7666,24 +7712,28 @@
           <a:noFill/>
         </p:spPr>
         <p:txBody>
-          <a:bodyPr wrap="square"/>
-          <a:lstStyle/>
-          <a:p>
-            <a:pPr marL="0" indent="0" algn="ctr">
-              <a:lnSpc>
-                <a:spcPct val="150000"/>
-              </a:lnSpc>
-              <a:buNone/>
-            </a:pPr>
-            <a:r>
-              <a:rPr sz="2000" b="1">
+          <a:bodyPr wrap="none" anchor="t"/>
+          <a:lstStyle/>
+          <a:p>
+            <a:pPr algn="ctr"/>
+            <a:r>
+              <a:rPr sz="3600" b="1">
                 <a:solidFill>
                   <a:srgbClr val="000000"/>
                 </a:solidFill>
                 <a:latin typeface="Calibri"/>
               </a:rPr>
-              <a:t>P.A. COLLEGE OF ENGINEERING
-DEPARTMENT OF COMPUTER SCIENCE &amp; ENGINEERING</a:t>
+              <a:t>P.A. COLLEGE OF ENGINEERING</a:t>
+            </a:r>
+            <a:br/>
+            <a:r>
+              <a:rPr sz="3600" b="1">
+                <a:solidFill>
+                  <a:srgbClr val="000000"/>
+                </a:solidFill>
+                <a:latin typeface="Calibri"/>
+              </a:rPr>
+              <a:t>DEPARTMENT OF COMPUTER SCIENCE &amp; ENGINEERING</a:t>
             </a:r>
           </a:p>
         </p:txBody>
@@ -7938,7 +7988,7 @@
         </p:nvSpPr>
         <p:spPr>
           <a:xfrm>
-            <a:off x="4073652" y="886054"/>
+            <a:off x="2743200" y="0"/>
             <a:ext cx="12801600" cy="1234440"/>
           </a:xfrm>
           <a:prstGeom prst="rect">
@@ -7947,24 +7997,28 @@
           <a:noFill/>
         </p:spPr>
         <p:txBody>
-          <a:bodyPr wrap="square"/>
-          <a:lstStyle/>
-          <a:p>
-            <a:pPr marL="0" indent="0" algn="ctr">
-              <a:lnSpc>
-                <a:spcPct val="150000"/>
-              </a:lnSpc>
-              <a:buNone/>
-            </a:pPr>
-            <a:r>
-              <a:rPr sz="2000" b="1">
+          <a:bodyPr wrap="none" anchor="t"/>
+          <a:lstStyle/>
+          <a:p>
+            <a:pPr algn="ctr"/>
+            <a:r>
+              <a:rPr sz="3600" b="1">
                 <a:solidFill>
                   <a:srgbClr val="000000"/>
                 </a:solidFill>
                 <a:latin typeface="Calibri"/>
               </a:rPr>
-              <a:t>P.A. COLLEGE OF ENGINEERING
-DEPARTMENT OF COMPUTER SCIENCE &amp; ENGINEERING</a:t>
+              <a:t>P.A. COLLEGE OF ENGINEERING</a:t>
+            </a:r>
+            <a:br/>
+            <a:r>
+              <a:rPr sz="3600" b="1">
+                <a:solidFill>
+                  <a:srgbClr val="000000"/>
+                </a:solidFill>
+                <a:latin typeface="Calibri"/>
+              </a:rPr>
+              <a:t>DEPARTMENT OF COMPUTER SCIENCE &amp; ENGINEERING</a:t>
             </a:r>
           </a:p>
         </p:txBody>

</xml_diff>

<commit_message>
increase content text for projection
</commit_message>
<xml_diff>
--- a/ppt/SynCura_Deck_V3_FINAL.pptx
+++ b/ppt/SynCura_Deck_V3_FINAL.pptx
@@ -3575,7 +3575,7 @@
               <a:buChar char="•"/>
             </a:pPr>
             <a:r>
-              <a:rPr sz="2200">
+              <a:rPr sz="2500">
                 <a:solidFill>
                   <a:srgbClr val="000000"/>
                 </a:solidFill>
@@ -3592,7 +3592,7 @@
               <a:buChar char="•"/>
             </a:pPr>
             <a:r>
-              <a:rPr sz="2200">
+              <a:rPr sz="2500">
                 <a:solidFill>
                   <a:srgbClr val="000000"/>
                 </a:solidFill>
@@ -3609,7 +3609,7 @@
               <a:buChar char="•"/>
             </a:pPr>
             <a:r>
-              <a:rPr sz="2200">
+              <a:rPr sz="2500">
                 <a:solidFill>
                   <a:srgbClr val="000000"/>
                 </a:solidFill>
@@ -3626,7 +3626,7 @@
               <a:buChar char="•"/>
             </a:pPr>
             <a:r>
-              <a:rPr sz="2200">
+              <a:rPr sz="2500">
                 <a:solidFill>
                   <a:srgbClr val="000000"/>
                 </a:solidFill>
@@ -3843,7 +3843,7 @@
               <a:buChar char="•"/>
             </a:pPr>
             <a:r>
-              <a:rPr sz="2300">
+              <a:rPr sz="2400">
                 <a:latin typeface="Calibri"/>
               </a:rPr>
               <a:t>Backend: Python 3.10, FastAPI, uvicorn, NumPy, scikit-learn, PyTorch</a:t>
@@ -3851,7 +3851,7 @@
           </a:p>
           <a:p>
             <a:r>
-              <a:rPr sz="2300">
+              <a:rPr sz="2400">
                 <a:latin typeface="Calibri"/>
               </a:rPr>
               <a:t>Two LSTM hidden layers (96 units) + Temporal Attention</a:t>
@@ -3859,7 +3859,7 @@
           </a:p>
           <a:p>
             <a:r>
-              <a:rPr sz="2300">
+              <a:rPr sz="2400">
                 <a:latin typeface="Calibri"/>
               </a:rPr>
               <a:t>Microservices: FastAPI real-time backend, React + Vite frontend</a:t>
@@ -3867,7 +3867,7 @@
           </a:p>
           <a:p>
             <a:r>
-              <a:rPr sz="2300">
+              <a:rPr sz="2400">
                 <a:latin typeface="Calibri"/>
               </a:rPr>
               <a:t>Edge/stream ingestion: MQTT with Eclipse Mosquitto</a:t>
@@ -3934,7 +3934,7 @@
               </a:spcBef>
             </a:pPr>
             <a:r>
-              <a:rPr sz="1800">
+              <a:rPr sz="1900" b="1">
                 <a:solidFill>
                   <a:srgbClr val="000000"/>
                 </a:solidFill>
@@ -4048,7 +4048,7 @@
               </a:spcBef>
             </a:pPr>
             <a:r>
-              <a:rPr sz="1800">
+              <a:rPr sz="1900" b="1">
                 <a:solidFill>
                   <a:srgbClr val="000000"/>
                 </a:solidFill>
@@ -4162,7 +4162,7 @@
               </a:spcBef>
             </a:pPr>
             <a:r>
-              <a:rPr sz="1800">
+              <a:rPr sz="1900" b="1">
                 <a:solidFill>
                   <a:srgbClr val="000000"/>
                 </a:solidFill>
@@ -4276,7 +4276,7 @@
               </a:spcBef>
             </a:pPr>
             <a:r>
-              <a:rPr sz="1800">
+              <a:rPr sz="1900" b="1">
                 <a:solidFill>
                   <a:srgbClr val="000000"/>
                 </a:solidFill>
@@ -4493,7 +4493,7 @@
               <a:buChar char="•"/>
             </a:pPr>
             <a:r>
-              <a:rPr sz="2400">
+              <a:rPr sz="2600">
                 <a:solidFill>
                   <a:srgbClr val="000000"/>
                 </a:solidFill>
@@ -4504,7 +4504,7 @@
           </a:p>
           <a:p>
             <a:r>
-              <a:rPr sz="2400">
+              <a:rPr sz="2600">
                 <a:solidFill>
                   <a:srgbClr val="000000"/>
                 </a:solidFill>
@@ -4719,7 +4719,7 @@
               <a:buChar char="•"/>
             </a:pPr>
             <a:r>
-              <a:rPr sz="2400">
+              <a:rPr sz="2600">
                 <a:solidFill>
                   <a:srgbClr val="000000"/>
                 </a:solidFill>
@@ -4736,7 +4736,7 @@
               <a:buChar char="•"/>
             </a:pPr>
             <a:r>
-              <a:rPr sz="2400">
+              <a:rPr sz="2600">
                 <a:solidFill>
                   <a:srgbClr val="000000"/>
                 </a:solidFill>
@@ -4753,7 +4753,7 @@
               <a:buChar char="•"/>
             </a:pPr>
             <a:r>
-              <a:rPr sz="2400">
+              <a:rPr sz="2600">
                 <a:solidFill>
                   <a:srgbClr val="000000"/>
                 </a:solidFill>
@@ -4770,7 +4770,7 @@
               <a:buChar char="•"/>
             </a:pPr>
             <a:r>
-              <a:rPr sz="2400">
+              <a:rPr sz="2600">
                 <a:solidFill>
                   <a:srgbClr val="000000"/>
                 </a:solidFill>
@@ -4787,7 +4787,7 @@
               <a:buChar char="•"/>
             </a:pPr>
             <a:r>
-              <a:rPr sz="2400">
+              <a:rPr sz="2600">
                 <a:solidFill>
                   <a:srgbClr val="000000"/>
                 </a:solidFill>
@@ -5004,7 +5004,7 @@
               <a:buChar char="•"/>
             </a:pPr>
             <a:r>
-              <a:rPr sz="2400">
+              <a:rPr sz="2600">
                 <a:solidFill>
                   <a:srgbClr val="000000"/>
                 </a:solidFill>
@@ -5021,7 +5021,7 @@
               <a:buChar char="•"/>
             </a:pPr>
             <a:r>
-              <a:rPr sz="2400">
+              <a:rPr sz="2600">
                 <a:solidFill>
                   <a:srgbClr val="000000"/>
                 </a:solidFill>
@@ -5038,7 +5038,7 @@
               <a:buChar char="•"/>
             </a:pPr>
             <a:r>
-              <a:rPr sz="2400">
+              <a:rPr sz="2600">
                 <a:solidFill>
                   <a:srgbClr val="000000"/>
                 </a:solidFill>
@@ -5055,7 +5055,7 @@
               <a:buChar char="•"/>
             </a:pPr>
             <a:r>
-              <a:rPr sz="2400">
+              <a:rPr sz="2600">
                 <a:solidFill>
                   <a:srgbClr val="000000"/>
                 </a:solidFill>
@@ -5272,7 +5272,7 @@
               <a:buChar char="•"/>
             </a:pPr>
             <a:r>
-              <a:rPr sz="1800">
+              <a:rPr sz="2000">
                 <a:latin typeface="Calibri"/>
               </a:rPr>
               <a:t>[1] Zheng et al. (2025): Development and Validation of a Dynamic Real-Time Risk Prediction Model for ICU Patients Based on Longitudinal Irregular Data: Multicenter Retrospective Study. JMIR 27:e69293.</a:t>
@@ -5280,7 +5280,7 @@
           </a:p>
           <a:p>
             <a:r>
-              <a:rPr sz="1800">
+              <a:rPr sz="2000">
                 <a:latin typeface="Calibri"/>
               </a:rPr>
               <a:t>[2] Wang, Bai &amp; Jin (2026): Explainable Deep-Learning Models for Predicting ICU Patient Outcome. Frontiers in Physiology 17.</a:t>
@@ -5288,7 +5288,7 @@
           </a:p>
           <a:p>
             <a:r>
-              <a:rPr sz="1800">
+              <a:rPr sz="2000">
                 <a:latin typeface="Calibri"/>
               </a:rPr>
               <a:t>[3] Yan et al. (2026): Deep Learning-Based In-Hospital Mortality Prediction Using Long-Term Sequential Data in ICU Patients. PeerJ 14:e21631.</a:t>
@@ -5296,7 +5296,7 @@
           </a:p>
           <a:p>
             <a:r>
-              <a:rPr sz="1800">
+              <a:rPr sz="2000">
                 <a:latin typeface="Calibri"/>
               </a:rPr>
               <a:t>[4] Sadanandan (2026): Multimodal Deep Learning for Early Prediction of Patient Deterioration in the ICU: Integrating Time-Series EHR Data with Clinical Notes. arXiv:2603.14719.</a:t>
@@ -5304,7 +5304,7 @@
           </a:p>
           <a:p>
             <a:r>
-              <a:rPr sz="1800">
+              <a:rPr sz="2000">
                 <a:latin typeface="Calibri"/>
               </a:rPr>
               <a:t>[5] Wu et al. (2024): Revisiting the Potential Value of Vital Signs in the Real-Time Prediction of Mortality Risk in ICU Patients. J Big Data 11:40.</a:t>
@@ -5312,7 +5312,7 @@
           </a:p>
           <a:p>
             <a:r>
-              <a:rPr sz="1800">
+              <a:rPr sz="2000">
                 <a:latin typeface="Calibri"/>
               </a:rPr>
               <a:t>[6] Xie et al. (2025): Unlocking the Potential of Real-Time ICU Mortality Prediction: Redefining Risk Assessment with Continuous Data Recovery. npj Digital Medicine 8:733.</a:t>
@@ -5320,7 +5320,7 @@
           </a:p>
           <a:p>
             <a:r>
-              <a:rPr sz="1800">
+              <a:rPr sz="2000">
                 <a:latin typeface="Calibri"/>
               </a:rPr>
               <a:t>[7] Choi et al. (2020): Deep Interpretable Early Warning System for the Detection of Clinical Deterioration. IEEE J-BHI 24(9).</a:t>
@@ -5328,7 +5328,7 @@
           </a:p>
           <a:p>
             <a:r>
-              <a:rPr sz="1800">
+              <a:rPr sz="2000">
                 <a:latin typeface="Calibri"/>
               </a:rPr>
               <a:t>[8] Scheid et al. (2025): Development and Validation of a Clinical Wearable Deep Learning Based Continuous In-Hospital Deterioration Prediction Model. Nature Communications 16:9513.</a:t>
@@ -5336,7 +5336,7 @@
           </a:p>
           <a:p>
             <a:r>
-              <a:rPr sz="1800">
+              <a:rPr sz="2000">
                 <a:latin typeface="Calibri"/>
               </a:rPr>
               <a:t>[9] PhysioNet (2012): Computing in Cardiology Challenge 2012 dataset. physionet.org/content/challenge-2012.</a:t>
@@ -5721,7 +5721,7 @@
               <a:buNone/>
             </a:pPr>
             <a:r>
-              <a:rPr sz="2400" b="1">
+              <a:rPr sz="2600" b="1">
                 <a:solidFill>
                   <a:srgbClr val="000000"/>
                 </a:solidFill>
@@ -5738,7 +5738,7 @@
               <a:buNone/>
             </a:pPr>
             <a:r>
-              <a:rPr sz="2400" b="1">
+              <a:rPr sz="2600" b="1">
                 <a:solidFill>
                   <a:srgbClr val="000000"/>
                 </a:solidFill>
@@ -5755,7 +5755,7 @@
               <a:buNone/>
             </a:pPr>
             <a:r>
-              <a:rPr sz="2400" b="1">
+              <a:rPr sz="2600" b="1">
                 <a:solidFill>
                   <a:srgbClr val="000000"/>
                 </a:solidFill>
@@ -5772,7 +5772,7 @@
               <a:buNone/>
             </a:pPr>
             <a:r>
-              <a:rPr sz="2400" b="1">
+              <a:rPr sz="2600" b="1">
                 <a:solidFill>
                   <a:srgbClr val="000000"/>
                 </a:solidFill>
@@ -5989,7 +5989,7 @@
               <a:buChar char="•"/>
             </a:pPr>
             <a:r>
-              <a:rPr sz="2400">
+              <a:rPr sz="2600">
                 <a:solidFill>
                   <a:srgbClr val="000000"/>
                 </a:solidFill>
@@ -6000,7 +6000,7 @@
           </a:p>
           <a:p>
             <a:r>
-              <a:rPr sz="2400">
+              <a:rPr sz="2600">
                 <a:solidFill>
                   <a:srgbClr val="000000"/>
                 </a:solidFill>
@@ -6011,7 +6011,7 @@
           </a:p>
           <a:p>
             <a:r>
-              <a:rPr sz="2400">
+              <a:rPr sz="2600">
                 <a:solidFill>
                   <a:srgbClr val="000000"/>
                 </a:solidFill>
@@ -6022,7 +6022,7 @@
           </a:p>
           <a:p>
             <a:r>
-              <a:rPr sz="2400">
+              <a:rPr sz="2600">
                 <a:solidFill>
                   <a:srgbClr val="000000"/>
                 </a:solidFill>
@@ -6239,7 +6239,7 @@
               <a:buChar char="•"/>
             </a:pPr>
             <a:r>
-              <a:rPr sz="2000">
+              <a:rPr sz="2200">
                 <a:latin typeface="Calibri"/>
               </a:rPr>
               <a:t>Base paper: Zheng et al. (2025) - Temporal-Branch Attention LSTM (TBAL), MIMIC-IV + eICU, dynamic AUROC ~0.936. SynCura adapts TBAL to PhysioNet 2012.</a:t>
@@ -6247,7 +6247,7 @@
           </a:p>
           <a:p>
             <a:r>
-              <a:rPr sz="2000">
+              <a:rPr sz="2200">
                 <a:latin typeface="Calibri"/>
               </a:rPr>
               <a:t>Support 1: Yan et al. (2026) - single LSTM, multi-centre ICU, AUC 0.802.</a:t>
@@ -6255,7 +6255,7 @@
           </a:p>
           <a:p>
             <a:r>
-              <a:rPr sz="2000">
+              <a:rPr sz="2200">
                 <a:latin typeface="Calibri"/>
               </a:rPr>
               <a:t>Support 2: Sadanandan (2026) - multimodal LSTM + ClinicalBERT, AUROC 0.786.</a:t>
@@ -6263,7 +6263,7 @@
           </a:p>
           <a:p>
             <a:r>
-              <a:rPr sz="2000">
+              <a:rPr sz="2200">
                 <a:latin typeface="Calibri"/>
               </a:rPr>
               <a:t>Support 3: Wu et al. (2024) - vital-signs-only LSTM, AUC 0.926.</a:t>
@@ -6271,7 +6271,7 @@
           </a:p>
           <a:p>
             <a:r>
-              <a:rPr sz="2000">
+              <a:rPr sz="2200">
                 <a:latin typeface="Calibri"/>
               </a:rPr>
               <a:t>Support 4: Xie et al. (2025) - RealMIP missing-data recovery, AUC 0.957-0.968.</a:t>
@@ -6279,7 +6279,7 @@
           </a:p>
           <a:p>
             <a:r>
-              <a:rPr sz="2000">
+              <a:rPr sz="2200">
                 <a:latin typeface="Calibri"/>
               </a:rPr>
               <a:t>Support 5: Choi et al. (2020) - interpretable BiLSTM early-warning, AUROC ~0.880.</a:t>
@@ -6287,7 +6287,7 @@
           </a:p>
           <a:p>
             <a:r>
-              <a:rPr sz="2000">
+              <a:rPr sz="2200">
                 <a:latin typeface="Calibri"/>
               </a:rPr>
               <a:t>Support 6: Scheid et al. (2025) - continuous wearable deep learning, AUROC ~0.890.</a:t>
@@ -6295,7 +6295,7 @@
           </a:p>
           <a:p>
             <a:r>
-              <a:rPr sz="2000">
+              <a:rPr sz="2200">
                 <a:latin typeface="Calibri"/>
               </a:rPr>
               <a:t>Support 7: Wang, Bai &amp; Jin (2026) - explainable LSTM, AUC 0.79-0.87.</a:t>
@@ -6303,7 +6303,7 @@
           </a:p>
           <a:p>
             <a:r>
-              <a:rPr sz="2000">
+              <a:rPr sz="2200">
                 <a:latin typeface="Calibri"/>
               </a:rPr>
               <a:t>Gap: models report single AUC only; few validate on unseen patients; none ship a real-time explainable risk path.</a:t>
@@ -6517,7 +6517,7 @@
               <a:buChar char="•"/>
             </a:pPr>
             <a:r>
-              <a:rPr sz="2300">
+              <a:rPr sz="2400">
                 <a:latin typeface="Calibri"/>
               </a:rPr>
               <a:t>Title: Development and Validation of a Dynamic Real-Time Risk Prediction Model for ICU Patients based on Longitudinal Irregular Data</a:t>
@@ -6525,7 +6525,7 @@
           </a:p>
           <a:p>
             <a:r>
-              <a:rPr sz="2300">
+              <a:rPr sz="2400">
                 <a:latin typeface="Calibri"/>
               </a:rPr>
               <a:t>Authors: Zheng et al. (2025) - JMIR vol. 27, e69293</a:t>
@@ -6533,7 +6533,7 @@
           </a:p>
           <a:p>
             <a:r>
-              <a:rPr sz="2300">
+              <a:rPr sz="2400">
                 <a:latin typeface="Calibri"/>
               </a:rPr>
               <a:t>Method: Temporal-Branch Attention LSTM (TBAL); longitudinal irregular EHR; MIMIC-IV + eICU</a:t>
@@ -6541,7 +6541,7 @@
           </a:p>
           <a:p>
             <a:r>
-              <a:rPr sz="2300">
+              <a:rPr sz="2400">
                 <a:latin typeface="Calibri"/>
               </a:rPr>
               <a:t>Dynamic AUROC ~0.936; static ~0.812; recall 79.1%</a:t>
@@ -6549,7 +6549,7 @@
           </a:p>
           <a:p>
             <a:r>
-              <a:rPr sz="2300">
+              <a:rPr sz="2400">
                 <a:latin typeface="Calibri"/>
               </a:rPr>
               <a:t>SynCura adapts TBAL: 90-min rolling window, 12 features, temporal attention, PhysioNet 2012</a:t>
@@ -6557,7 +6557,7 @@
           </a:p>
           <a:p>
             <a:r>
-              <a:rPr sz="2300">
+              <a:rPr sz="2400">
                 <a:latin typeface="Calibri"/>
               </a:rPr>
               <a:t>Caution - hindsight bias: with retrospective data till discharge AUROC rises to 0.989 (future info); cross-hospital drops to 0.81</a:t>
@@ -6771,7 +6771,7 @@
               <a:buChar char="•"/>
             </a:pPr>
             <a:r>
-              <a:rPr sz="2300">
+              <a:rPr sz="2500">
                 <a:solidFill>
                   <a:srgbClr val="000000"/>
                 </a:solidFill>
@@ -6788,7 +6788,7 @@
               <a:buChar char="•"/>
             </a:pPr>
             <a:r>
-              <a:rPr sz="2300">
+              <a:rPr sz="2500">
                 <a:solidFill>
                   <a:srgbClr val="000000"/>
                 </a:solidFill>
@@ -6805,7 +6805,7 @@
               <a:buChar char="•"/>
             </a:pPr>
             <a:r>
-              <a:rPr sz="2300">
+              <a:rPr sz="2500">
                 <a:solidFill>
                   <a:srgbClr val="000000"/>
                 </a:solidFill>
@@ -6822,7 +6822,7 @@
               <a:buChar char="•"/>
             </a:pPr>
             <a:r>
-              <a:rPr sz="2300">
+              <a:rPr sz="2500">
                 <a:solidFill>
                   <a:srgbClr val="000000"/>
                 </a:solidFill>
@@ -7075,7 +7075,7 @@
           <a:p>
             <a:pPr algn="ctr"/>
             <a:r>
-              <a:rPr sz="2200" b="1">
+              <a:rPr sz="2400" b="1">
                 <a:solidFill>
                   <a:srgbClr val="1757AC"/>
                 </a:solidFill>
@@ -7091,7 +7091,7 @@
               </a:spcBef>
             </a:pPr>
             <a:r>
-              <a:rPr sz="1800">
+              <a:rPr sz="2000" b="1">
                 <a:solidFill>
                   <a:srgbClr val="000000"/>
                 </a:solidFill>
@@ -7190,7 +7190,7 @@
           <a:p>
             <a:pPr algn="ctr"/>
             <a:r>
-              <a:rPr sz="2200" b="1">
+              <a:rPr sz="2400" b="1">
                 <a:solidFill>
                   <a:srgbClr val="1757AC"/>
                 </a:solidFill>
@@ -7206,7 +7206,7 @@
               </a:spcBef>
             </a:pPr>
             <a:r>
-              <a:rPr sz="1800">
+              <a:rPr sz="2000" b="1">
                 <a:solidFill>
                   <a:srgbClr val="000000"/>
                 </a:solidFill>
@@ -7305,7 +7305,7 @@
           <a:p>
             <a:pPr algn="ctr"/>
             <a:r>
-              <a:rPr sz="2200" b="1">
+              <a:rPr sz="2400" b="1">
                 <a:solidFill>
                   <a:srgbClr val="1757AC"/>
                 </a:solidFill>
@@ -7321,7 +7321,7 @@
               </a:spcBef>
             </a:pPr>
             <a:r>
-              <a:rPr sz="1800">
+              <a:rPr sz="2000" b="1">
                 <a:solidFill>
                   <a:srgbClr val="000000"/>
                 </a:solidFill>
@@ -7420,7 +7420,7 @@
           <a:p>
             <a:pPr algn="ctr"/>
             <a:r>
-              <a:rPr sz="2200" b="1">
+              <a:rPr sz="2400" b="1">
                 <a:solidFill>
                   <a:srgbClr val="1757AC"/>
                 </a:solidFill>
@@ -7436,7 +7436,7 @@
               </a:spcBef>
             </a:pPr>
             <a:r>
-              <a:rPr sz="1800">
+              <a:rPr sz="2000" b="1">
                 <a:solidFill>
                   <a:srgbClr val="000000"/>
                 </a:solidFill>
@@ -7535,7 +7535,7 @@
           <a:p>
             <a:pPr algn="ctr"/>
             <a:r>
-              <a:rPr sz="2200" b="1">
+              <a:rPr sz="2400" b="1">
                 <a:solidFill>
                   <a:srgbClr val="1757AC"/>
                 </a:solidFill>
@@ -7551,7 +7551,7 @@
               </a:spcBef>
             </a:pPr>
             <a:r>
-              <a:rPr sz="1800">
+              <a:rPr sz="2000" b="1">
                 <a:solidFill>
                   <a:srgbClr val="000000"/>
                 </a:solidFill>
@@ -7587,7 +7587,7 @@
           <a:p>
             <a:pPr algn="ctr"/>
             <a:r>
-              <a:rPr sz="1800" i="1">
+              <a:rPr sz="2000" i="1">
                 <a:solidFill>
                   <a:srgbClr val="444444"/>
                 </a:solidFill>
@@ -7804,7 +7804,7 @@
               <a:buChar char="•"/>
             </a:pPr>
             <a:r>
-              <a:rPr sz="2400">
+              <a:rPr sz="2600">
                 <a:solidFill>
                   <a:srgbClr val="000000"/>
                 </a:solidFill>
@@ -7821,7 +7821,7 @@
               <a:buChar char="•"/>
             </a:pPr>
             <a:r>
-              <a:rPr sz="2400">
+              <a:rPr sz="2600">
                 <a:solidFill>
                   <a:srgbClr val="000000"/>
                 </a:solidFill>
@@ -7838,7 +7838,7 @@
               <a:buChar char="•"/>
             </a:pPr>
             <a:r>
-              <a:rPr sz="2400">
+              <a:rPr sz="2600">
                 <a:solidFill>
                   <a:srgbClr val="000000"/>
                 </a:solidFill>
@@ -7855,7 +7855,7 @@
               <a:buChar char="•"/>
             </a:pPr>
             <a:r>
-              <a:rPr sz="2400">
+              <a:rPr sz="2600">
                 <a:solidFill>
                   <a:srgbClr val="000000"/>
                 </a:solidFill>
@@ -7872,7 +7872,7 @@
               <a:buChar char="•"/>
             </a:pPr>
             <a:r>
-              <a:rPr sz="2400">
+              <a:rPr sz="2600">
                 <a:solidFill>
                   <a:srgbClr val="000000"/>
                 </a:solidFill>
@@ -8089,7 +8089,7 @@
               <a:buChar char="•"/>
             </a:pPr>
             <a:r>
-              <a:rPr sz="2000">
+              <a:rPr sz="2100">
                 <a:solidFill>
                   <a:srgbClr val="000000"/>
                 </a:solidFill>
@@ -8106,7 +8106,7 @@
               <a:buChar char="•"/>
             </a:pPr>
             <a:r>
-              <a:rPr sz="2000">
+              <a:rPr sz="2100">
                 <a:solidFill>
                   <a:srgbClr val="000000"/>
                 </a:solidFill>
@@ -8123,7 +8123,7 @@
               <a:buChar char="•"/>
             </a:pPr>
             <a:r>
-              <a:rPr sz="2000">
+              <a:rPr sz="2100">
                 <a:solidFill>
                   <a:srgbClr val="000000"/>
                 </a:solidFill>

</xml_diff>

<commit_message>
adjust deck fonts and alignment
</commit_message>
<xml_diff>
--- a/ppt/SynCura_Deck_V3_FINAL.pptx
+++ b/ppt/SynCura_Deck_V3_FINAL.pptx
@@ -317,7 +317,7 @@
           <a:p>
             <a:fld id="{5BCAD085-E8A6-8845-BD4E-CB4CCA059FC4}" type="datetimeFigureOut">
               <a:rPr lang="en-US" smtClean="0"/>
-              <a:t>9/17/2026</a:t>
+              <a:t>9/18/2026</a:t>
             </a:fld>
             <a:endParaRPr lang="en-US"/>
           </a:p>
@@ -375,6 +375,18 @@
   <p:clrMapOvr>
     <a:masterClrMapping/>
   </p:clrMapOvr>
+  <mc:AlternateContent xmlns:mc="http://schemas.openxmlformats.org/markup-compatibility/2006">
+    <mc:Choice xmlns:p159="http://schemas.microsoft.com/office/powerpoint/2015/09/main" Requires="p159">
+      <p:transition xmlns:p14="http://schemas.microsoft.com/office/powerpoint/2010/main" spd="slow" p14:dur="2000">
+        <p159:morph option="byObject"/>
+      </p:transition>
+    </mc:Choice>
+    <mc:Fallback>
+      <p:transition spd="slow">
+        <p:fade/>
+      </p:transition>
+    </mc:Fallback>
+  </mc:AlternateContent>
 </p:sldLayout>
 </file>
 
@@ -485,7 +497,7 @@
           <a:p>
             <a:fld id="{5BCAD085-E8A6-8845-BD4E-CB4CCA059FC4}" type="datetimeFigureOut">
               <a:rPr lang="en-US" smtClean="0"/>
-              <a:t>9/17/2026</a:t>
+              <a:t>9/18/2026</a:t>
             </a:fld>
             <a:endParaRPr lang="en-US"/>
           </a:p>
@@ -543,6 +555,18 @@
   <p:clrMapOvr>
     <a:masterClrMapping/>
   </p:clrMapOvr>
+  <mc:AlternateContent xmlns:mc="http://schemas.openxmlformats.org/markup-compatibility/2006">
+    <mc:Choice xmlns:p159="http://schemas.microsoft.com/office/powerpoint/2015/09/main" Requires="p159">
+      <p:transition xmlns:p14="http://schemas.microsoft.com/office/powerpoint/2010/main" spd="slow" p14:dur="2000">
+        <p159:morph option="byObject"/>
+      </p:transition>
+    </mc:Choice>
+    <mc:Fallback>
+      <p:transition spd="slow">
+        <p:fade/>
+      </p:transition>
+    </mc:Fallback>
+  </mc:AlternateContent>
 </p:sldLayout>
 </file>
 
@@ -663,7 +687,7 @@
           <a:p>
             <a:fld id="{5BCAD085-E8A6-8845-BD4E-CB4CCA059FC4}" type="datetimeFigureOut">
               <a:rPr lang="en-US" smtClean="0"/>
-              <a:t>9/17/2026</a:t>
+              <a:t>9/18/2026</a:t>
             </a:fld>
             <a:endParaRPr lang="en-US"/>
           </a:p>
@@ -721,6 +745,18 @@
   <p:clrMapOvr>
     <a:masterClrMapping/>
   </p:clrMapOvr>
+  <mc:AlternateContent xmlns:mc="http://schemas.openxmlformats.org/markup-compatibility/2006">
+    <mc:Choice xmlns:p159="http://schemas.microsoft.com/office/powerpoint/2015/09/main" Requires="p159">
+      <p:transition xmlns:p14="http://schemas.microsoft.com/office/powerpoint/2010/main" spd="slow" p14:dur="2000">
+        <p159:morph option="byObject"/>
+      </p:transition>
+    </mc:Choice>
+    <mc:Fallback>
+      <p:transition spd="slow">
+        <p:fade/>
+      </p:transition>
+    </mc:Fallback>
+  </mc:AlternateContent>
 </p:sldLayout>
 </file>
 
@@ -831,7 +867,7 @@
           <a:p>
             <a:fld id="{5BCAD085-E8A6-8845-BD4E-CB4CCA059FC4}" type="datetimeFigureOut">
               <a:rPr lang="en-US" smtClean="0"/>
-              <a:t>9/17/2026</a:t>
+              <a:t>9/18/2026</a:t>
             </a:fld>
             <a:endParaRPr lang="en-US"/>
           </a:p>
@@ -889,6 +925,18 @@
   <p:clrMapOvr>
     <a:masterClrMapping/>
   </p:clrMapOvr>
+  <mc:AlternateContent xmlns:mc="http://schemas.openxmlformats.org/markup-compatibility/2006">
+    <mc:Choice xmlns:p159="http://schemas.microsoft.com/office/powerpoint/2015/09/main" Requires="p159">
+      <p:transition xmlns:p14="http://schemas.microsoft.com/office/powerpoint/2010/main" spd="slow" p14:dur="2000">
+        <p159:morph option="byObject"/>
+      </p:transition>
+    </mc:Choice>
+    <mc:Fallback>
+      <p:transition spd="slow">
+        <p:fade/>
+      </p:transition>
+    </mc:Fallback>
+  </mc:AlternateContent>
 </p:sldLayout>
 </file>
 
@@ -1076,7 +1124,7 @@
           <a:p>
             <a:fld id="{5BCAD085-E8A6-8845-BD4E-CB4CCA059FC4}" type="datetimeFigureOut">
               <a:rPr lang="en-US" smtClean="0"/>
-              <a:t>9/17/2026</a:t>
+              <a:t>9/18/2026</a:t>
             </a:fld>
             <a:endParaRPr lang="en-US"/>
           </a:p>
@@ -1134,6 +1182,18 @@
   <p:clrMapOvr>
     <a:masterClrMapping/>
   </p:clrMapOvr>
+  <mc:AlternateContent xmlns:mc="http://schemas.openxmlformats.org/markup-compatibility/2006">
+    <mc:Choice xmlns:p159="http://schemas.microsoft.com/office/powerpoint/2015/09/main" Requires="p159">
+      <p:transition xmlns:p14="http://schemas.microsoft.com/office/powerpoint/2010/main" spd="slow" p14:dur="2000">
+        <p159:morph option="byObject"/>
+      </p:transition>
+    </mc:Choice>
+    <mc:Fallback>
+      <p:transition spd="slow">
+        <p:fade/>
+      </p:transition>
+    </mc:Fallback>
+  </mc:AlternateContent>
 </p:sldLayout>
 </file>
 
@@ -1361,7 +1421,7 @@
           <a:p>
             <a:fld id="{5BCAD085-E8A6-8845-BD4E-CB4CCA059FC4}" type="datetimeFigureOut">
               <a:rPr lang="en-US" smtClean="0"/>
-              <a:t>9/17/2026</a:t>
+              <a:t>9/18/2026</a:t>
             </a:fld>
             <a:endParaRPr lang="en-US"/>
           </a:p>
@@ -1419,6 +1479,18 @@
   <p:clrMapOvr>
     <a:masterClrMapping/>
   </p:clrMapOvr>
+  <mc:AlternateContent xmlns:mc="http://schemas.openxmlformats.org/markup-compatibility/2006">
+    <mc:Choice xmlns:p159="http://schemas.microsoft.com/office/powerpoint/2015/09/main" Requires="p159">
+      <p:transition xmlns:p14="http://schemas.microsoft.com/office/powerpoint/2010/main" spd="slow" p14:dur="2000">
+        <p159:morph option="byObject"/>
+      </p:transition>
+    </mc:Choice>
+    <mc:Fallback>
+      <p:transition spd="slow">
+        <p:fade/>
+      </p:transition>
+    </mc:Fallback>
+  </mc:AlternateContent>
 </p:sldLayout>
 </file>
 
@@ -1780,7 +1852,7 @@
           <a:p>
             <a:fld id="{5BCAD085-E8A6-8845-BD4E-CB4CCA059FC4}" type="datetimeFigureOut">
               <a:rPr lang="en-US" smtClean="0"/>
-              <a:t>9/17/2026</a:t>
+              <a:t>9/18/2026</a:t>
             </a:fld>
             <a:endParaRPr lang="en-US"/>
           </a:p>
@@ -1838,6 +1910,18 @@
   <p:clrMapOvr>
     <a:masterClrMapping/>
   </p:clrMapOvr>
+  <mc:AlternateContent xmlns:mc="http://schemas.openxmlformats.org/markup-compatibility/2006">
+    <mc:Choice xmlns:p159="http://schemas.microsoft.com/office/powerpoint/2015/09/main" Requires="p159">
+      <p:transition xmlns:p14="http://schemas.microsoft.com/office/powerpoint/2010/main" spd="slow" p14:dur="2000">
+        <p159:morph option="byObject"/>
+      </p:transition>
+    </mc:Choice>
+    <mc:Fallback>
+      <p:transition spd="slow">
+        <p:fade/>
+      </p:transition>
+    </mc:Fallback>
+  </mc:AlternateContent>
 </p:sldLayout>
 </file>
 
@@ -1897,7 +1981,7 @@
           <a:p>
             <a:fld id="{5BCAD085-E8A6-8845-BD4E-CB4CCA059FC4}" type="datetimeFigureOut">
               <a:rPr lang="en-US" smtClean="0"/>
-              <a:t>9/17/2026</a:t>
+              <a:t>9/18/2026</a:t>
             </a:fld>
             <a:endParaRPr lang="en-US"/>
           </a:p>
@@ -1955,6 +2039,18 @@
   <p:clrMapOvr>
     <a:masterClrMapping/>
   </p:clrMapOvr>
+  <mc:AlternateContent xmlns:mc="http://schemas.openxmlformats.org/markup-compatibility/2006">
+    <mc:Choice xmlns:p159="http://schemas.microsoft.com/office/powerpoint/2015/09/main" Requires="p159">
+      <p:transition xmlns:p14="http://schemas.microsoft.com/office/powerpoint/2010/main" spd="slow" p14:dur="2000">
+        <p159:morph option="byObject"/>
+      </p:transition>
+    </mc:Choice>
+    <mc:Fallback>
+      <p:transition spd="slow">
+        <p:fade/>
+      </p:transition>
+    </mc:Fallback>
+  </mc:AlternateContent>
 </p:sldLayout>
 </file>
 
@@ -1992,7 +2088,7 @@
           <a:p>
             <a:fld id="{5BCAD085-E8A6-8845-BD4E-CB4CCA059FC4}" type="datetimeFigureOut">
               <a:rPr lang="en-US" smtClean="0"/>
-              <a:t>9/17/2026</a:t>
+              <a:t>9/18/2026</a:t>
             </a:fld>
             <a:endParaRPr lang="en-US"/>
           </a:p>
@@ -2050,6 +2146,18 @@
   <p:clrMapOvr>
     <a:masterClrMapping/>
   </p:clrMapOvr>
+  <mc:AlternateContent xmlns:mc="http://schemas.openxmlformats.org/markup-compatibility/2006">
+    <mc:Choice xmlns:p159="http://schemas.microsoft.com/office/powerpoint/2015/09/main" Requires="p159">
+      <p:transition xmlns:p14="http://schemas.microsoft.com/office/powerpoint/2010/main" spd="slow" p14:dur="2000">
+        <p159:morph option="byObject"/>
+      </p:transition>
+    </mc:Choice>
+    <mc:Fallback>
+      <p:transition spd="slow">
+        <p:fade/>
+      </p:transition>
+    </mc:Fallback>
+  </mc:AlternateContent>
 </p:sldLayout>
 </file>
 
@@ -2267,7 +2375,7 @@
           <a:p>
             <a:fld id="{5BCAD085-E8A6-8845-BD4E-CB4CCA059FC4}" type="datetimeFigureOut">
               <a:rPr lang="en-US" smtClean="0"/>
-              <a:t>9/17/2026</a:t>
+              <a:t>9/18/2026</a:t>
             </a:fld>
             <a:endParaRPr lang="en-US"/>
           </a:p>
@@ -2325,6 +2433,18 @@
   <p:clrMapOvr>
     <a:masterClrMapping/>
   </p:clrMapOvr>
+  <mc:AlternateContent xmlns:mc="http://schemas.openxmlformats.org/markup-compatibility/2006">
+    <mc:Choice xmlns:p159="http://schemas.microsoft.com/office/powerpoint/2015/09/main" Requires="p159">
+      <p:transition xmlns:p14="http://schemas.microsoft.com/office/powerpoint/2010/main" spd="slow" p14:dur="2000">
+        <p159:morph option="byObject"/>
+      </p:transition>
+    </mc:Choice>
+    <mc:Fallback>
+      <p:transition spd="slow">
+        <p:fade/>
+      </p:transition>
+    </mc:Fallback>
+  </mc:AlternateContent>
 </p:sldLayout>
 </file>
 
@@ -2519,7 +2639,7 @@
           <a:p>
             <a:fld id="{5BCAD085-E8A6-8845-BD4E-CB4CCA059FC4}" type="datetimeFigureOut">
               <a:rPr lang="en-US" smtClean="0"/>
-              <a:t>9/17/2026</a:t>
+              <a:t>9/18/2026</a:t>
             </a:fld>
             <a:endParaRPr lang="en-US"/>
           </a:p>
@@ -2577,6 +2697,18 @@
   <p:clrMapOvr>
     <a:masterClrMapping/>
   </p:clrMapOvr>
+  <mc:AlternateContent xmlns:mc="http://schemas.openxmlformats.org/markup-compatibility/2006">
+    <mc:Choice xmlns:p159="http://schemas.microsoft.com/office/powerpoint/2015/09/main" Requires="p159">
+      <p:transition xmlns:p14="http://schemas.microsoft.com/office/powerpoint/2010/main" spd="slow" p14:dur="2000">
+        <p159:morph option="byObject"/>
+      </p:transition>
+    </mc:Choice>
+    <mc:Fallback>
+      <p:transition spd="slow">
+        <p:fade/>
+      </p:transition>
+    </mc:Fallback>
+  </mc:AlternateContent>
 </p:sldLayout>
 </file>
 
@@ -2730,7 +2862,7 @@
           <a:p>
             <a:fld id="{5BCAD085-E8A6-8845-BD4E-CB4CCA059FC4}" type="datetimeFigureOut">
               <a:rPr lang="en-US" smtClean="0"/>
-              <a:t>9/17/2026</a:t>
+              <a:t>9/18/2026</a:t>
             </a:fld>
             <a:endParaRPr lang="en-US"/>
           </a:p>
@@ -2835,6 +2967,18 @@
     <p:sldLayoutId id="2147483658" r:id="rId10"/>
     <p:sldLayoutId id="2147483659" r:id="rId11"/>
   </p:sldLayoutIdLst>
+  <mc:AlternateContent xmlns:mc="http://schemas.openxmlformats.org/markup-compatibility/2006">
+    <mc:Choice xmlns:p159="http://schemas.microsoft.com/office/powerpoint/2015/09/main" Requires="p159">
+      <p:transition xmlns:p14="http://schemas.microsoft.com/office/powerpoint/2010/main" spd="slow" p14:dur="2000">
+        <p159:morph option="byObject"/>
+      </p:transition>
+    </mc:Choice>
+    <mc:Fallback>
+      <p:transition spd="slow">
+        <p:fade/>
+      </p:transition>
+    </mc:Fallback>
+  </mc:AlternateContent>
   <p:txStyles>
     <p:titleStyle>
       <a:lvl1pPr algn="ctr" defTabSz="457200" rtl="0" eaLnBrk="1" latinLnBrk="0" hangingPunct="1">
@@ -3374,6 +3518,18 @@
   <p:clrMapOvr>
     <a:masterClrMapping/>
   </p:clrMapOvr>
+  <mc:AlternateContent xmlns:mc="http://schemas.openxmlformats.org/markup-compatibility/2006">
+    <mc:Choice xmlns:p159="http://schemas.microsoft.com/office/powerpoint/2015/09/main" Requires="p159">
+      <p:transition xmlns:p14="http://schemas.microsoft.com/office/powerpoint/2010/main" spd="slow" p14:dur="2000">
+        <p159:morph option="byObject"/>
+      </p:transition>
+    </mc:Choice>
+    <mc:Fallback>
+      <p:transition spd="slow">
+        <p:fade/>
+      </p:transition>
+    </mc:Fallback>
+  </mc:AlternateContent>
 </p:sld>
 </file>
 
@@ -3533,7 +3689,7 @@
               <a:buNone/>
             </a:pPr>
             <a:r>
-              <a:rPr sz="3400" b="1">
+              <a:rPr sz="4000" b="1" dirty="0">
                 <a:solidFill>
                   <a:srgbClr val="1757AC"/>
                 </a:solidFill>
@@ -3552,7 +3708,7 @@
         </p:nvSpPr>
         <p:spPr>
           <a:xfrm>
-            <a:off x="990295" y="3261665"/>
+            <a:off x="990295" y="3273240"/>
             <a:ext cx="16303752" cy="6035040"/>
           </a:xfrm>
           <a:prstGeom prst="rect">
@@ -3575,7 +3731,7 @@
               <a:buChar char="•"/>
             </a:pPr>
             <a:r>
-              <a:rPr sz="2500">
+              <a:rPr sz="2800" dirty="0">
                 <a:solidFill>
                   <a:srgbClr val="000000"/>
                 </a:solidFill>
@@ -3592,7 +3748,7 @@
               <a:buChar char="•"/>
             </a:pPr>
             <a:r>
-              <a:rPr sz="2500">
+              <a:rPr sz="2800" dirty="0">
                 <a:solidFill>
                   <a:srgbClr val="000000"/>
                 </a:solidFill>
@@ -3609,13 +3765,13 @@
               <a:buChar char="•"/>
             </a:pPr>
             <a:r>
-              <a:rPr sz="2500">
+              <a:rPr sz="2800" dirty="0">
                 <a:solidFill>
                   <a:srgbClr val="000000"/>
                 </a:solidFill>
                 <a:latin typeface="Calibri"/>
               </a:rPr>
-              <a:t>Reported what papers often skip: false-alarm rate, specificity, precision, F1, lead time vs NEWS2, and calibration.</a:t>
+              <a:t>Reported what papers often skip: false-alarm rate, specificity, precision, lead time vs NEWS2, and calibration.</a:t>
             </a:r>
           </a:p>
           <a:p>
@@ -3626,13 +3782,31 @@
               <a:buChar char="•"/>
             </a:pPr>
             <a:r>
-              <a:rPr sz="2500">
+              <a:rPr sz="2800" dirty="0">
                 <a:solidFill>
                   <a:srgbClr val="000000"/>
                 </a:solidFill>
                 <a:latin typeface="Calibri"/>
               </a:rPr>
-              <a:t>Next steps: eICU/MIMIC external validation, robust missing-data handling, time-aware attention, and a prospective clinical pilot.</a:t>
+              <a:t>Next steps: </a:t>
+            </a:r>
+            <a:r>
+              <a:rPr sz="2800" dirty="0" err="1">
+                <a:solidFill>
+                  <a:srgbClr val="000000"/>
+                </a:solidFill>
+                <a:latin typeface="Calibri"/>
+              </a:rPr>
+              <a:t>eICU</a:t>
+            </a:r>
+            <a:r>
+              <a:rPr sz="2800" dirty="0">
+                <a:solidFill>
+                  <a:srgbClr val="000000"/>
+                </a:solidFill>
+                <a:latin typeface="Calibri"/>
+              </a:rPr>
+              <a:t>/MIMIC external validation, robust missing-data handling, time-aware attention, and a prospective clinical pilot.</a:t>
             </a:r>
           </a:p>
         </p:txBody>
@@ -3642,6 +3816,18 @@
   <p:clrMapOvr>
     <a:masterClrMapping/>
   </p:clrMapOvr>
+  <mc:AlternateContent xmlns:mc="http://schemas.openxmlformats.org/markup-compatibility/2006">
+    <mc:Choice xmlns:p159="http://schemas.microsoft.com/office/powerpoint/2015/09/main" Requires="p159">
+      <p:transition xmlns:p14="http://schemas.microsoft.com/office/powerpoint/2010/main" spd="slow" p14:dur="2000">
+        <p159:morph option="byObject"/>
+      </p:transition>
+    </mc:Choice>
+    <mc:Fallback>
+      <p:transition spd="slow">
+        <p:fade/>
+      </p:transition>
+    </mc:Fallback>
+  </mc:AlternateContent>
 </p:sld>
 </file>
 
@@ -3801,7 +3987,7 @@
               <a:buNone/>
             </a:pPr>
             <a:r>
-              <a:rPr sz="3400" b="1">
+              <a:rPr sz="4000" b="1" dirty="0">
                 <a:solidFill>
                   <a:srgbClr val="1757AC"/>
                 </a:solidFill>
@@ -3820,7 +4006,7 @@
         </p:nvSpPr>
         <p:spPr>
           <a:xfrm>
-            <a:off x="990295" y="3261665"/>
+            <a:off x="932688" y="2894076"/>
             <a:ext cx="16303752" cy="6035040"/>
           </a:xfrm>
           <a:prstGeom prst="rect">
@@ -3843,35 +4029,101 @@
               <a:buChar char="•"/>
             </a:pPr>
             <a:r>
-              <a:rPr sz="2400">
-                <a:latin typeface="Calibri"/>
-              </a:rPr>
-              <a:t>Backend: Python 3.10, FastAPI, uvicorn, NumPy, scikit-learn, PyTorch</a:t>
-            </a:r>
-          </a:p>
-          <a:p>
-            <a:r>
-              <a:rPr sz="2400">
+              <a:rPr sz="2800" dirty="0">
+                <a:latin typeface="Calibri"/>
+              </a:rPr>
+              <a:t>Backend: Python 3.10, </a:t>
+            </a:r>
+            <a:r>
+              <a:rPr sz="2800" dirty="0" err="1">
+                <a:latin typeface="Calibri"/>
+              </a:rPr>
+              <a:t>FastAPI</a:t>
+            </a:r>
+            <a:endParaRPr lang="en-IN" sz="2800" dirty="0">
+              <a:latin typeface="Calibri"/>
+            </a:endParaRPr>
+          </a:p>
+          <a:p>
+            <a:pPr marL="406400" indent="-406400">
+              <a:lnSpc>
+                <a:spcPct val="150000"/>
+              </a:lnSpc>
+              <a:spcAft>
+                <a:spcPts val="1400"/>
+              </a:spcAft>
+              <a:buSzPct val="100000"/>
+              <a:buChar char="•"/>
+            </a:pPr>
+            <a:r>
+              <a:rPr sz="2800" dirty="0">
                 <a:latin typeface="Calibri"/>
               </a:rPr>
               <a:t>Two LSTM hidden layers (96 units) + Temporal Attention</a:t>
             </a:r>
-          </a:p>
-          <a:p>
-            <a:r>
-              <a:rPr sz="2400">
-                <a:latin typeface="Calibri"/>
-              </a:rPr>
-              <a:t>Microservices: FastAPI real-time backend, React + Vite frontend</a:t>
-            </a:r>
-          </a:p>
-          <a:p>
-            <a:r>
-              <a:rPr sz="2400">
-                <a:latin typeface="Calibri"/>
-              </a:rPr>
-              <a:t>Edge/stream ingestion: MQTT with Eclipse Mosquitto</a:t>
-            </a:r>
+            <a:endParaRPr lang="en-IN" sz="2800" dirty="0">
+              <a:latin typeface="Calibri"/>
+            </a:endParaRPr>
+          </a:p>
+          <a:p>
+            <a:pPr marL="406400" indent="-406400">
+              <a:lnSpc>
+                <a:spcPct val="150000"/>
+              </a:lnSpc>
+              <a:spcAft>
+                <a:spcPts val="1400"/>
+              </a:spcAft>
+              <a:buSzPct val="100000"/>
+              <a:buChar char="•"/>
+            </a:pPr>
+            <a:r>
+              <a:rPr sz="2800" dirty="0">
+                <a:latin typeface="Calibri"/>
+              </a:rPr>
+              <a:t>Microservices: </a:t>
+            </a:r>
+            <a:r>
+              <a:rPr sz="2800" dirty="0" err="1">
+                <a:latin typeface="Calibri"/>
+              </a:rPr>
+              <a:t>FastAPI</a:t>
+            </a:r>
+            <a:r>
+              <a:rPr sz="2800" dirty="0">
+                <a:latin typeface="Calibri"/>
+              </a:rPr>
+              <a:t> real-time backend, React + Vite frontend</a:t>
+            </a:r>
+            <a:endParaRPr lang="en-IN" sz="2800" dirty="0">
+              <a:latin typeface="Calibri"/>
+            </a:endParaRPr>
+          </a:p>
+          <a:p>
+            <a:pPr marL="406400" indent="-406400">
+              <a:lnSpc>
+                <a:spcPct val="150000"/>
+              </a:lnSpc>
+              <a:spcAft>
+                <a:spcPts val="1400"/>
+              </a:spcAft>
+              <a:buSzPct val="100000"/>
+              <a:buChar char="•"/>
+            </a:pPr>
+            <a:r>
+              <a:rPr sz="2800" dirty="0">
+                <a:latin typeface="Calibri"/>
+              </a:rPr>
+              <a:t>Edge/stream ingestion: MQTT with Eclipse </a:t>
+            </a:r>
+            <a:r>
+              <a:rPr sz="2800" dirty="0" err="1">
+                <a:latin typeface="Calibri"/>
+              </a:rPr>
+              <a:t>Mosquitto</a:t>
+            </a:r>
+            <a:endParaRPr sz="2800" dirty="0">
+              <a:latin typeface="Calibri"/>
+            </a:endParaRPr>
           </a:p>
         </p:txBody>
       </p:sp>
@@ -4260,7 +4512,7 @@
           <a:p>
             <a:pPr algn="ctr"/>
             <a:r>
-              <a:rPr sz="2200" b="1">
+              <a:rPr sz="2200" b="1" dirty="0">
                 <a:solidFill>
                   <a:srgbClr val="1757AC"/>
                 </a:solidFill>
@@ -4276,7 +4528,7 @@
               </a:spcBef>
             </a:pPr>
             <a:r>
-              <a:rPr sz="1900" b="1">
+              <a:rPr sz="1900" b="1" dirty="0">
                 <a:solidFill>
                   <a:srgbClr val="000000"/>
                 </a:solidFill>
@@ -4292,6 +4544,18 @@
   <p:clrMapOvr>
     <a:masterClrMapping/>
   </p:clrMapOvr>
+  <mc:AlternateContent xmlns:mc="http://schemas.openxmlformats.org/markup-compatibility/2006">
+    <mc:Choice xmlns:p159="http://schemas.microsoft.com/office/powerpoint/2015/09/main" Requires="p159">
+      <p:transition xmlns:p14="http://schemas.microsoft.com/office/powerpoint/2010/main" spd="slow" p14:dur="2000">
+        <p159:morph option="byObject"/>
+      </p:transition>
+    </mc:Choice>
+    <mc:Fallback>
+      <p:transition spd="slow">
+        <p:fade/>
+      </p:transition>
+    </mc:Fallback>
+  </mc:AlternateContent>
 </p:sld>
 </file>
 
@@ -4451,7 +4715,7 @@
               <a:buNone/>
             </a:pPr>
             <a:r>
-              <a:rPr sz="3400" b="1">
+              <a:rPr sz="4000" b="1" dirty="0">
                 <a:solidFill>
                   <a:srgbClr val="1757AC"/>
                 </a:solidFill>
@@ -4493,7 +4757,7 @@
               <a:buChar char="•"/>
             </a:pPr>
             <a:r>
-              <a:rPr sz="2600">
+              <a:rPr sz="2600" dirty="0">
                 <a:solidFill>
                   <a:srgbClr val="000000"/>
                 </a:solidFill>
@@ -4501,10 +4765,26 @@
               </a:rPr>
               <a:t>SDG 3 - Good Health and Well-Being: earlier detection of ICU deterioration supports timely clinical review and better patient monitoring.</a:t>
             </a:r>
-          </a:p>
-          <a:p>
-            <a:r>
-              <a:rPr sz="2600">
+            <a:endParaRPr lang="en-IN" sz="2600" dirty="0">
+              <a:solidFill>
+                <a:srgbClr val="000000"/>
+              </a:solidFill>
+              <a:latin typeface="Calibri"/>
+            </a:endParaRPr>
+          </a:p>
+          <a:p>
+            <a:pPr marL="406400" indent="-406400">
+              <a:lnSpc>
+                <a:spcPct val="150000"/>
+              </a:lnSpc>
+              <a:spcAft>
+                <a:spcPts val="1400"/>
+              </a:spcAft>
+              <a:buSzPct val="100000"/>
+              <a:buChar char="•"/>
+            </a:pPr>
+            <a:r>
+              <a:rPr sz="2600" dirty="0">
                 <a:solidFill>
                   <a:srgbClr val="000000"/>
                 </a:solidFill>
@@ -4520,6 +4800,18 @@
   <p:clrMapOvr>
     <a:masterClrMapping/>
   </p:clrMapOvr>
+  <mc:AlternateContent xmlns:mc="http://schemas.openxmlformats.org/markup-compatibility/2006">
+    <mc:Choice xmlns:p159="http://schemas.microsoft.com/office/powerpoint/2015/09/main" Requires="p159">
+      <p:transition xmlns:p14="http://schemas.microsoft.com/office/powerpoint/2010/main" spd="slow" p14:dur="2000">
+        <p159:morph option="byObject"/>
+      </p:transition>
+    </mc:Choice>
+    <mc:Fallback>
+      <p:transition spd="slow">
+        <p:fade/>
+      </p:transition>
+    </mc:Fallback>
+  </mc:AlternateContent>
 </p:sld>
 </file>
 
@@ -4677,7 +4969,7 @@
           <a:p>
             <a:pPr algn="ctr"/>
             <a:r>
-              <a:rPr sz="3400" b="1">
+              <a:rPr sz="4000" b="1" dirty="0">
                 <a:solidFill>
                   <a:srgbClr val="1757AC"/>
                 </a:solidFill>
@@ -4719,7 +5011,7 @@
               <a:buChar char="•"/>
             </a:pPr>
             <a:r>
-              <a:rPr sz="2600">
+              <a:rPr sz="3200" dirty="0">
                 <a:solidFill>
                   <a:srgbClr val="000000"/>
                 </a:solidFill>
@@ -4736,7 +5028,7 @@
               <a:buChar char="•"/>
             </a:pPr>
             <a:r>
-              <a:rPr sz="2600">
+              <a:rPr sz="3200" dirty="0">
                 <a:solidFill>
                   <a:srgbClr val="000000"/>
                 </a:solidFill>
@@ -4753,13 +5045,31 @@
               <a:buChar char="•"/>
             </a:pPr>
             <a:r>
-              <a:rPr sz="2600">
+              <a:rPr sz="3200" dirty="0">
                 <a:solidFill>
                   <a:srgbClr val="000000"/>
                 </a:solidFill>
                 <a:latin typeface="Calibri"/>
               </a:rPr>
-              <a:t>External validation on MIMIC-IV and eICU patient cohorts.</a:t>
+              <a:t>External validation on MIMIC-IV and </a:t>
+            </a:r>
+            <a:r>
+              <a:rPr sz="3200" dirty="0" err="1">
+                <a:solidFill>
+                  <a:srgbClr val="000000"/>
+                </a:solidFill>
+                <a:latin typeface="Calibri"/>
+              </a:rPr>
+              <a:t>eICU</a:t>
+            </a:r>
+            <a:r>
+              <a:rPr sz="3200" dirty="0">
+                <a:solidFill>
+                  <a:srgbClr val="000000"/>
+                </a:solidFill>
+                <a:latin typeface="Calibri"/>
+              </a:rPr>
+              <a:t> patient cohorts.</a:t>
             </a:r>
           </a:p>
           <a:p>
@@ -4770,7 +5080,7 @@
               <a:buChar char="•"/>
             </a:pPr>
             <a:r>
-              <a:rPr sz="2600">
+              <a:rPr sz="3200" dirty="0">
                 <a:solidFill>
                   <a:srgbClr val="000000"/>
                 </a:solidFill>
@@ -4787,7 +5097,7 @@
               <a:buChar char="•"/>
             </a:pPr>
             <a:r>
-              <a:rPr sz="2600">
+              <a:rPr sz="3200" dirty="0">
                 <a:solidFill>
                   <a:srgbClr val="000000"/>
                 </a:solidFill>
@@ -4803,6 +5113,18 @@
   <p:clrMapOvr>
     <a:masterClrMapping/>
   </p:clrMapOvr>
+  <mc:AlternateContent xmlns:mc="http://schemas.openxmlformats.org/markup-compatibility/2006">
+    <mc:Choice xmlns:p159="http://schemas.microsoft.com/office/powerpoint/2015/09/main" Requires="p159">
+      <p:transition xmlns:p14="http://schemas.microsoft.com/office/powerpoint/2010/main" spd="slow" p14:dur="2000">
+        <p159:morph option="byObject"/>
+      </p:transition>
+    </mc:Choice>
+    <mc:Fallback>
+      <p:transition spd="slow">
+        <p:fade/>
+      </p:transition>
+    </mc:Fallback>
+  </mc:AlternateContent>
 </p:sld>
 </file>
 
@@ -4948,8 +5270,8 @@
         </p:nvSpPr>
         <p:spPr>
           <a:xfrm>
-            <a:off x="914400" y="2011680"/>
-            <a:ext cx="16459200" cy="914400"/>
+            <a:off x="7639550" y="2011680"/>
+            <a:ext cx="3008901" cy="707886"/>
           </a:xfrm>
           <a:prstGeom prst="rect">
             <a:avLst/>
@@ -4964,7 +5286,7 @@
           <a:p>
             <a:pPr algn="ctr"/>
             <a:r>
-              <a:rPr sz="3400" b="1">
+              <a:rPr sz="4000" b="1" dirty="0">
                 <a:solidFill>
                   <a:srgbClr val="1757AC"/>
                 </a:solidFill>
@@ -4972,6 +5294,12 @@
               </a:rPr>
               <a:t>CONCLUSION</a:t>
             </a:r>
+            <a:endParaRPr sz="3400" b="1" dirty="0">
+              <a:solidFill>
+                <a:srgbClr val="1757AC"/>
+              </a:solidFill>
+              <a:latin typeface="Calibri"/>
+            </a:endParaRPr>
           </a:p>
         </p:txBody>
       </p:sp>
@@ -4984,7 +5312,7 @@
         <p:spPr>
           <a:xfrm>
             <a:off x="1005840" y="3291840"/>
-            <a:ext cx="16276320" cy="6035040"/>
+            <a:ext cx="16276320" cy="3377848"/>
           </a:xfrm>
           <a:prstGeom prst="rect">
             <a:avLst/>
@@ -5004,13 +5332,22 @@
               <a:buChar char="•"/>
             </a:pPr>
             <a:r>
-              <a:rPr sz="2600">
+              <a:rPr sz="2800" dirty="0" err="1">
                 <a:solidFill>
                   <a:srgbClr val="000000"/>
                 </a:solidFill>
                 <a:latin typeface="Calibri"/>
               </a:rPr>
-              <a:t>SynCura demonstrates an end-to-end explainable ICU risk-monitoring workflow from clinical time-series input to dashboard output.</a:t>
+              <a:t>SynCura</a:t>
+            </a:r>
+            <a:r>
+              <a:rPr sz="2800" dirty="0">
+                <a:solidFill>
+                  <a:srgbClr val="000000"/>
+                </a:solidFill>
+                <a:latin typeface="Calibri"/>
+              </a:rPr>
+              <a:t> demonstrates an end-to-end explainable ICU risk-monitoring workflow from clinical time-series input to dashboard output.</a:t>
             </a:r>
           </a:p>
           <a:p>
@@ -5021,7 +5358,7 @@
               <a:buChar char="•"/>
             </a:pPr>
             <a:r>
-              <a:rPr sz="2600">
+              <a:rPr sz="2800" dirty="0">
                 <a:solidFill>
                   <a:srgbClr val="000000"/>
                 </a:solidFill>
@@ -5038,7 +5375,7 @@
               <a:buChar char="•"/>
             </a:pPr>
             <a:r>
-              <a:rPr sz="2600">
+              <a:rPr sz="2800" dirty="0">
                 <a:solidFill>
                   <a:srgbClr val="000000"/>
                 </a:solidFill>
@@ -5055,7 +5392,7 @@
               <a:buChar char="•"/>
             </a:pPr>
             <a:r>
-              <a:rPr sz="2600">
+              <a:rPr sz="2800" dirty="0">
                 <a:solidFill>
                   <a:srgbClr val="000000"/>
                 </a:solidFill>
@@ -5071,6 +5408,18 @@
   <p:clrMapOvr>
     <a:masterClrMapping/>
   </p:clrMapOvr>
+  <mc:AlternateContent xmlns:mc="http://schemas.openxmlformats.org/markup-compatibility/2006">
+    <mc:Choice xmlns:p159="http://schemas.microsoft.com/office/powerpoint/2015/09/main" Requires="p159">
+      <p:transition xmlns:p14="http://schemas.microsoft.com/office/powerpoint/2010/main" spd="slow" p14:dur="2000">
+        <p159:morph option="byObject"/>
+      </p:transition>
+    </mc:Choice>
+    <mc:Fallback>
+      <p:transition spd="slow">
+        <p:fade/>
+      </p:transition>
+    </mc:Fallback>
+  </mc:AlternateContent>
 </p:sld>
 </file>
 
@@ -5230,7 +5579,7 @@
               <a:buNone/>
             </a:pPr>
             <a:r>
-              <a:rPr sz="3400" b="1">
+              <a:rPr sz="4000" b="1" dirty="0">
                 <a:solidFill>
                   <a:srgbClr val="1757AC"/>
                 </a:solidFill>
@@ -5238,6 +5587,12 @@
               </a:rPr>
               <a:t>REFERENCES</a:t>
             </a:r>
+            <a:endParaRPr sz="3400" b="1" dirty="0">
+              <a:solidFill>
+                <a:srgbClr val="1757AC"/>
+              </a:solidFill>
+              <a:latin typeface="Calibri"/>
+            </a:endParaRPr>
           </a:p>
         </p:txBody>
       </p:sp>
@@ -5249,8 +5604,8 @@
         </p:nvSpPr>
         <p:spPr>
           <a:xfrm>
-            <a:off x="990295" y="3261665"/>
-            <a:ext cx="16303752" cy="6035040"/>
+            <a:off x="990295" y="2894076"/>
+            <a:ext cx="16303752" cy="6402629"/>
           </a:xfrm>
           <a:prstGeom prst="rect">
             <a:avLst/>
@@ -5272,71 +5627,148 @@
               <a:buChar char="•"/>
             </a:pPr>
             <a:r>
-              <a:rPr sz="2000">
+              <a:rPr sz="2400" dirty="0">
                 <a:latin typeface="Calibri"/>
               </a:rPr>
               <a:t>[1] Zheng et al. (2025): Development and Validation of a Dynamic Real-Time Risk Prediction Model for ICU Patients Based on Longitudinal Irregular Data: Multicenter Retrospective Study. JMIR 27:e69293.</a:t>
             </a:r>
-          </a:p>
-          <a:p>
-            <a:r>
-              <a:rPr sz="2000">
+            <a:endParaRPr lang="en-IN" sz="2400" dirty="0">
+              <a:latin typeface="Calibri"/>
+            </a:endParaRPr>
+          </a:p>
+          <a:p>
+            <a:pPr marL="406400" indent="-406400">
+              <a:lnSpc>
+                <a:spcPct val="150000"/>
+              </a:lnSpc>
+              <a:spcAft>
+                <a:spcPts val="1400"/>
+              </a:spcAft>
+              <a:buSzPct val="100000"/>
+              <a:buChar char="•"/>
+            </a:pPr>
+            <a:r>
+              <a:rPr sz="2400" dirty="0">
                 <a:latin typeface="Calibri"/>
               </a:rPr>
               <a:t>[2] Wang, Bai &amp; Jin (2026): Explainable Deep-Learning Models for Predicting ICU Patient Outcome. Frontiers in Physiology 17.</a:t>
             </a:r>
           </a:p>
           <a:p>
-            <a:r>
-              <a:rPr sz="2000">
-                <a:latin typeface="Calibri"/>
-              </a:rPr>
-              <a:t>[3] Yan et al. (2026): Deep Learning-Based In-Hospital Mortality Prediction Using Long-Term Sequential Data in ICU Patients. PeerJ 14:e21631.</a:t>
-            </a:r>
-          </a:p>
-          <a:p>
-            <a:r>
-              <a:rPr sz="2000">
-                <a:latin typeface="Calibri"/>
-              </a:rPr>
-              <a:t>[4] Sadanandan (2026): Multimodal Deep Learning for Early Prediction of Patient Deterioration in the ICU: Integrating Time-Series EHR Data with Clinical Notes. arXiv:2603.14719.</a:t>
-            </a:r>
-          </a:p>
-          <a:p>
-            <a:r>
-              <a:rPr sz="2000">
+            <a:pPr marL="342900" indent="-342900">
+              <a:buFont typeface="Arial" panose="020B0604020202020204" pitchFamily="34" charset="0"/>
+              <a:buChar char="•"/>
+            </a:pPr>
+            <a:r>
+              <a:rPr sz="2400" dirty="0">
+                <a:latin typeface="Calibri"/>
+              </a:rPr>
+              <a:t>[3] Yan et al. (2026): Deep Learning-Based In-Hospital Mortality Prediction Using Long-Term Sequential Data in ICU Patients. </a:t>
+            </a:r>
+            <a:r>
+              <a:rPr sz="2400" dirty="0" err="1">
+                <a:latin typeface="Calibri"/>
+              </a:rPr>
+              <a:t>PeerJ</a:t>
+            </a:r>
+            <a:r>
+              <a:rPr sz="2400" dirty="0">
+                <a:latin typeface="Calibri"/>
+              </a:rPr>
+              <a:t> 14:e21631.</a:t>
+            </a:r>
+          </a:p>
+          <a:p>
+            <a:pPr marL="342900" indent="-342900">
+              <a:buFont typeface="Arial" panose="020B0604020202020204" pitchFamily="34" charset="0"/>
+              <a:buChar char="•"/>
+            </a:pPr>
+            <a:r>
+              <a:rPr sz="2400" dirty="0">
+                <a:latin typeface="Calibri"/>
+              </a:rPr>
+              <a:t>[4] </a:t>
+            </a:r>
+            <a:r>
+              <a:rPr sz="2400" dirty="0" err="1">
+                <a:latin typeface="Calibri"/>
+              </a:rPr>
+              <a:t>Sadanandan</a:t>
+            </a:r>
+            <a:r>
+              <a:rPr sz="2400" dirty="0">
+                <a:latin typeface="Calibri"/>
+              </a:rPr>
+              <a:t> (2026): Multimodal Deep Learning for Early Prediction of Patient Deterioration in the ICU: Integrating Time-Series EHR Data with Clinical Notes. arXiv:2603.14719.</a:t>
+            </a:r>
+          </a:p>
+          <a:p>
+            <a:pPr marL="342900" indent="-342900">
+              <a:buFont typeface="Arial" panose="020B0604020202020204" pitchFamily="34" charset="0"/>
+              <a:buChar char="•"/>
+            </a:pPr>
+            <a:r>
+              <a:rPr sz="2400" dirty="0">
                 <a:latin typeface="Calibri"/>
               </a:rPr>
               <a:t>[5] Wu et al. (2024): Revisiting the Potential Value of Vital Signs in the Real-Time Prediction of Mortality Risk in ICU Patients. J Big Data 11:40.</a:t>
             </a:r>
           </a:p>
           <a:p>
-            <a:r>
-              <a:rPr sz="2000">
-                <a:latin typeface="Calibri"/>
-              </a:rPr>
-              <a:t>[6] Xie et al. (2025): Unlocking the Potential of Real-Time ICU Mortality Prediction: Redefining Risk Assessment with Continuous Data Recovery. npj Digital Medicine 8:733.</a:t>
-            </a:r>
-          </a:p>
-          <a:p>
-            <a:r>
-              <a:rPr sz="2000">
+            <a:pPr marL="342900" indent="-342900">
+              <a:buFont typeface="Arial" panose="020B0604020202020204" pitchFamily="34" charset="0"/>
+              <a:buChar char="•"/>
+            </a:pPr>
+            <a:r>
+              <a:rPr sz="2400" dirty="0">
+                <a:latin typeface="Calibri"/>
+              </a:rPr>
+              <a:t>[6] Xie et al. (2025): Unlocking the Potential of Real-Time ICU Mortality Prediction: Redefining Risk Assessment with Continuous Data Recovery. </a:t>
+            </a:r>
+            <a:r>
+              <a:rPr sz="2400" dirty="0" err="1">
+                <a:latin typeface="Calibri"/>
+              </a:rPr>
+              <a:t>npj</a:t>
+            </a:r>
+            <a:r>
+              <a:rPr sz="2400" dirty="0">
+                <a:latin typeface="Calibri"/>
+              </a:rPr>
+              <a:t> Digital Medicine 8:733.</a:t>
+            </a:r>
+          </a:p>
+          <a:p>
+            <a:pPr marL="342900" indent="-342900">
+              <a:buFont typeface="Arial" panose="020B0604020202020204" pitchFamily="34" charset="0"/>
+              <a:buChar char="•"/>
+            </a:pPr>
+            <a:r>
+              <a:rPr sz="2400" dirty="0">
                 <a:latin typeface="Calibri"/>
               </a:rPr>
               <a:t>[7] Choi et al. (2020): Deep Interpretable Early Warning System for the Detection of Clinical Deterioration. IEEE J-BHI 24(9).</a:t>
             </a:r>
           </a:p>
           <a:p>
-            <a:r>
-              <a:rPr sz="2000">
+            <a:pPr marL="342900" indent="-342900">
+              <a:buFont typeface="Arial" panose="020B0604020202020204" pitchFamily="34" charset="0"/>
+              <a:buChar char="•"/>
+            </a:pPr>
+            <a:r>
+              <a:rPr sz="2400" dirty="0">
                 <a:latin typeface="Calibri"/>
               </a:rPr>
               <a:t>[8] Scheid et al. (2025): Development and Validation of a Clinical Wearable Deep Learning Based Continuous In-Hospital Deterioration Prediction Model. Nature Communications 16:9513.</a:t>
             </a:r>
           </a:p>
           <a:p>
-            <a:r>
-              <a:rPr sz="2000">
+            <a:pPr marL="342900" indent="-342900">
+              <a:buFont typeface="Arial" panose="020B0604020202020204" pitchFamily="34" charset="0"/>
+              <a:buChar char="•"/>
+            </a:pPr>
+            <a:r>
+              <a:rPr sz="2400" dirty="0">
                 <a:latin typeface="Calibri"/>
               </a:rPr>
               <a:t>[9] PhysioNet (2012): Computing in Cardiology Challenge 2012 dataset. physionet.org/content/challenge-2012.</a:t>
@@ -5349,6 +5781,18 @@
   <p:clrMapOvr>
     <a:masterClrMapping/>
   </p:clrMapOvr>
+  <mc:AlternateContent xmlns:mc="http://schemas.openxmlformats.org/markup-compatibility/2006">
+    <mc:Choice xmlns:p159="http://schemas.microsoft.com/office/powerpoint/2015/09/main" Requires="p159">
+      <p:transition xmlns:p14="http://schemas.microsoft.com/office/powerpoint/2010/main" spd="slow" p14:dur="2000">
+        <p159:morph option="byObject"/>
+      </p:transition>
+    </mc:Choice>
+    <mc:Fallback>
+      <p:transition spd="slow">
+        <p:fade/>
+      </p:transition>
+    </mc:Fallback>
+  </mc:AlternateContent>
 </p:sld>
 </file>
 
@@ -5524,6 +5968,18 @@
   <p:clrMapOvr>
     <a:masterClrMapping/>
   </p:clrMapOvr>
+  <mc:AlternateContent xmlns:mc="http://schemas.openxmlformats.org/markup-compatibility/2006">
+    <mc:Choice xmlns:p159="http://schemas.microsoft.com/office/powerpoint/2015/09/main" Requires="p159">
+      <p:transition xmlns:p14="http://schemas.microsoft.com/office/powerpoint/2010/main" spd="slow" p14:dur="2000">
+        <p159:morph option="byObject"/>
+      </p:transition>
+    </mc:Choice>
+    <mc:Fallback>
+      <p:transition spd="slow">
+        <p:fade/>
+      </p:transition>
+    </mc:Fallback>
+  </mc:AlternateContent>
 </p:sld>
 </file>
 
@@ -5788,6 +6244,18 @@
   <p:clrMapOvr>
     <a:masterClrMapping/>
   </p:clrMapOvr>
+  <mc:AlternateContent xmlns:mc="http://schemas.openxmlformats.org/markup-compatibility/2006">
+    <mc:Choice xmlns:p159="http://schemas.microsoft.com/office/powerpoint/2015/09/main" Requires="p159">
+      <p:transition xmlns:p14="http://schemas.microsoft.com/office/powerpoint/2010/main" spd="slow" p14:dur="2000">
+        <p159:morph option="byObject"/>
+      </p:transition>
+    </mc:Choice>
+    <mc:Fallback>
+      <p:transition spd="slow">
+        <p:fade/>
+      </p:transition>
+    </mc:Fallback>
+  </mc:AlternateContent>
 </p:sld>
 </file>
 
@@ -5931,7 +6399,7 @@
         </p:nvSpPr>
         <p:spPr>
           <a:xfrm>
-            <a:off x="914400" y="1979676"/>
+            <a:off x="914400" y="1968101"/>
             <a:ext cx="16459200" cy="914400"/>
           </a:xfrm>
           <a:prstGeom prst="rect">
@@ -5947,7 +6415,7 @@
               <a:buNone/>
             </a:pPr>
             <a:r>
-              <a:rPr sz="3400" b="1">
+              <a:rPr sz="4000" b="1" dirty="0">
                 <a:solidFill>
                   <a:srgbClr val="1757AC"/>
                 </a:solidFill>
@@ -5989,7 +6457,7 @@
               <a:buChar char="•"/>
             </a:pPr>
             <a:r>
-              <a:rPr sz="2600">
+              <a:rPr sz="2800" dirty="0">
                 <a:solidFill>
                   <a:srgbClr val="000000"/>
                 </a:solidFill>
@@ -5999,8 +6467,12 @@
             </a:r>
           </a:p>
           <a:p>
-            <a:r>
-              <a:rPr sz="2600">
+            <a:pPr marL="457200" indent="-457200">
+              <a:buFont typeface="Arial" panose="020B0604020202020204" pitchFamily="34" charset="0"/>
+              <a:buChar char="•"/>
+            </a:pPr>
+            <a:r>
+              <a:rPr sz="2800" dirty="0">
                 <a:solidFill>
                   <a:srgbClr val="000000"/>
                 </a:solidFill>
@@ -6010,26 +6482,58 @@
             </a:r>
           </a:p>
           <a:p>
-            <a:r>
-              <a:rPr sz="2600">
+            <a:pPr marL="457200" indent="-457200">
+              <a:buFont typeface="Arial" panose="020B0604020202020204" pitchFamily="34" charset="0"/>
+              <a:buChar char="•"/>
+            </a:pPr>
+            <a:r>
+              <a:rPr sz="2800" dirty="0" err="1">
                 <a:solidFill>
                   <a:srgbClr val="000000"/>
                 </a:solidFill>
                 <a:latin typeface="Calibri"/>
               </a:rPr>
-              <a:t>SynCura applies temporal deep learning to streaming-style vital and clinical measurements.</a:t>
-            </a:r>
-          </a:p>
-          <a:p>
-            <a:r>
-              <a:rPr sz="2600">
+              <a:t>SynCura</a:t>
+            </a:r>
+            <a:r>
+              <a:rPr sz="2800" dirty="0">
                 <a:solidFill>
                   <a:srgbClr val="000000"/>
                 </a:solidFill>
                 <a:latin typeface="Calibri"/>
               </a:rPr>
+              <a:t> applies temporal deep learning to streaming-style vital and clinical measurements.</a:t>
+            </a:r>
+          </a:p>
+          <a:p>
+            <a:pPr marL="457200" indent="-457200">
+              <a:buFont typeface="Arial" panose="020B0604020202020204" pitchFamily="34" charset="0"/>
+              <a:buChar char="•"/>
+            </a:pPr>
+            <a:r>
+              <a:rPr sz="2800" dirty="0">
+                <a:solidFill>
+                  <a:srgbClr val="000000"/>
+                </a:solidFill>
+                <a:latin typeface="Calibri"/>
+              </a:rPr>
               <a:t>The project focuses on an explainable software prototype, not autonomous clinical decision-making.</a:t>
             </a:r>
+            <a:r>
+              <a:rPr lang="en-IN" sz="2800" dirty="0">
+                <a:solidFill>
+                  <a:srgbClr val="000000"/>
+                </a:solidFill>
+                <a:latin typeface="Calibri"/>
+              </a:rPr>
+              <a:t>	1</a:t>
+            </a:r>
+            <a:endParaRPr sz="2800" dirty="0">
+              <a:solidFill>
+                <a:srgbClr val="000000"/>
+              </a:solidFill>
+              <a:latin typeface="Calibri"/>
+            </a:endParaRPr>
           </a:p>
         </p:txBody>
       </p:sp>
@@ -6038,6 +6542,18 @@
   <p:clrMapOvr>
     <a:masterClrMapping/>
   </p:clrMapOvr>
+  <mc:AlternateContent xmlns:mc="http://schemas.openxmlformats.org/markup-compatibility/2006">
+    <mc:Choice xmlns:p159="http://schemas.microsoft.com/office/powerpoint/2015/09/main" Requires="p159">
+      <p:transition xmlns:p14="http://schemas.microsoft.com/office/powerpoint/2010/main" spd="slow" p14:dur="2000">
+        <p159:morph option="byObject"/>
+      </p:transition>
+    </mc:Choice>
+    <mc:Fallback>
+      <p:transition spd="slow">
+        <p:fade/>
+      </p:transition>
+    </mc:Fallback>
+  </mc:AlternateContent>
 </p:sld>
 </file>
 
@@ -6197,7 +6713,7 @@
               <a:buNone/>
             </a:pPr>
             <a:r>
-              <a:rPr sz="3400" b="1">
+              <a:rPr sz="4000" b="1" dirty="0">
                 <a:solidFill>
                   <a:srgbClr val="1757AC"/>
                 </a:solidFill>
@@ -6239,71 +6755,187 @@
               <a:buChar char="•"/>
             </a:pPr>
             <a:r>
-              <a:rPr sz="2200">
-                <a:latin typeface="Calibri"/>
-              </a:rPr>
-              <a:t>Base paper: Zheng et al. (2025) - Temporal-Branch Attention LSTM (TBAL), MIMIC-IV + eICU, dynamic AUROC ~0.936. SynCura adapts TBAL to PhysioNet 2012.</a:t>
-            </a:r>
-          </a:p>
-          <a:p>
-            <a:r>
-              <a:rPr sz="2200">
-                <a:latin typeface="Calibri"/>
-              </a:rPr>
-              <a:t>Support 1: Yan et al. (2026) - single LSTM, multi-centre ICU, AUC 0.802.</a:t>
-            </a:r>
-          </a:p>
-          <a:p>
-            <a:r>
-              <a:rPr sz="2200">
-                <a:latin typeface="Calibri"/>
-              </a:rPr>
-              <a:t>Support 2: Sadanandan (2026) - multimodal LSTM + ClinicalBERT, AUROC 0.786.</a:t>
-            </a:r>
-          </a:p>
-          <a:p>
-            <a:r>
-              <a:rPr sz="2200">
+              <a:rPr sz="2400" dirty="0">
+                <a:latin typeface="Calibri"/>
+              </a:rPr>
+              <a:t>Base paper: Zheng et al. (2025) - Temporal-Branch Attention LSTM (TBAL), MIMIC-IV + </a:t>
+            </a:r>
+            <a:r>
+              <a:rPr sz="2400" dirty="0" err="1">
+                <a:latin typeface="Calibri"/>
+              </a:rPr>
+              <a:t>eICU</a:t>
+            </a:r>
+            <a:r>
+              <a:rPr sz="2400" dirty="0">
+                <a:latin typeface="Calibri"/>
+              </a:rPr>
+              <a:t>, dynamic AUROC ~0.936. </a:t>
+            </a:r>
+            <a:r>
+              <a:rPr sz="2400" dirty="0" err="1">
+                <a:latin typeface="Calibri"/>
+              </a:rPr>
+              <a:t>SynCura</a:t>
+            </a:r>
+            <a:r>
+              <a:rPr sz="2400" dirty="0">
+                <a:latin typeface="Calibri"/>
+              </a:rPr>
+              <a:t> adapts TBAL to PhysioNet 2012.</a:t>
+            </a:r>
+          </a:p>
+          <a:p>
+            <a:pPr marL="342900" indent="-342900">
+              <a:buFont typeface="Courier New" panose="02070309020205020404" pitchFamily="49" charset="0"/>
+              <a:buChar char="o"/>
+            </a:pPr>
+            <a:r>
+              <a:rPr sz="2400" dirty="0">
+                <a:latin typeface="Calibri"/>
+              </a:rPr>
+              <a:t>Support 1: Yan et al. (2026) - single LSTM, multi-</a:t>
+            </a:r>
+            <a:r>
+              <a:rPr sz="2400" dirty="0" err="1">
+                <a:latin typeface="Calibri"/>
+              </a:rPr>
+              <a:t>centre</a:t>
+            </a:r>
+            <a:r>
+              <a:rPr sz="2400" dirty="0">
+                <a:latin typeface="Calibri"/>
+              </a:rPr>
+              <a:t> ICU, AUC 0.802.</a:t>
+            </a:r>
+          </a:p>
+          <a:p>
+            <a:pPr marL="342900" indent="-342900">
+              <a:buFont typeface="Courier New" panose="02070309020205020404" pitchFamily="49" charset="0"/>
+              <a:buChar char="o"/>
+            </a:pPr>
+            <a:r>
+              <a:rPr sz="2400" dirty="0">
+                <a:latin typeface="Calibri"/>
+              </a:rPr>
+              <a:t>Support 2: </a:t>
+            </a:r>
+            <a:r>
+              <a:rPr sz="2400" dirty="0" err="1">
+                <a:latin typeface="Calibri"/>
+              </a:rPr>
+              <a:t>Sadanandan</a:t>
+            </a:r>
+            <a:r>
+              <a:rPr sz="2400" dirty="0">
+                <a:latin typeface="Calibri"/>
+              </a:rPr>
+              <a:t> (2026) - multimodal LSTM + </a:t>
+            </a:r>
+            <a:r>
+              <a:rPr sz="2400" dirty="0" err="1">
+                <a:latin typeface="Calibri"/>
+              </a:rPr>
+              <a:t>ClinicalBERT</a:t>
+            </a:r>
+            <a:r>
+              <a:rPr sz="2400" dirty="0">
+                <a:latin typeface="Calibri"/>
+              </a:rPr>
+              <a:t>, AUROC 0.786.</a:t>
+            </a:r>
+          </a:p>
+          <a:p>
+            <a:pPr marL="342900" indent="-342900">
+              <a:buFont typeface="Courier New" panose="02070309020205020404" pitchFamily="49" charset="0"/>
+              <a:buChar char="o"/>
+            </a:pPr>
+            <a:r>
+              <a:rPr sz="2400" dirty="0">
                 <a:latin typeface="Calibri"/>
               </a:rPr>
               <a:t>Support 3: Wu et al. (2024) - vital-signs-only LSTM, AUC 0.926.</a:t>
             </a:r>
           </a:p>
           <a:p>
-            <a:r>
-              <a:rPr sz="2200">
-                <a:latin typeface="Calibri"/>
-              </a:rPr>
-              <a:t>Support 4: Xie et al. (2025) - RealMIP missing-data recovery, AUC 0.957-0.968.</a:t>
-            </a:r>
-          </a:p>
-          <a:p>
-            <a:r>
-              <a:rPr sz="2200">
-                <a:latin typeface="Calibri"/>
-              </a:rPr>
-              <a:t>Support 5: Choi et al. (2020) - interpretable BiLSTM early-warning, AUROC ~0.880.</a:t>
-            </a:r>
-          </a:p>
-          <a:p>
-            <a:r>
-              <a:rPr sz="2200">
+            <a:pPr marL="342900" indent="-342900">
+              <a:buFont typeface="Courier New" panose="02070309020205020404" pitchFamily="49" charset="0"/>
+              <a:buChar char="o"/>
+            </a:pPr>
+            <a:r>
+              <a:rPr sz="2400" dirty="0">
+                <a:latin typeface="Calibri"/>
+              </a:rPr>
+              <a:t>Support 4: Xie et al. (2025) - </a:t>
+            </a:r>
+            <a:r>
+              <a:rPr sz="2400" dirty="0" err="1">
+                <a:latin typeface="Calibri"/>
+              </a:rPr>
+              <a:t>RealMIP</a:t>
+            </a:r>
+            <a:r>
+              <a:rPr sz="2400" dirty="0">
+                <a:latin typeface="Calibri"/>
+              </a:rPr>
+              <a:t> missing-data recovery, AUC 0.957-0.968.</a:t>
+            </a:r>
+          </a:p>
+          <a:p>
+            <a:pPr marL="342900" indent="-342900">
+              <a:buFont typeface="Courier New" panose="02070309020205020404" pitchFamily="49" charset="0"/>
+              <a:buChar char="o"/>
+            </a:pPr>
+            <a:r>
+              <a:rPr sz="2400" dirty="0">
+                <a:latin typeface="Calibri"/>
+              </a:rPr>
+              <a:t>Support 5: Choi et al. (2020) - interpretable </a:t>
+            </a:r>
+            <a:r>
+              <a:rPr sz="2400" dirty="0" err="1">
+                <a:latin typeface="Calibri"/>
+              </a:rPr>
+              <a:t>BiLSTM</a:t>
+            </a:r>
+            <a:r>
+              <a:rPr sz="2400" dirty="0">
+                <a:latin typeface="Calibri"/>
+              </a:rPr>
+              <a:t> early-warning, AUROC ~0.880.</a:t>
+            </a:r>
+          </a:p>
+          <a:p>
+            <a:pPr marL="342900" indent="-342900">
+              <a:buFont typeface="Courier New" panose="02070309020205020404" pitchFamily="49" charset="0"/>
+              <a:buChar char="o"/>
+            </a:pPr>
+            <a:r>
+              <a:rPr sz="2400" dirty="0">
                 <a:latin typeface="Calibri"/>
               </a:rPr>
               <a:t>Support 6: Scheid et al. (2025) - continuous wearable deep learning, AUROC ~0.890.</a:t>
             </a:r>
           </a:p>
           <a:p>
-            <a:r>
-              <a:rPr sz="2200">
+            <a:pPr marL="342900" indent="-342900">
+              <a:buFont typeface="Courier New" panose="02070309020205020404" pitchFamily="49" charset="0"/>
+              <a:buChar char="o"/>
+            </a:pPr>
+            <a:r>
+              <a:rPr sz="2400" dirty="0">
                 <a:latin typeface="Calibri"/>
               </a:rPr>
               <a:t>Support 7: Wang, Bai &amp; Jin (2026) - explainable LSTM, AUC 0.79-0.87.</a:t>
             </a:r>
           </a:p>
           <a:p>
-            <a:r>
-              <a:rPr sz="2200">
+            <a:pPr marL="342900" indent="-342900">
+              <a:buFont typeface="Courier New" panose="02070309020205020404" pitchFamily="49" charset="0"/>
+              <a:buChar char="o"/>
+            </a:pPr>
+            <a:r>
+              <a:rPr sz="2400" dirty="0">
                 <a:latin typeface="Calibri"/>
               </a:rPr>
               <a:t>Gap: models report single AUC only; few validate on unseen patients; none ship a real-time explainable risk path.</a:t>
@@ -6316,6 +6948,18 @@
   <p:clrMapOvr>
     <a:masterClrMapping/>
   </p:clrMapOvr>
+  <mc:AlternateContent xmlns:mc="http://schemas.openxmlformats.org/markup-compatibility/2006">
+    <mc:Choice xmlns:p159="http://schemas.microsoft.com/office/powerpoint/2015/09/main" Requires="p159">
+      <p:transition xmlns:p14="http://schemas.microsoft.com/office/powerpoint/2010/main" spd="slow" p14:dur="2000">
+        <p159:morph option="byObject"/>
+      </p:transition>
+    </mc:Choice>
+    <mc:Fallback>
+      <p:transition spd="slow">
+        <p:fade/>
+      </p:transition>
+    </mc:Fallback>
+  </mc:AlternateContent>
 </p:sld>
 </file>
 
@@ -6475,7 +7119,7 @@
               <a:buNone/>
             </a:pPr>
             <a:r>
-              <a:rPr sz="3400" b="1">
+              <a:rPr sz="4000" b="1" dirty="0">
                 <a:solidFill>
                   <a:srgbClr val="1757AC"/>
                 </a:solidFill>
@@ -6517,47 +7161,82 @@
               <a:buChar char="•"/>
             </a:pPr>
             <a:r>
-              <a:rPr sz="2400">
+              <a:rPr sz="2800" dirty="0">
                 <a:latin typeface="Calibri"/>
               </a:rPr>
               <a:t>Title: Development and Validation of a Dynamic Real-Time Risk Prediction Model for ICU Patients based on Longitudinal Irregular Data</a:t>
             </a:r>
           </a:p>
           <a:p>
-            <a:r>
-              <a:rPr sz="2400">
+            <a:pPr marL="342900" indent="-342900">
+              <a:buFont typeface="Wingdings" panose="05000000000000000000" pitchFamily="2" charset="2"/>
+              <a:buChar char="§"/>
+            </a:pPr>
+            <a:r>
+              <a:rPr sz="2800" dirty="0">
                 <a:latin typeface="Calibri"/>
               </a:rPr>
               <a:t>Authors: Zheng et al. (2025) - JMIR vol. 27, e69293</a:t>
             </a:r>
           </a:p>
           <a:p>
-            <a:r>
-              <a:rPr sz="2400">
-                <a:latin typeface="Calibri"/>
-              </a:rPr>
-              <a:t>Method: Temporal-Branch Attention LSTM (TBAL); longitudinal irregular EHR; MIMIC-IV + eICU</a:t>
-            </a:r>
-          </a:p>
-          <a:p>
-            <a:r>
-              <a:rPr sz="2400">
+            <a:pPr marL="342900" indent="-342900">
+              <a:buFont typeface="Wingdings" panose="05000000000000000000" pitchFamily="2" charset="2"/>
+              <a:buChar char="§"/>
+            </a:pPr>
+            <a:r>
+              <a:rPr sz="2800" dirty="0">
+                <a:latin typeface="Calibri"/>
+              </a:rPr>
+              <a:t>Method: Temporal-Branch Attention LSTM (TBAL); longitudinal irregular EHR; MIMIC-IV + </a:t>
+            </a:r>
+            <a:r>
+              <a:rPr sz="2800" dirty="0" err="1">
+                <a:latin typeface="Calibri"/>
+              </a:rPr>
+              <a:t>eICU</a:t>
+            </a:r>
+            <a:endParaRPr sz="2800" dirty="0">
+              <a:latin typeface="Calibri"/>
+            </a:endParaRPr>
+          </a:p>
+          <a:p>
+            <a:pPr marL="342900" indent="-342900">
+              <a:buFont typeface="Wingdings" panose="05000000000000000000" pitchFamily="2" charset="2"/>
+              <a:buChar char="§"/>
+            </a:pPr>
+            <a:r>
+              <a:rPr sz="2800" dirty="0">
                 <a:latin typeface="Calibri"/>
               </a:rPr>
               <a:t>Dynamic AUROC ~0.936; static ~0.812; recall 79.1%</a:t>
             </a:r>
           </a:p>
           <a:p>
-            <a:r>
-              <a:rPr sz="2400">
-                <a:latin typeface="Calibri"/>
-              </a:rPr>
-              <a:t>SynCura adapts TBAL: 90-min rolling window, 12 features, temporal attention, PhysioNet 2012</a:t>
-            </a:r>
-          </a:p>
-          <a:p>
-            <a:r>
-              <a:rPr sz="2400">
+            <a:pPr marL="342900" indent="-342900">
+              <a:buFont typeface="Wingdings" panose="05000000000000000000" pitchFamily="2" charset="2"/>
+              <a:buChar char="§"/>
+            </a:pPr>
+            <a:r>
+              <a:rPr sz="2800" dirty="0" err="1">
+                <a:latin typeface="Calibri"/>
+              </a:rPr>
+              <a:t>SynCura</a:t>
+            </a:r>
+            <a:r>
+              <a:rPr sz="2800" dirty="0">
+                <a:latin typeface="Calibri"/>
+              </a:rPr>
+              <a:t> adapts TBAL: 90-min rolling window, 12 features, temporal attention, PhysioNet 2012</a:t>
+            </a:r>
+          </a:p>
+          <a:p>
+            <a:pPr marL="342900" indent="-342900">
+              <a:buFont typeface="Wingdings" panose="05000000000000000000" pitchFamily="2" charset="2"/>
+              <a:buChar char="§"/>
+            </a:pPr>
+            <a:r>
+              <a:rPr sz="2800" dirty="0">
                 <a:latin typeface="Calibri"/>
               </a:rPr>
               <a:t>Caution - hindsight bias: with retrospective data till discharge AUROC rises to 0.989 (future info); cross-hospital drops to 0.81</a:t>
@@ -6570,6 +7249,18 @@
   <p:clrMapOvr>
     <a:masterClrMapping/>
   </p:clrMapOvr>
+  <mc:AlternateContent xmlns:mc="http://schemas.openxmlformats.org/markup-compatibility/2006">
+    <mc:Choice xmlns:p159="http://schemas.microsoft.com/office/powerpoint/2015/09/main" Requires="p159">
+      <p:transition xmlns:p14="http://schemas.microsoft.com/office/powerpoint/2010/main" spd="slow" p14:dur="2000">
+        <p159:morph option="byObject"/>
+      </p:transition>
+    </mc:Choice>
+    <mc:Fallback>
+      <p:transition spd="slow">
+        <p:fade/>
+      </p:transition>
+    </mc:Fallback>
+  </mc:AlternateContent>
 </p:sld>
 </file>
 
@@ -6729,7 +7420,7 @@
               <a:buNone/>
             </a:pPr>
             <a:r>
-              <a:rPr sz="3400" b="1">
+              <a:rPr sz="4000" b="1" dirty="0">
                 <a:solidFill>
                   <a:srgbClr val="1757AC"/>
                 </a:solidFill>
@@ -6748,8 +7439,8 @@
         </p:nvSpPr>
         <p:spPr>
           <a:xfrm>
-            <a:off x="990295" y="3261665"/>
-            <a:ext cx="11873493" cy="6035040"/>
+            <a:off x="990296" y="3261665"/>
+            <a:ext cx="11394616" cy="6035040"/>
           </a:xfrm>
           <a:prstGeom prst="rect">
             <a:avLst/>
@@ -6771,7 +7462,7 @@
               <a:buChar char="•"/>
             </a:pPr>
             <a:r>
-              <a:rPr sz="2500">
+              <a:rPr sz="2500" dirty="0">
                 <a:solidFill>
                   <a:srgbClr val="000000"/>
                 </a:solidFill>
@@ -6788,7 +7479,7 @@
               <a:buChar char="•"/>
             </a:pPr>
             <a:r>
-              <a:rPr sz="2500">
+              <a:rPr sz="2500" dirty="0">
                 <a:solidFill>
                   <a:srgbClr val="000000"/>
                 </a:solidFill>
@@ -6805,7 +7496,7 @@
               <a:buChar char="•"/>
             </a:pPr>
             <a:r>
-              <a:rPr sz="2500">
+              <a:rPr sz="2500" dirty="0">
                 <a:solidFill>
                   <a:srgbClr val="000000"/>
                 </a:solidFill>
@@ -6822,13 +7513,31 @@
               <a:buChar char="•"/>
             </a:pPr>
             <a:r>
-              <a:rPr sz="2500">
+              <a:rPr sz="2500" dirty="0">
                 <a:solidFill>
                   <a:srgbClr val="000000"/>
                 </a:solidFill>
                 <a:latin typeface="Calibri"/>
               </a:rPr>
-              <a:t>Deployable path: FastAPI alerting, HTTP/MQTT ingestion; misses/false alarms queue into weighted retraining.</a:t>
+              <a:t>Deployable path: </a:t>
+            </a:r>
+            <a:r>
+              <a:rPr sz="2500" dirty="0" err="1">
+                <a:solidFill>
+                  <a:srgbClr val="000000"/>
+                </a:solidFill>
+                <a:latin typeface="Calibri"/>
+              </a:rPr>
+              <a:t>FastAPI</a:t>
+            </a:r>
+            <a:r>
+              <a:rPr sz="2500" dirty="0">
+                <a:solidFill>
+                  <a:srgbClr val="000000"/>
+                </a:solidFill>
+                <a:latin typeface="Calibri"/>
+              </a:rPr>
+              <a:t> alerting, HTTP/MQTT ingestion; misses/false alarms queue into weighted retraining.</a:t>
             </a:r>
           </a:p>
         </p:txBody>
@@ -6849,8 +7558,8 @@
         </p:blipFill>
         <p:spPr>
           <a:xfrm>
-            <a:off x="13000948" y="4160520"/>
-            <a:ext cx="4967012" cy="3566160"/>
+            <a:off x="12226343" y="3040844"/>
+            <a:ext cx="6061657" cy="4352081"/>
           </a:xfrm>
           <a:prstGeom prst="rect">
             <a:avLst/>
@@ -6862,6 +7571,18 @@
   <p:clrMapOvr>
     <a:masterClrMapping/>
   </p:clrMapOvr>
+  <mc:AlternateContent xmlns:mc="http://schemas.openxmlformats.org/markup-compatibility/2006">
+    <mc:Choice xmlns:p159="http://schemas.microsoft.com/office/powerpoint/2015/09/main" Requires="p159">
+      <p:transition xmlns:p14="http://schemas.microsoft.com/office/powerpoint/2010/main" spd="slow" p14:dur="2000">
+        <p159:morph option="byObject"/>
+      </p:transition>
+    </mc:Choice>
+    <mc:Fallback>
+      <p:transition spd="slow">
+        <p:fade/>
+      </p:transition>
+    </mc:Fallback>
+  </mc:AlternateContent>
 </p:sld>
 </file>
 
@@ -7021,7 +7742,7 @@
               <a:buNone/>
             </a:pPr>
             <a:r>
-              <a:rPr sz="3400" b="1">
+              <a:rPr sz="4000" b="1" dirty="0">
                 <a:solidFill>
                   <a:srgbClr val="1757AC"/>
                 </a:solidFill>
@@ -7603,6 +8324,18 @@
   <p:clrMapOvr>
     <a:masterClrMapping/>
   </p:clrMapOvr>
+  <mc:AlternateContent xmlns:mc="http://schemas.openxmlformats.org/markup-compatibility/2006">
+    <mc:Choice xmlns:p159="http://schemas.microsoft.com/office/powerpoint/2015/09/main" Requires="p159">
+      <p:transition xmlns:p14="http://schemas.microsoft.com/office/powerpoint/2010/main" spd="slow" p14:dur="2000">
+        <p159:morph option="byObject"/>
+      </p:transition>
+    </mc:Choice>
+    <mc:Fallback>
+      <p:transition spd="slow">
+        <p:fade/>
+      </p:transition>
+    </mc:Fallback>
+  </mc:AlternateContent>
 </p:sld>
 </file>
 
@@ -7762,7 +8495,7 @@
               <a:buNone/>
             </a:pPr>
             <a:r>
-              <a:rPr sz="3400" b="1">
+              <a:rPr sz="4000" b="1" dirty="0">
                 <a:solidFill>
                   <a:srgbClr val="1757AC"/>
                 </a:solidFill>
@@ -7888,6 +8621,18 @@
   <p:clrMapOvr>
     <a:masterClrMapping/>
   </p:clrMapOvr>
+  <mc:AlternateContent xmlns:mc="http://schemas.openxmlformats.org/markup-compatibility/2006">
+    <mc:Choice xmlns:p159="http://schemas.microsoft.com/office/powerpoint/2015/09/main" Requires="p159">
+      <p:transition xmlns:p14="http://schemas.microsoft.com/office/powerpoint/2010/main" spd="slow" p14:dur="2000">
+        <p159:morph option="byObject"/>
+      </p:transition>
+    </mc:Choice>
+    <mc:Fallback>
+      <p:transition spd="slow">
+        <p:fade/>
+      </p:transition>
+    </mc:Fallback>
+  </mc:AlternateContent>
 </p:sld>
 </file>
 
@@ -8067,7 +8812,7 @@
         <p:spPr>
           <a:xfrm>
             <a:off x="960120" y="3337560"/>
-            <a:ext cx="3063240" cy="4754880"/>
+            <a:ext cx="3700370" cy="4754880"/>
           </a:xfrm>
           <a:prstGeom prst="rect">
             <a:avLst/>
@@ -8089,7 +8834,7 @@
               <a:buChar char="•"/>
             </a:pPr>
             <a:r>
-              <a:rPr sz="2100">
+              <a:rPr sz="2200" dirty="0">
                 <a:solidFill>
                   <a:srgbClr val="000000"/>
                 </a:solidFill>
@@ -8106,7 +8851,7 @@
               <a:buChar char="•"/>
             </a:pPr>
             <a:r>
-              <a:rPr sz="2100">
+              <a:rPr sz="2200" dirty="0">
                 <a:solidFill>
                   <a:srgbClr val="000000"/>
                 </a:solidFill>
@@ -8123,7 +8868,7 @@
               <a:buChar char="•"/>
             </a:pPr>
             <a:r>
-              <a:rPr sz="2100">
+              <a:rPr sz="2200" dirty="0">
                 <a:solidFill>
                   <a:srgbClr val="000000"/>
                 </a:solidFill>
@@ -8150,8 +8895,8 @@
         </p:blipFill>
         <p:spPr>
           <a:xfrm>
-            <a:off x="4072597" y="5074920"/>
-            <a:ext cx="4480560" cy="3920490"/>
+            <a:off x="5220929" y="2743200"/>
+            <a:ext cx="6413166" cy="5611520"/>
           </a:xfrm>
           <a:prstGeom prst="rect">
             <a:avLst/>
@@ -8168,14 +8913,15 @@
         </p:nvPicPr>
         <p:blipFill>
           <a:blip r:embed="rId6"/>
+          <a:srcRect b="44821"/>
           <a:stretch>
             <a:fillRect/>
           </a:stretch>
         </p:blipFill>
         <p:spPr>
           <a:xfrm>
-            <a:off x="9010357" y="5394960"/>
-            <a:ext cx="5205046" cy="3383280"/>
+            <a:off x="11739719" y="2587531"/>
+            <a:ext cx="6411122" cy="2299429"/>
           </a:xfrm>
           <a:prstGeom prst="rect">
             <a:avLst/>
@@ -8187,6 +8933,18 @@
   <p:clrMapOvr>
     <a:masterClrMapping/>
   </p:clrMapOvr>
+  <mc:AlternateContent xmlns:mc="http://schemas.openxmlformats.org/markup-compatibility/2006">
+    <mc:Choice xmlns:p159="http://schemas.microsoft.com/office/powerpoint/2015/09/main" Requires="p159">
+      <p:transition xmlns:p14="http://schemas.microsoft.com/office/powerpoint/2010/main" spd="slow" p14:dur="2000">
+        <p159:morph option="byObject"/>
+      </p:transition>
+    </mc:Choice>
+    <mc:Fallback>
+      <p:transition spd="slow">
+        <p:fade/>
+      </p:transition>
+    </mc:Fallback>
+  </mc:AlternateContent>
 </p:sld>
 </file>
 

</xml_diff>

<commit_message>
add literature review document with findings table
</commit_message>
<xml_diff>
--- a/ppt/SynCura_Deck_V3_FINAL.pptx
+++ b/ppt/SynCura_Deck_V3_FINAL.pptx
@@ -375,13 +375,13 @@
   <p:clrMapOvr>
     <a:masterClrMapping/>
   </p:clrMapOvr>
-  <mc:AlternateContent xmlns:mc="http://schemas.openxmlformats.org/markup-compatibility/2006">
-    <mc:Choice xmlns:p159="http://schemas.microsoft.com/office/powerpoint/2015/09/main" Requires="p159">
+  <mc:AlternateContent xmlns:mc="http://schemas.openxmlformats.org/markup-compatibility/2006" xmlns:p159="http://schemas.microsoft.com/office/powerpoint/2015/09/main">
+    <mc:Choice Requires="p159">
       <p:transition xmlns:p14="http://schemas.microsoft.com/office/powerpoint/2010/main" spd="slow" p14:dur="2000">
         <p159:morph option="byObject"/>
       </p:transition>
     </mc:Choice>
-    <mc:Fallback>
+    <mc:Fallback xmlns="">
       <p:transition spd="slow">
         <p:fade/>
       </p:transition>
@@ -555,13 +555,13 @@
   <p:clrMapOvr>
     <a:masterClrMapping/>
   </p:clrMapOvr>
-  <mc:AlternateContent xmlns:mc="http://schemas.openxmlformats.org/markup-compatibility/2006">
-    <mc:Choice xmlns:p159="http://schemas.microsoft.com/office/powerpoint/2015/09/main" Requires="p159">
+  <mc:AlternateContent xmlns:mc="http://schemas.openxmlformats.org/markup-compatibility/2006" xmlns:p159="http://schemas.microsoft.com/office/powerpoint/2015/09/main">
+    <mc:Choice Requires="p159">
       <p:transition xmlns:p14="http://schemas.microsoft.com/office/powerpoint/2010/main" spd="slow" p14:dur="2000">
         <p159:morph option="byObject"/>
       </p:transition>
     </mc:Choice>
-    <mc:Fallback>
+    <mc:Fallback xmlns="">
       <p:transition spd="slow">
         <p:fade/>
       </p:transition>
@@ -745,13 +745,13 @@
   <p:clrMapOvr>
     <a:masterClrMapping/>
   </p:clrMapOvr>
-  <mc:AlternateContent xmlns:mc="http://schemas.openxmlformats.org/markup-compatibility/2006">
-    <mc:Choice xmlns:p159="http://schemas.microsoft.com/office/powerpoint/2015/09/main" Requires="p159">
+  <mc:AlternateContent xmlns:mc="http://schemas.openxmlformats.org/markup-compatibility/2006" xmlns:p159="http://schemas.microsoft.com/office/powerpoint/2015/09/main">
+    <mc:Choice Requires="p159">
       <p:transition xmlns:p14="http://schemas.microsoft.com/office/powerpoint/2010/main" spd="slow" p14:dur="2000">
         <p159:morph option="byObject"/>
       </p:transition>
     </mc:Choice>
-    <mc:Fallback>
+    <mc:Fallback xmlns="">
       <p:transition spd="slow">
         <p:fade/>
       </p:transition>
@@ -925,13 +925,13 @@
   <p:clrMapOvr>
     <a:masterClrMapping/>
   </p:clrMapOvr>
-  <mc:AlternateContent xmlns:mc="http://schemas.openxmlformats.org/markup-compatibility/2006">
-    <mc:Choice xmlns:p159="http://schemas.microsoft.com/office/powerpoint/2015/09/main" Requires="p159">
+  <mc:AlternateContent xmlns:mc="http://schemas.openxmlformats.org/markup-compatibility/2006" xmlns:p159="http://schemas.microsoft.com/office/powerpoint/2015/09/main">
+    <mc:Choice Requires="p159">
       <p:transition xmlns:p14="http://schemas.microsoft.com/office/powerpoint/2010/main" spd="slow" p14:dur="2000">
         <p159:morph option="byObject"/>
       </p:transition>
     </mc:Choice>
-    <mc:Fallback>
+    <mc:Fallback xmlns="">
       <p:transition spd="slow">
         <p:fade/>
       </p:transition>
@@ -1182,13 +1182,13 @@
   <p:clrMapOvr>
     <a:masterClrMapping/>
   </p:clrMapOvr>
-  <mc:AlternateContent xmlns:mc="http://schemas.openxmlformats.org/markup-compatibility/2006">
-    <mc:Choice xmlns:p159="http://schemas.microsoft.com/office/powerpoint/2015/09/main" Requires="p159">
+  <mc:AlternateContent xmlns:mc="http://schemas.openxmlformats.org/markup-compatibility/2006" xmlns:p159="http://schemas.microsoft.com/office/powerpoint/2015/09/main">
+    <mc:Choice Requires="p159">
       <p:transition xmlns:p14="http://schemas.microsoft.com/office/powerpoint/2010/main" spd="slow" p14:dur="2000">
         <p159:morph option="byObject"/>
       </p:transition>
     </mc:Choice>
-    <mc:Fallback>
+    <mc:Fallback xmlns="">
       <p:transition spd="slow">
         <p:fade/>
       </p:transition>
@@ -1479,13 +1479,13 @@
   <p:clrMapOvr>
     <a:masterClrMapping/>
   </p:clrMapOvr>
-  <mc:AlternateContent xmlns:mc="http://schemas.openxmlformats.org/markup-compatibility/2006">
-    <mc:Choice xmlns:p159="http://schemas.microsoft.com/office/powerpoint/2015/09/main" Requires="p159">
+  <mc:AlternateContent xmlns:mc="http://schemas.openxmlformats.org/markup-compatibility/2006" xmlns:p159="http://schemas.microsoft.com/office/powerpoint/2015/09/main">
+    <mc:Choice Requires="p159">
       <p:transition xmlns:p14="http://schemas.microsoft.com/office/powerpoint/2010/main" spd="slow" p14:dur="2000">
         <p159:morph option="byObject"/>
       </p:transition>
     </mc:Choice>
-    <mc:Fallback>
+    <mc:Fallback xmlns="">
       <p:transition spd="slow">
         <p:fade/>
       </p:transition>
@@ -1910,13 +1910,13 @@
   <p:clrMapOvr>
     <a:masterClrMapping/>
   </p:clrMapOvr>
-  <mc:AlternateContent xmlns:mc="http://schemas.openxmlformats.org/markup-compatibility/2006">
-    <mc:Choice xmlns:p159="http://schemas.microsoft.com/office/powerpoint/2015/09/main" Requires="p159">
+  <mc:AlternateContent xmlns:mc="http://schemas.openxmlformats.org/markup-compatibility/2006" xmlns:p159="http://schemas.microsoft.com/office/powerpoint/2015/09/main">
+    <mc:Choice Requires="p159">
       <p:transition xmlns:p14="http://schemas.microsoft.com/office/powerpoint/2010/main" spd="slow" p14:dur="2000">
         <p159:morph option="byObject"/>
       </p:transition>
     </mc:Choice>
-    <mc:Fallback>
+    <mc:Fallback xmlns="">
       <p:transition spd="slow">
         <p:fade/>
       </p:transition>
@@ -2039,13 +2039,13 @@
   <p:clrMapOvr>
     <a:masterClrMapping/>
   </p:clrMapOvr>
-  <mc:AlternateContent xmlns:mc="http://schemas.openxmlformats.org/markup-compatibility/2006">
-    <mc:Choice xmlns:p159="http://schemas.microsoft.com/office/powerpoint/2015/09/main" Requires="p159">
+  <mc:AlternateContent xmlns:mc="http://schemas.openxmlformats.org/markup-compatibility/2006" xmlns:p159="http://schemas.microsoft.com/office/powerpoint/2015/09/main">
+    <mc:Choice Requires="p159">
       <p:transition xmlns:p14="http://schemas.microsoft.com/office/powerpoint/2010/main" spd="slow" p14:dur="2000">
         <p159:morph option="byObject"/>
       </p:transition>
     </mc:Choice>
-    <mc:Fallback>
+    <mc:Fallback xmlns="">
       <p:transition spd="slow">
         <p:fade/>
       </p:transition>
@@ -2146,13 +2146,13 @@
   <p:clrMapOvr>
     <a:masterClrMapping/>
   </p:clrMapOvr>
-  <mc:AlternateContent xmlns:mc="http://schemas.openxmlformats.org/markup-compatibility/2006">
-    <mc:Choice xmlns:p159="http://schemas.microsoft.com/office/powerpoint/2015/09/main" Requires="p159">
+  <mc:AlternateContent xmlns:mc="http://schemas.openxmlformats.org/markup-compatibility/2006" xmlns:p159="http://schemas.microsoft.com/office/powerpoint/2015/09/main">
+    <mc:Choice Requires="p159">
       <p:transition xmlns:p14="http://schemas.microsoft.com/office/powerpoint/2010/main" spd="slow" p14:dur="2000">
         <p159:morph option="byObject"/>
       </p:transition>
     </mc:Choice>
-    <mc:Fallback>
+    <mc:Fallback xmlns="">
       <p:transition spd="slow">
         <p:fade/>
       </p:transition>
@@ -2433,13 +2433,13 @@
   <p:clrMapOvr>
     <a:masterClrMapping/>
   </p:clrMapOvr>
-  <mc:AlternateContent xmlns:mc="http://schemas.openxmlformats.org/markup-compatibility/2006">
-    <mc:Choice xmlns:p159="http://schemas.microsoft.com/office/powerpoint/2015/09/main" Requires="p159">
+  <mc:AlternateContent xmlns:mc="http://schemas.openxmlformats.org/markup-compatibility/2006" xmlns:p159="http://schemas.microsoft.com/office/powerpoint/2015/09/main">
+    <mc:Choice Requires="p159">
       <p:transition xmlns:p14="http://schemas.microsoft.com/office/powerpoint/2010/main" spd="slow" p14:dur="2000">
         <p159:morph option="byObject"/>
       </p:transition>
     </mc:Choice>
-    <mc:Fallback>
+    <mc:Fallback xmlns="">
       <p:transition spd="slow">
         <p:fade/>
       </p:transition>
@@ -2697,13 +2697,13 @@
   <p:clrMapOvr>
     <a:masterClrMapping/>
   </p:clrMapOvr>
-  <mc:AlternateContent xmlns:mc="http://schemas.openxmlformats.org/markup-compatibility/2006">
-    <mc:Choice xmlns:p159="http://schemas.microsoft.com/office/powerpoint/2015/09/main" Requires="p159">
+  <mc:AlternateContent xmlns:mc="http://schemas.openxmlformats.org/markup-compatibility/2006" xmlns:p159="http://schemas.microsoft.com/office/powerpoint/2015/09/main">
+    <mc:Choice Requires="p159">
       <p:transition xmlns:p14="http://schemas.microsoft.com/office/powerpoint/2010/main" spd="slow" p14:dur="2000">
         <p159:morph option="byObject"/>
       </p:transition>
     </mc:Choice>
-    <mc:Fallback>
+    <mc:Fallback xmlns="">
       <p:transition spd="slow">
         <p:fade/>
       </p:transition>
@@ -2967,13 +2967,13 @@
     <p:sldLayoutId id="2147483658" r:id="rId10"/>
     <p:sldLayoutId id="2147483659" r:id="rId11"/>
   </p:sldLayoutIdLst>
-  <mc:AlternateContent xmlns:mc="http://schemas.openxmlformats.org/markup-compatibility/2006">
-    <mc:Choice xmlns:p159="http://schemas.microsoft.com/office/powerpoint/2015/09/main" Requires="p159">
+  <mc:AlternateContent xmlns:mc="http://schemas.openxmlformats.org/markup-compatibility/2006" xmlns:p159="http://schemas.microsoft.com/office/powerpoint/2015/09/main">
+    <mc:Choice Requires="p159">
       <p:transition xmlns:p14="http://schemas.microsoft.com/office/powerpoint/2010/main" spd="slow" p14:dur="2000">
         <p159:morph option="byObject"/>
       </p:transition>
     </mc:Choice>
-    <mc:Fallback>
+    <mc:Fallback xmlns="">
       <p:transition spd="slow">
         <p:fade/>
       </p:transition>
@@ -3518,13 +3518,13 @@
   <p:clrMapOvr>
     <a:masterClrMapping/>
   </p:clrMapOvr>
-  <mc:AlternateContent xmlns:mc="http://schemas.openxmlformats.org/markup-compatibility/2006">
-    <mc:Choice xmlns:p159="http://schemas.microsoft.com/office/powerpoint/2015/09/main" Requires="p159">
+  <mc:AlternateContent xmlns:mc="http://schemas.openxmlformats.org/markup-compatibility/2006" xmlns:p159="http://schemas.microsoft.com/office/powerpoint/2015/09/main">
+    <mc:Choice Requires="p159">
       <p:transition xmlns:p14="http://schemas.microsoft.com/office/powerpoint/2010/main" spd="slow" p14:dur="2000">
         <p159:morph option="byObject"/>
       </p:transition>
     </mc:Choice>
-    <mc:Fallback>
+    <mc:Fallback xmlns="">
       <p:transition spd="slow">
         <p:fade/>
       </p:transition>
@@ -3816,13 +3816,13 @@
   <p:clrMapOvr>
     <a:masterClrMapping/>
   </p:clrMapOvr>
-  <mc:AlternateContent xmlns:mc="http://schemas.openxmlformats.org/markup-compatibility/2006">
-    <mc:Choice xmlns:p159="http://schemas.microsoft.com/office/powerpoint/2015/09/main" Requires="p159">
+  <mc:AlternateContent xmlns:mc="http://schemas.openxmlformats.org/markup-compatibility/2006" xmlns:p159="http://schemas.microsoft.com/office/powerpoint/2015/09/main">
+    <mc:Choice Requires="p159">
       <p:transition xmlns:p14="http://schemas.microsoft.com/office/powerpoint/2010/main" spd="slow" p14:dur="2000">
         <p159:morph option="byObject"/>
       </p:transition>
     </mc:Choice>
-    <mc:Fallback>
+    <mc:Fallback xmlns="">
       <p:transition spd="slow">
         <p:fade/>
       </p:transition>
@@ -4544,13 +4544,13 @@
   <p:clrMapOvr>
     <a:masterClrMapping/>
   </p:clrMapOvr>
-  <mc:AlternateContent xmlns:mc="http://schemas.openxmlformats.org/markup-compatibility/2006">
-    <mc:Choice xmlns:p159="http://schemas.microsoft.com/office/powerpoint/2015/09/main" Requires="p159">
+  <mc:AlternateContent xmlns:mc="http://schemas.openxmlformats.org/markup-compatibility/2006" xmlns:p159="http://schemas.microsoft.com/office/powerpoint/2015/09/main">
+    <mc:Choice Requires="p159">
       <p:transition xmlns:p14="http://schemas.microsoft.com/office/powerpoint/2010/main" spd="slow" p14:dur="2000">
         <p159:morph option="byObject"/>
       </p:transition>
     </mc:Choice>
-    <mc:Fallback>
+    <mc:Fallback xmlns="">
       <p:transition spd="slow">
         <p:fade/>
       </p:transition>
@@ -4800,13 +4800,13 @@
   <p:clrMapOvr>
     <a:masterClrMapping/>
   </p:clrMapOvr>
-  <mc:AlternateContent xmlns:mc="http://schemas.openxmlformats.org/markup-compatibility/2006">
-    <mc:Choice xmlns:p159="http://schemas.microsoft.com/office/powerpoint/2015/09/main" Requires="p159">
+  <mc:AlternateContent xmlns:mc="http://schemas.openxmlformats.org/markup-compatibility/2006" xmlns:p159="http://schemas.microsoft.com/office/powerpoint/2015/09/main">
+    <mc:Choice Requires="p159">
       <p:transition xmlns:p14="http://schemas.microsoft.com/office/powerpoint/2010/main" spd="slow" p14:dur="2000">
         <p159:morph option="byObject"/>
       </p:transition>
     </mc:Choice>
-    <mc:Fallback>
+    <mc:Fallback xmlns="">
       <p:transition spd="slow">
         <p:fade/>
       </p:transition>
@@ -5113,13 +5113,13 @@
   <p:clrMapOvr>
     <a:masterClrMapping/>
   </p:clrMapOvr>
-  <mc:AlternateContent xmlns:mc="http://schemas.openxmlformats.org/markup-compatibility/2006">
-    <mc:Choice xmlns:p159="http://schemas.microsoft.com/office/powerpoint/2015/09/main" Requires="p159">
+  <mc:AlternateContent xmlns:mc="http://schemas.openxmlformats.org/markup-compatibility/2006" xmlns:p159="http://schemas.microsoft.com/office/powerpoint/2015/09/main">
+    <mc:Choice Requires="p159">
       <p:transition xmlns:p14="http://schemas.microsoft.com/office/powerpoint/2010/main" spd="slow" p14:dur="2000">
         <p159:morph option="byObject"/>
       </p:transition>
     </mc:Choice>
-    <mc:Fallback>
+    <mc:Fallback xmlns="">
       <p:transition spd="slow">
         <p:fade/>
       </p:transition>
@@ -5408,13 +5408,13 @@
   <p:clrMapOvr>
     <a:masterClrMapping/>
   </p:clrMapOvr>
-  <mc:AlternateContent xmlns:mc="http://schemas.openxmlformats.org/markup-compatibility/2006">
-    <mc:Choice xmlns:p159="http://schemas.microsoft.com/office/powerpoint/2015/09/main" Requires="p159">
+  <mc:AlternateContent xmlns:mc="http://schemas.openxmlformats.org/markup-compatibility/2006" xmlns:p159="http://schemas.microsoft.com/office/powerpoint/2015/09/main">
+    <mc:Choice Requires="p159">
       <p:transition xmlns:p14="http://schemas.microsoft.com/office/powerpoint/2010/main" spd="slow" p14:dur="2000">
         <p159:morph option="byObject"/>
       </p:transition>
     </mc:Choice>
-    <mc:Fallback>
+    <mc:Fallback xmlns="">
       <p:transition spd="slow">
         <p:fade/>
       </p:transition>
@@ -5781,13 +5781,13 @@
   <p:clrMapOvr>
     <a:masterClrMapping/>
   </p:clrMapOvr>
-  <mc:AlternateContent xmlns:mc="http://schemas.openxmlformats.org/markup-compatibility/2006">
-    <mc:Choice xmlns:p159="http://schemas.microsoft.com/office/powerpoint/2015/09/main" Requires="p159">
+  <mc:AlternateContent xmlns:mc="http://schemas.openxmlformats.org/markup-compatibility/2006" xmlns:p159="http://schemas.microsoft.com/office/powerpoint/2015/09/main">
+    <mc:Choice Requires="p159">
       <p:transition xmlns:p14="http://schemas.microsoft.com/office/powerpoint/2010/main" spd="slow" p14:dur="2000">
         <p159:morph option="byObject"/>
       </p:transition>
     </mc:Choice>
-    <mc:Fallback>
+    <mc:Fallback xmlns="">
       <p:transition spd="slow">
         <p:fade/>
       </p:transition>
@@ -5968,13 +5968,13 @@
   <p:clrMapOvr>
     <a:masterClrMapping/>
   </p:clrMapOvr>
-  <mc:AlternateContent xmlns:mc="http://schemas.openxmlformats.org/markup-compatibility/2006">
-    <mc:Choice xmlns:p159="http://schemas.microsoft.com/office/powerpoint/2015/09/main" Requires="p159">
+  <mc:AlternateContent xmlns:mc="http://schemas.openxmlformats.org/markup-compatibility/2006" xmlns:p159="http://schemas.microsoft.com/office/powerpoint/2015/09/main">
+    <mc:Choice Requires="p159">
       <p:transition xmlns:p14="http://schemas.microsoft.com/office/powerpoint/2010/main" spd="slow" p14:dur="2000">
         <p159:morph option="byObject"/>
       </p:transition>
     </mc:Choice>
-    <mc:Fallback>
+    <mc:Fallback xmlns="">
       <p:transition spd="slow">
         <p:fade/>
       </p:transition>
@@ -6244,13 +6244,13 @@
   <p:clrMapOvr>
     <a:masterClrMapping/>
   </p:clrMapOvr>
-  <mc:AlternateContent xmlns:mc="http://schemas.openxmlformats.org/markup-compatibility/2006">
-    <mc:Choice xmlns:p159="http://schemas.microsoft.com/office/powerpoint/2015/09/main" Requires="p159">
+  <mc:AlternateContent xmlns:mc="http://schemas.openxmlformats.org/markup-compatibility/2006" xmlns:p159="http://schemas.microsoft.com/office/powerpoint/2015/09/main">
+    <mc:Choice Requires="p159">
       <p:transition xmlns:p14="http://schemas.microsoft.com/office/powerpoint/2010/main" spd="slow" p14:dur="2000">
         <p159:morph option="byObject"/>
       </p:transition>
     </mc:Choice>
-    <mc:Fallback>
+    <mc:Fallback xmlns="">
       <p:transition spd="slow">
         <p:fade/>
       </p:transition>
@@ -6457,7 +6457,7 @@
               <a:buChar char="•"/>
             </a:pPr>
             <a:r>
-              <a:rPr sz="2800" dirty="0">
+              <a:rPr sz="3200" dirty="0">
                 <a:solidFill>
                   <a:srgbClr val="000000"/>
                 </a:solidFill>
@@ -6472,7 +6472,7 @@
               <a:buChar char="•"/>
             </a:pPr>
             <a:r>
-              <a:rPr sz="2800" dirty="0">
+              <a:rPr sz="3200" dirty="0">
                 <a:solidFill>
                   <a:srgbClr val="000000"/>
                 </a:solidFill>
@@ -6487,7 +6487,7 @@
               <a:buChar char="•"/>
             </a:pPr>
             <a:r>
-              <a:rPr sz="2800" dirty="0" err="1">
+              <a:rPr sz="3200" dirty="0" err="1">
                 <a:solidFill>
                   <a:srgbClr val="000000"/>
                 </a:solidFill>
@@ -6496,7 +6496,7 @@
               <a:t>SynCura</a:t>
             </a:r>
             <a:r>
-              <a:rPr sz="2800" dirty="0">
+              <a:rPr sz="3200" dirty="0">
                 <a:solidFill>
                   <a:srgbClr val="000000"/>
                 </a:solidFill>
@@ -6511,7 +6511,7 @@
               <a:buChar char="•"/>
             </a:pPr>
             <a:r>
-              <a:rPr sz="2800" dirty="0">
+              <a:rPr sz="3200" dirty="0">
                 <a:solidFill>
                   <a:srgbClr val="000000"/>
                 </a:solidFill>
@@ -6520,7 +6520,7 @@
               <a:t>The project focuses on an explainable software prototype, not autonomous clinical decision-making.</a:t>
             </a:r>
             <a:r>
-              <a:rPr lang="en-IN" sz="2800" dirty="0">
+              <a:rPr lang="en-IN" sz="3200" dirty="0">
                 <a:solidFill>
                   <a:srgbClr val="000000"/>
                 </a:solidFill>
@@ -6528,7 +6528,7 @@
               </a:rPr>
               <a:t>	1</a:t>
             </a:r>
-            <a:endParaRPr sz="2800" dirty="0">
+            <a:endParaRPr sz="3200" dirty="0">
               <a:solidFill>
                 <a:srgbClr val="000000"/>
               </a:solidFill>
@@ -6542,13 +6542,13 @@
   <p:clrMapOvr>
     <a:masterClrMapping/>
   </p:clrMapOvr>
-  <mc:AlternateContent xmlns:mc="http://schemas.openxmlformats.org/markup-compatibility/2006">
-    <mc:Choice xmlns:p159="http://schemas.microsoft.com/office/powerpoint/2015/09/main" Requires="p159">
+  <mc:AlternateContent xmlns:mc="http://schemas.openxmlformats.org/markup-compatibility/2006" xmlns:p159="http://schemas.microsoft.com/office/powerpoint/2015/09/main">
+    <mc:Choice Requires="p159">
       <p:transition xmlns:p14="http://schemas.microsoft.com/office/powerpoint/2010/main" spd="slow" p14:dur="2000">
         <p159:morph option="byObject"/>
       </p:transition>
     </mc:Choice>
-    <mc:Fallback>
+    <mc:Fallback xmlns="">
       <p:transition spd="slow">
         <p:fade/>
       </p:transition>
@@ -6755,31 +6755,31 @@
               <a:buChar char="•"/>
             </a:pPr>
             <a:r>
-              <a:rPr sz="2400" dirty="0">
+              <a:rPr sz="2800" dirty="0">
                 <a:latin typeface="Calibri"/>
               </a:rPr>
               <a:t>Base paper: Zheng et al. (2025) - Temporal-Branch Attention LSTM (TBAL), MIMIC-IV + </a:t>
             </a:r>
             <a:r>
-              <a:rPr sz="2400" dirty="0" err="1">
+              <a:rPr sz="2800" dirty="0" err="1">
                 <a:latin typeface="Calibri"/>
               </a:rPr>
               <a:t>eICU</a:t>
             </a:r>
             <a:r>
-              <a:rPr sz="2400" dirty="0">
+              <a:rPr sz="2800" dirty="0">
                 <a:latin typeface="Calibri"/>
               </a:rPr>
               <a:t>, dynamic AUROC ~0.936. </a:t>
             </a:r>
             <a:r>
-              <a:rPr sz="2400" dirty="0" err="1">
+              <a:rPr sz="2800" dirty="0" err="1">
                 <a:latin typeface="Calibri"/>
               </a:rPr>
               <a:t>SynCura</a:t>
             </a:r>
             <a:r>
-              <a:rPr sz="2400" dirty="0">
+              <a:rPr sz="2800" dirty="0">
                 <a:latin typeface="Calibri"/>
               </a:rPr>
               <a:t> adapts TBAL to PhysioNet 2012.</a:t>
@@ -6791,19 +6791,19 @@
               <a:buChar char="o"/>
             </a:pPr>
             <a:r>
-              <a:rPr sz="2400" dirty="0">
+              <a:rPr sz="2800" dirty="0">
                 <a:latin typeface="Calibri"/>
               </a:rPr>
               <a:t>Support 1: Yan et al. (2026) - single LSTM, multi-</a:t>
             </a:r>
             <a:r>
-              <a:rPr sz="2400" dirty="0" err="1">
+              <a:rPr sz="2800" dirty="0" err="1">
                 <a:latin typeface="Calibri"/>
               </a:rPr>
               <a:t>centre</a:t>
             </a:r>
             <a:r>
-              <a:rPr sz="2400" dirty="0">
+              <a:rPr sz="2800" dirty="0">
                 <a:latin typeface="Calibri"/>
               </a:rPr>
               <a:t> ICU, AUC 0.802.</a:t>
@@ -6815,31 +6815,31 @@
               <a:buChar char="o"/>
             </a:pPr>
             <a:r>
-              <a:rPr sz="2400" dirty="0">
+              <a:rPr sz="2800" dirty="0">
                 <a:latin typeface="Calibri"/>
               </a:rPr>
               <a:t>Support 2: </a:t>
             </a:r>
             <a:r>
-              <a:rPr sz="2400" dirty="0" err="1">
+              <a:rPr sz="2800" dirty="0" err="1">
                 <a:latin typeface="Calibri"/>
               </a:rPr>
               <a:t>Sadanandan</a:t>
             </a:r>
             <a:r>
-              <a:rPr sz="2400" dirty="0">
+              <a:rPr sz="2800" dirty="0">
                 <a:latin typeface="Calibri"/>
               </a:rPr>
               <a:t> (2026) - multimodal LSTM + </a:t>
             </a:r>
             <a:r>
-              <a:rPr sz="2400" dirty="0" err="1">
+              <a:rPr sz="2800" dirty="0" err="1">
                 <a:latin typeface="Calibri"/>
               </a:rPr>
               <a:t>ClinicalBERT</a:t>
             </a:r>
             <a:r>
-              <a:rPr sz="2400" dirty="0">
+              <a:rPr sz="2800" dirty="0">
                 <a:latin typeface="Calibri"/>
               </a:rPr>
               <a:t>, AUROC 0.786.</a:t>
@@ -6851,7 +6851,7 @@
               <a:buChar char="o"/>
             </a:pPr>
             <a:r>
-              <a:rPr sz="2400" dirty="0">
+              <a:rPr sz="2800" dirty="0">
                 <a:latin typeface="Calibri"/>
               </a:rPr>
               <a:t>Support 3: Wu et al. (2024) - vital-signs-only LSTM, AUC 0.926.</a:t>
@@ -6863,19 +6863,19 @@
               <a:buChar char="o"/>
             </a:pPr>
             <a:r>
-              <a:rPr sz="2400" dirty="0">
+              <a:rPr sz="2800" dirty="0">
                 <a:latin typeface="Calibri"/>
               </a:rPr>
               <a:t>Support 4: Xie et al. (2025) - </a:t>
             </a:r>
             <a:r>
-              <a:rPr sz="2400" dirty="0" err="1">
+              <a:rPr sz="2800" dirty="0" err="1">
                 <a:latin typeface="Calibri"/>
               </a:rPr>
               <a:t>RealMIP</a:t>
             </a:r>
             <a:r>
-              <a:rPr sz="2400" dirty="0">
+              <a:rPr sz="2800" dirty="0">
                 <a:latin typeface="Calibri"/>
               </a:rPr>
               <a:t> missing-data recovery, AUC 0.957-0.968.</a:t>
@@ -6887,19 +6887,19 @@
               <a:buChar char="o"/>
             </a:pPr>
             <a:r>
-              <a:rPr sz="2400" dirty="0">
+              <a:rPr sz="2800" dirty="0">
                 <a:latin typeface="Calibri"/>
               </a:rPr>
               <a:t>Support 5: Choi et al. (2020) - interpretable </a:t>
             </a:r>
             <a:r>
-              <a:rPr sz="2400" dirty="0" err="1">
+              <a:rPr sz="2800" dirty="0" err="1">
                 <a:latin typeface="Calibri"/>
               </a:rPr>
               <a:t>BiLSTM</a:t>
             </a:r>
             <a:r>
-              <a:rPr sz="2400" dirty="0">
+              <a:rPr sz="2800" dirty="0">
                 <a:latin typeface="Calibri"/>
               </a:rPr>
               <a:t> early-warning, AUROC ~0.880.</a:t>
@@ -6911,7 +6911,7 @@
               <a:buChar char="o"/>
             </a:pPr>
             <a:r>
-              <a:rPr sz="2400" dirty="0">
+              <a:rPr sz="2800" dirty="0">
                 <a:latin typeface="Calibri"/>
               </a:rPr>
               <a:t>Support 6: Scheid et al. (2025) - continuous wearable deep learning, AUROC ~0.890.</a:t>
@@ -6923,7 +6923,7 @@
               <a:buChar char="o"/>
             </a:pPr>
             <a:r>
-              <a:rPr sz="2400" dirty="0">
+              <a:rPr sz="2800" dirty="0">
                 <a:latin typeface="Calibri"/>
               </a:rPr>
               <a:t>Support 7: Wang, Bai &amp; Jin (2026) - explainable LSTM, AUC 0.79-0.87.</a:t>
@@ -6935,7 +6935,7 @@
               <a:buChar char="o"/>
             </a:pPr>
             <a:r>
-              <a:rPr sz="2400" dirty="0">
+              <a:rPr sz="2800" dirty="0">
                 <a:latin typeface="Calibri"/>
               </a:rPr>
               <a:t>Gap: models report single AUC only; few validate on unseen patients; none ship a real-time explainable risk path.</a:t>
@@ -6948,13 +6948,13 @@
   <p:clrMapOvr>
     <a:masterClrMapping/>
   </p:clrMapOvr>
-  <mc:AlternateContent xmlns:mc="http://schemas.openxmlformats.org/markup-compatibility/2006">
-    <mc:Choice xmlns:p159="http://schemas.microsoft.com/office/powerpoint/2015/09/main" Requires="p159">
+  <mc:AlternateContent xmlns:mc="http://schemas.openxmlformats.org/markup-compatibility/2006" xmlns:p159="http://schemas.microsoft.com/office/powerpoint/2015/09/main">
+    <mc:Choice Requires="p159">
       <p:transition xmlns:p14="http://schemas.microsoft.com/office/powerpoint/2010/main" spd="slow" p14:dur="2000">
         <p159:morph option="byObject"/>
       </p:transition>
     </mc:Choice>
-    <mc:Fallback>
+    <mc:Fallback xmlns="">
       <p:transition spd="slow">
         <p:fade/>
       </p:transition>
@@ -7249,13 +7249,13 @@
   <p:clrMapOvr>
     <a:masterClrMapping/>
   </p:clrMapOvr>
-  <mc:AlternateContent xmlns:mc="http://schemas.openxmlformats.org/markup-compatibility/2006">
-    <mc:Choice xmlns:p159="http://schemas.microsoft.com/office/powerpoint/2015/09/main" Requires="p159">
+  <mc:AlternateContent xmlns:mc="http://schemas.openxmlformats.org/markup-compatibility/2006" xmlns:p159="http://schemas.microsoft.com/office/powerpoint/2015/09/main">
+    <mc:Choice Requires="p159">
       <p:transition xmlns:p14="http://schemas.microsoft.com/office/powerpoint/2010/main" spd="slow" p14:dur="2000">
         <p159:morph option="byObject"/>
       </p:transition>
     </mc:Choice>
-    <mc:Fallback>
+    <mc:Fallback xmlns="">
       <p:transition spd="slow">
         <p:fade/>
       </p:transition>
@@ -7571,13 +7571,13 @@
   <p:clrMapOvr>
     <a:masterClrMapping/>
   </p:clrMapOvr>
-  <mc:AlternateContent xmlns:mc="http://schemas.openxmlformats.org/markup-compatibility/2006">
-    <mc:Choice xmlns:p159="http://schemas.microsoft.com/office/powerpoint/2015/09/main" Requires="p159">
+  <mc:AlternateContent xmlns:mc="http://schemas.openxmlformats.org/markup-compatibility/2006" xmlns:p159="http://schemas.microsoft.com/office/powerpoint/2015/09/main">
+    <mc:Choice Requires="p159">
       <p:transition xmlns:p14="http://schemas.microsoft.com/office/powerpoint/2010/main" spd="slow" p14:dur="2000">
         <p159:morph option="byObject"/>
       </p:transition>
     </mc:Choice>
-    <mc:Fallback>
+    <mc:Fallback xmlns="">
       <p:transition spd="slow">
         <p:fade/>
       </p:transition>
@@ -8324,13 +8324,13 @@
   <p:clrMapOvr>
     <a:masterClrMapping/>
   </p:clrMapOvr>
-  <mc:AlternateContent xmlns:mc="http://schemas.openxmlformats.org/markup-compatibility/2006">
-    <mc:Choice xmlns:p159="http://schemas.microsoft.com/office/powerpoint/2015/09/main" Requires="p159">
+  <mc:AlternateContent xmlns:mc="http://schemas.openxmlformats.org/markup-compatibility/2006" xmlns:p159="http://schemas.microsoft.com/office/powerpoint/2015/09/main">
+    <mc:Choice Requires="p159">
       <p:transition xmlns:p14="http://schemas.microsoft.com/office/powerpoint/2010/main" spd="slow" p14:dur="2000">
         <p159:morph option="byObject"/>
       </p:transition>
     </mc:Choice>
-    <mc:Fallback>
+    <mc:Fallback xmlns="">
       <p:transition spd="slow">
         <p:fade/>
       </p:transition>
@@ -8621,13 +8621,13 @@
   <p:clrMapOvr>
     <a:masterClrMapping/>
   </p:clrMapOvr>
-  <mc:AlternateContent xmlns:mc="http://schemas.openxmlformats.org/markup-compatibility/2006">
-    <mc:Choice xmlns:p159="http://schemas.microsoft.com/office/powerpoint/2015/09/main" Requires="p159">
+  <mc:AlternateContent xmlns:mc="http://schemas.openxmlformats.org/markup-compatibility/2006" xmlns:p159="http://schemas.microsoft.com/office/powerpoint/2015/09/main">
+    <mc:Choice Requires="p159">
       <p:transition xmlns:p14="http://schemas.microsoft.com/office/powerpoint/2010/main" spd="slow" p14:dur="2000">
         <p159:morph option="byObject"/>
       </p:transition>
     </mc:Choice>
-    <mc:Fallback>
+    <mc:Fallback xmlns="">
       <p:transition spd="slow">
         <p:fade/>
       </p:transition>
@@ -8933,13 +8933,13 @@
   <p:clrMapOvr>
     <a:masterClrMapping/>
   </p:clrMapOvr>
-  <mc:AlternateContent xmlns:mc="http://schemas.openxmlformats.org/markup-compatibility/2006">
-    <mc:Choice xmlns:p159="http://schemas.microsoft.com/office/powerpoint/2015/09/main" Requires="p159">
+  <mc:AlternateContent xmlns:mc="http://schemas.openxmlformats.org/markup-compatibility/2006" xmlns:p159="http://schemas.microsoft.com/office/powerpoint/2015/09/main">
+    <mc:Choice Requires="p159">
       <p:transition xmlns:p14="http://schemas.microsoft.com/office/powerpoint/2010/main" spd="slow" p14:dur="2000">
         <p159:morph option="byObject"/>
       </p:transition>
     </mc:Choice>
-    <mc:Fallback>
+    <mc:Fallback xmlns="">
       <p:transition spd="slow">
         <p:fade/>
       </p:transition>

</xml_diff>